<commit_message>
Update docs from source repo: f6a7493f20870dd204f03d5c2b1f653ce0b61602
</commit_message>
<xml_diff>
--- a/docs/image/図の編集.pptx
+++ b/docs/image/図の編集.pptx
@@ -8,6 +8,8 @@
     <p:sldId id="256" r:id="rId2"/>
     <p:sldId id="257" r:id="rId3"/>
     <p:sldId id="258" r:id="rId4"/>
+    <p:sldId id="259" r:id="rId5"/>
+    <p:sldId id="260" r:id="rId6"/>
   </p:sldIdLst>
   <p:sldSz cx="12192000" cy="6858000"/>
   <p:notesSz cx="6858000" cy="9144000"/>
@@ -106,6 +108,11 @@
       </a:defRPr>
     </a:lvl9pPr>
   </p:defaultTextStyle>
+  <p:extLst>
+    <p:ext uri="{EFAFB233-063F-42B5-8137-9DF3F51BA10A}">
+      <p15:sldGuideLst xmlns:p15="http://schemas.microsoft.com/office/powerpoint/2012/main"/>
+    </p:ext>
+  </p:extLst>
 </p:presentation>
 </file>
 
@@ -256,7 +263,7 @@
           <a:p>
             <a:fld id="{E95EF2F7-7090-4231-B7EF-7F1B5A5EFE03}" type="datetimeFigureOut">
               <a:rPr kumimoji="1" lang="ja-JP" altLang="en-US" smtClean="0"/>
-              <a:t>2026/4/23</a:t>
+              <a:t>2026/4/24</a:t>
             </a:fld>
             <a:endParaRPr kumimoji="1" lang="ja-JP" altLang="en-US"/>
           </a:p>
@@ -486,7 +493,7 @@
           <a:p>
             <a:fld id="{E95EF2F7-7090-4231-B7EF-7F1B5A5EFE03}" type="datetimeFigureOut">
               <a:rPr kumimoji="1" lang="ja-JP" altLang="en-US" smtClean="0"/>
-              <a:t>2026/4/23</a:t>
+              <a:t>2026/4/24</a:t>
             </a:fld>
             <a:endParaRPr kumimoji="1" lang="ja-JP" altLang="en-US"/>
           </a:p>
@@ -726,7 +733,7 @@
           <a:p>
             <a:fld id="{E95EF2F7-7090-4231-B7EF-7F1B5A5EFE03}" type="datetimeFigureOut">
               <a:rPr kumimoji="1" lang="ja-JP" altLang="en-US" smtClean="0"/>
-              <a:t>2026/4/23</a:t>
+              <a:t>2026/4/24</a:t>
             </a:fld>
             <a:endParaRPr kumimoji="1" lang="ja-JP" altLang="en-US"/>
           </a:p>
@@ -956,7 +963,7 @@
           <a:p>
             <a:fld id="{E95EF2F7-7090-4231-B7EF-7F1B5A5EFE03}" type="datetimeFigureOut">
               <a:rPr kumimoji="1" lang="ja-JP" altLang="en-US" smtClean="0"/>
-              <a:t>2026/4/23</a:t>
+              <a:t>2026/4/24</a:t>
             </a:fld>
             <a:endParaRPr kumimoji="1" lang="ja-JP" altLang="en-US"/>
           </a:p>
@@ -1231,7 +1238,7 @@
           <a:p>
             <a:fld id="{E95EF2F7-7090-4231-B7EF-7F1B5A5EFE03}" type="datetimeFigureOut">
               <a:rPr kumimoji="1" lang="ja-JP" altLang="en-US" smtClean="0"/>
-              <a:t>2026/4/23</a:t>
+              <a:t>2026/4/24</a:t>
             </a:fld>
             <a:endParaRPr kumimoji="1" lang="ja-JP" altLang="en-US"/>
           </a:p>
@@ -1560,7 +1567,7 @@
           <a:p>
             <a:fld id="{E95EF2F7-7090-4231-B7EF-7F1B5A5EFE03}" type="datetimeFigureOut">
               <a:rPr kumimoji="1" lang="ja-JP" altLang="en-US" smtClean="0"/>
-              <a:t>2026/4/23</a:t>
+              <a:t>2026/4/24</a:t>
             </a:fld>
             <a:endParaRPr kumimoji="1" lang="ja-JP" altLang="en-US"/>
           </a:p>
@@ -2036,7 +2043,7 @@
           <a:p>
             <a:fld id="{E95EF2F7-7090-4231-B7EF-7F1B5A5EFE03}" type="datetimeFigureOut">
               <a:rPr kumimoji="1" lang="ja-JP" altLang="en-US" smtClean="0"/>
-              <a:t>2026/4/23</a:t>
+              <a:t>2026/4/24</a:t>
             </a:fld>
             <a:endParaRPr kumimoji="1" lang="ja-JP" altLang="en-US"/>
           </a:p>
@@ -2177,7 +2184,7 @@
           <a:p>
             <a:fld id="{E95EF2F7-7090-4231-B7EF-7F1B5A5EFE03}" type="datetimeFigureOut">
               <a:rPr kumimoji="1" lang="ja-JP" altLang="en-US" smtClean="0"/>
-              <a:t>2026/4/23</a:t>
+              <a:t>2026/4/24</a:t>
             </a:fld>
             <a:endParaRPr kumimoji="1" lang="ja-JP" altLang="en-US"/>
           </a:p>
@@ -2290,7 +2297,7 @@
           <a:p>
             <a:fld id="{E95EF2F7-7090-4231-B7EF-7F1B5A5EFE03}" type="datetimeFigureOut">
               <a:rPr kumimoji="1" lang="ja-JP" altLang="en-US" smtClean="0"/>
-              <a:t>2026/4/23</a:t>
+              <a:t>2026/4/24</a:t>
             </a:fld>
             <a:endParaRPr kumimoji="1" lang="ja-JP" altLang="en-US"/>
           </a:p>
@@ -2633,7 +2640,7 @@
           <a:p>
             <a:fld id="{E95EF2F7-7090-4231-B7EF-7F1B5A5EFE03}" type="datetimeFigureOut">
               <a:rPr kumimoji="1" lang="ja-JP" altLang="en-US" smtClean="0"/>
-              <a:t>2026/4/23</a:t>
+              <a:t>2026/4/24</a:t>
             </a:fld>
             <a:endParaRPr kumimoji="1" lang="ja-JP" altLang="en-US"/>
           </a:p>
@@ -2921,7 +2928,7 @@
           <a:p>
             <a:fld id="{E95EF2F7-7090-4231-B7EF-7F1B5A5EFE03}" type="datetimeFigureOut">
               <a:rPr kumimoji="1" lang="ja-JP" altLang="en-US" smtClean="0"/>
-              <a:t>2026/4/23</a:t>
+              <a:t>2026/4/24</a:t>
             </a:fld>
             <a:endParaRPr kumimoji="1" lang="ja-JP" altLang="en-US"/>
           </a:p>
@@ -3194,7 +3201,7 @@
           <a:p>
             <a:fld id="{E95EF2F7-7090-4231-B7EF-7F1B5A5EFE03}" type="datetimeFigureOut">
               <a:rPr kumimoji="1" lang="ja-JP" altLang="en-US" smtClean="0"/>
-              <a:t>2026/4/23</a:t>
+              <a:t>2026/4/24</a:t>
             </a:fld>
             <a:endParaRPr kumimoji="1" lang="ja-JP" altLang="en-US"/>
           </a:p>
@@ -4604,6 +4611,4027 @@
 </p:sld>
 </file>
 
+<file path=ppt/slides/slide4.xml><?xml version="1.0" encoding="utf-8"?>
+<p:sld xmlns:a="http://schemas.openxmlformats.org/drawingml/2006/main" xmlns:r="http://schemas.openxmlformats.org/officeDocument/2006/relationships" xmlns:p="http://schemas.openxmlformats.org/presentationml/2006/main">
+  <p:cSld>
+    <p:spTree>
+      <p:nvGrpSpPr>
+        <p:cNvPr id="1" name=""/>
+        <p:cNvGrpSpPr/>
+        <p:nvPr/>
+      </p:nvGrpSpPr>
+      <p:grpSpPr>
+        <a:xfrm>
+          <a:off x="0" y="0"/>
+          <a:ext cx="0" cy="0"/>
+          <a:chOff x="0" y="0"/>
+          <a:chExt cx="0" cy="0"/>
+        </a:xfrm>
+      </p:grpSpPr>
+      <p:grpSp>
+        <p:nvGrpSpPr>
+          <p:cNvPr id="21" name="グループ化 20">
+            <a:extLst>
+              <a:ext uri="{FF2B5EF4-FFF2-40B4-BE49-F238E27FC236}">
+                <a16:creationId xmlns:a16="http://schemas.microsoft.com/office/drawing/2014/main" id="{6B02DE35-A0B0-B1D0-83BA-00E31BD79AD6}"/>
+              </a:ext>
+            </a:extLst>
+          </p:cNvPr>
+          <p:cNvGrpSpPr/>
+          <p:nvPr/>
+        </p:nvGrpSpPr>
+        <p:grpSpPr>
+          <a:xfrm>
+            <a:off x="9768408" y="260648"/>
+            <a:ext cx="1987720" cy="1800200"/>
+            <a:chOff x="2783633" y="980728"/>
+            <a:chExt cx="3816423" cy="3456384"/>
+          </a:xfrm>
+        </p:grpSpPr>
+        <p:sp>
+          <p:nvSpPr>
+            <p:cNvPr id="22" name="楕円 21">
+              <a:extLst>
+                <a:ext uri="{FF2B5EF4-FFF2-40B4-BE49-F238E27FC236}">
+                  <a16:creationId xmlns:a16="http://schemas.microsoft.com/office/drawing/2014/main" id="{CE881C4B-4E5D-23FD-86F0-075C79D83C21}"/>
+                </a:ext>
+              </a:extLst>
+            </p:cNvPr>
+            <p:cNvSpPr/>
+            <p:nvPr/>
+          </p:nvSpPr>
+          <p:spPr>
+            <a:xfrm>
+              <a:off x="3215680" y="1268760"/>
+              <a:ext cx="2880000" cy="2880000"/>
+            </a:xfrm>
+            <a:prstGeom prst="ellipse">
+              <a:avLst/>
+            </a:prstGeom>
+            <a:noFill/>
+            <a:ln w="76200">
+              <a:solidFill>
+                <a:schemeClr val="accent1"/>
+              </a:solidFill>
+            </a:ln>
+          </p:spPr>
+          <p:style>
+            <a:lnRef idx="2">
+              <a:schemeClr val="accent1">
+                <a:shade val="15000"/>
+              </a:schemeClr>
+            </a:lnRef>
+            <a:fillRef idx="1">
+              <a:schemeClr val="accent1"/>
+            </a:fillRef>
+            <a:effectRef idx="0">
+              <a:schemeClr val="accent1"/>
+            </a:effectRef>
+            <a:fontRef idx="minor">
+              <a:schemeClr val="lt1"/>
+            </a:fontRef>
+          </p:style>
+          <p:txBody>
+            <a:bodyPr rtlCol="0" anchor="ctr"/>
+            <a:lstStyle/>
+            <a:p>
+              <a:pPr algn="ctr"/>
+              <a:endParaRPr kumimoji="1" lang="ja-JP" altLang="en-US"/>
+            </a:p>
+          </p:txBody>
+        </p:sp>
+        <p:sp>
+          <p:nvSpPr>
+            <p:cNvPr id="23" name="楕円 22">
+              <a:extLst>
+                <a:ext uri="{FF2B5EF4-FFF2-40B4-BE49-F238E27FC236}">
+                  <a16:creationId xmlns:a16="http://schemas.microsoft.com/office/drawing/2014/main" id="{A3CB064E-9DBF-66FA-1212-1F0A43C3813D}"/>
+                </a:ext>
+              </a:extLst>
+            </p:cNvPr>
+            <p:cNvSpPr/>
+            <p:nvPr/>
+          </p:nvSpPr>
+          <p:spPr>
+            <a:xfrm>
+              <a:off x="3791424" y="1268760"/>
+              <a:ext cx="1728512" cy="2880000"/>
+            </a:xfrm>
+            <a:prstGeom prst="ellipse">
+              <a:avLst/>
+            </a:prstGeom>
+            <a:noFill/>
+            <a:ln w="76200">
+              <a:solidFill>
+                <a:schemeClr val="accent1"/>
+              </a:solidFill>
+            </a:ln>
+          </p:spPr>
+          <p:style>
+            <a:lnRef idx="2">
+              <a:schemeClr val="accent1">
+                <a:shade val="15000"/>
+              </a:schemeClr>
+            </a:lnRef>
+            <a:fillRef idx="1">
+              <a:schemeClr val="accent1"/>
+            </a:fillRef>
+            <a:effectRef idx="0">
+              <a:schemeClr val="accent1"/>
+            </a:effectRef>
+            <a:fontRef idx="minor">
+              <a:schemeClr val="lt1"/>
+            </a:fontRef>
+          </p:style>
+          <p:txBody>
+            <a:bodyPr rtlCol="0" anchor="ctr"/>
+            <a:lstStyle/>
+            <a:p>
+              <a:pPr algn="ctr"/>
+              <a:endParaRPr kumimoji="1" lang="ja-JP" altLang="en-US"/>
+            </a:p>
+          </p:txBody>
+        </p:sp>
+        <p:cxnSp>
+          <p:nvCxnSpPr>
+            <p:cNvPr id="24" name="直線コネクタ 23">
+              <a:extLst>
+                <a:ext uri="{FF2B5EF4-FFF2-40B4-BE49-F238E27FC236}">
+                  <a16:creationId xmlns:a16="http://schemas.microsoft.com/office/drawing/2014/main" id="{A98F2A59-81E8-F866-068A-FBCEDE2F458E}"/>
+                </a:ext>
+              </a:extLst>
+            </p:cNvPr>
+            <p:cNvCxnSpPr>
+              <a:stCxn id="22" idx="2"/>
+              <a:endCxn id="22" idx="6"/>
+            </p:cNvCxnSpPr>
+            <p:nvPr/>
+          </p:nvCxnSpPr>
+          <p:spPr>
+            <a:xfrm>
+              <a:off x="3215680" y="2708760"/>
+              <a:ext cx="2880000" cy="0"/>
+            </a:xfrm>
+            <a:prstGeom prst="line">
+              <a:avLst/>
+            </a:prstGeom>
+            <a:ln w="76200"/>
+          </p:spPr>
+          <p:style>
+            <a:lnRef idx="1">
+              <a:schemeClr val="accent1"/>
+            </a:lnRef>
+            <a:fillRef idx="0">
+              <a:schemeClr val="accent1"/>
+            </a:fillRef>
+            <a:effectRef idx="0">
+              <a:schemeClr val="accent1"/>
+            </a:effectRef>
+            <a:fontRef idx="minor">
+              <a:schemeClr val="tx1"/>
+            </a:fontRef>
+          </p:style>
+        </p:cxnSp>
+        <p:cxnSp>
+          <p:nvCxnSpPr>
+            <p:cNvPr id="25" name="直線コネクタ 24">
+              <a:extLst>
+                <a:ext uri="{FF2B5EF4-FFF2-40B4-BE49-F238E27FC236}">
+                  <a16:creationId xmlns:a16="http://schemas.microsoft.com/office/drawing/2014/main" id="{0DB76BB2-7505-83B7-8979-6FE85C469355}"/>
+                </a:ext>
+              </a:extLst>
+            </p:cNvPr>
+            <p:cNvCxnSpPr>
+              <a:cxnSpLocks/>
+              <a:stCxn id="23" idx="0"/>
+              <a:endCxn id="23" idx="4"/>
+            </p:cNvCxnSpPr>
+            <p:nvPr/>
+          </p:nvCxnSpPr>
+          <p:spPr>
+            <a:xfrm>
+              <a:off x="4655680" y="1268760"/>
+              <a:ext cx="0" cy="2880000"/>
+            </a:xfrm>
+            <a:prstGeom prst="line">
+              <a:avLst/>
+            </a:prstGeom>
+            <a:ln w="76200"/>
+          </p:spPr>
+          <p:style>
+            <a:lnRef idx="1">
+              <a:schemeClr val="accent1"/>
+            </a:lnRef>
+            <a:fillRef idx="0">
+              <a:schemeClr val="accent1"/>
+            </a:fillRef>
+            <a:effectRef idx="0">
+              <a:schemeClr val="accent1"/>
+            </a:effectRef>
+            <a:fontRef idx="minor">
+              <a:schemeClr val="tx1"/>
+            </a:fontRef>
+          </p:style>
+        </p:cxnSp>
+        <p:sp>
+          <p:nvSpPr>
+            <p:cNvPr id="26" name="円弧 25">
+              <a:extLst>
+                <a:ext uri="{FF2B5EF4-FFF2-40B4-BE49-F238E27FC236}">
+                  <a16:creationId xmlns:a16="http://schemas.microsoft.com/office/drawing/2014/main" id="{24AD6524-B89B-60F6-F16A-E5D88DC18E76}"/>
+                </a:ext>
+              </a:extLst>
+            </p:cNvPr>
+            <p:cNvSpPr/>
+            <p:nvPr/>
+          </p:nvSpPr>
+          <p:spPr>
+            <a:xfrm flipV="1">
+              <a:off x="3287688" y="980728"/>
+              <a:ext cx="2736304" cy="1080120"/>
+            </a:xfrm>
+            <a:prstGeom prst="arc">
+              <a:avLst>
+                <a:gd name="adj1" fmla="val 11696102"/>
+                <a:gd name="adj2" fmla="val 20659846"/>
+              </a:avLst>
+            </a:prstGeom>
+            <a:ln w="76200"/>
+          </p:spPr>
+          <p:style>
+            <a:lnRef idx="1">
+              <a:schemeClr val="accent1"/>
+            </a:lnRef>
+            <a:fillRef idx="0">
+              <a:schemeClr val="accent1"/>
+            </a:fillRef>
+            <a:effectRef idx="0">
+              <a:schemeClr val="accent1"/>
+            </a:effectRef>
+            <a:fontRef idx="minor">
+              <a:schemeClr val="tx1"/>
+            </a:fontRef>
+          </p:style>
+          <p:txBody>
+            <a:bodyPr rtlCol="0" anchor="ctr"/>
+            <a:lstStyle/>
+            <a:p>
+              <a:pPr algn="ctr"/>
+              <a:endParaRPr kumimoji="1" lang="ja-JP" altLang="en-US"/>
+            </a:p>
+          </p:txBody>
+        </p:sp>
+        <p:sp>
+          <p:nvSpPr>
+            <p:cNvPr id="27" name="円弧 26">
+              <a:extLst>
+                <a:ext uri="{FF2B5EF4-FFF2-40B4-BE49-F238E27FC236}">
+                  <a16:creationId xmlns:a16="http://schemas.microsoft.com/office/drawing/2014/main" id="{333A4E9B-58AF-37EC-52AF-F24878F39D1C}"/>
+                </a:ext>
+              </a:extLst>
+            </p:cNvPr>
+            <p:cNvSpPr/>
+            <p:nvPr/>
+          </p:nvSpPr>
+          <p:spPr>
+            <a:xfrm rot="10800000" flipV="1">
+              <a:off x="3287688" y="3356992"/>
+              <a:ext cx="2736304" cy="1080120"/>
+            </a:xfrm>
+            <a:prstGeom prst="arc">
+              <a:avLst>
+                <a:gd name="adj1" fmla="val 11720544"/>
+                <a:gd name="adj2" fmla="val 20759633"/>
+              </a:avLst>
+            </a:prstGeom>
+            <a:ln w="76200"/>
+          </p:spPr>
+          <p:style>
+            <a:lnRef idx="1">
+              <a:schemeClr val="accent1"/>
+            </a:lnRef>
+            <a:fillRef idx="0">
+              <a:schemeClr val="accent1"/>
+            </a:fillRef>
+            <a:effectRef idx="0">
+              <a:schemeClr val="accent1"/>
+            </a:effectRef>
+            <a:fontRef idx="minor">
+              <a:schemeClr val="tx1"/>
+            </a:fontRef>
+          </p:style>
+          <p:txBody>
+            <a:bodyPr rtlCol="0" anchor="ctr"/>
+            <a:lstStyle/>
+            <a:p>
+              <a:pPr algn="ctr"/>
+              <a:endParaRPr kumimoji="1" lang="ja-JP" altLang="en-US"/>
+            </a:p>
+          </p:txBody>
+        </p:sp>
+        <p:grpSp>
+          <p:nvGrpSpPr>
+            <p:cNvPr id="28" name="グループ化 27">
+              <a:extLst>
+                <a:ext uri="{FF2B5EF4-FFF2-40B4-BE49-F238E27FC236}">
+                  <a16:creationId xmlns:a16="http://schemas.microsoft.com/office/drawing/2014/main" id="{3B345917-E99F-C020-287A-E22CEAD1FAA8}"/>
+                </a:ext>
+              </a:extLst>
+            </p:cNvPr>
+            <p:cNvGrpSpPr/>
+            <p:nvPr/>
+          </p:nvGrpSpPr>
+          <p:grpSpPr>
+            <a:xfrm>
+              <a:off x="3503712" y="1268760"/>
+              <a:ext cx="3096344" cy="2880320"/>
+              <a:chOff x="3503712" y="1268760"/>
+              <a:chExt cx="3096344" cy="2880320"/>
+            </a:xfrm>
+          </p:grpSpPr>
+          <p:sp>
+            <p:nvSpPr>
+              <p:cNvPr id="32" name="円弧 31">
+                <a:extLst>
+                  <a:ext uri="{FF2B5EF4-FFF2-40B4-BE49-F238E27FC236}">
+                    <a16:creationId xmlns:a16="http://schemas.microsoft.com/office/drawing/2014/main" id="{BB0C1C75-4351-5BC2-2925-891737948DE9}"/>
+                  </a:ext>
+                </a:extLst>
+              </p:cNvPr>
+              <p:cNvSpPr/>
+              <p:nvPr/>
+            </p:nvSpPr>
+            <p:spPr>
+              <a:xfrm rot="16200000" flipV="1">
+                <a:off x="3503712" y="1268760"/>
+                <a:ext cx="2880320" cy="2880320"/>
+              </a:xfrm>
+              <a:prstGeom prst="arc">
+                <a:avLst>
+                  <a:gd name="adj1" fmla="val 14690949"/>
+                  <a:gd name="adj2" fmla="val 17653756"/>
+                </a:avLst>
+              </a:prstGeom>
+              <a:ln w="76200"/>
+            </p:spPr>
+            <p:style>
+              <a:lnRef idx="1">
+                <a:schemeClr val="accent1"/>
+              </a:lnRef>
+              <a:fillRef idx="0">
+                <a:schemeClr val="accent1"/>
+              </a:fillRef>
+              <a:effectRef idx="0">
+                <a:schemeClr val="accent1"/>
+              </a:effectRef>
+              <a:fontRef idx="minor">
+                <a:schemeClr val="tx1"/>
+              </a:fontRef>
+            </p:style>
+            <p:txBody>
+              <a:bodyPr rtlCol="0" anchor="ctr"/>
+              <a:lstStyle/>
+              <a:p>
+                <a:pPr algn="ctr"/>
+                <a:endParaRPr kumimoji="1" lang="ja-JP" altLang="en-US"/>
+              </a:p>
+            </p:txBody>
+          </p:sp>
+          <p:sp>
+            <p:nvSpPr>
+              <p:cNvPr id="33" name="円弧 32">
+                <a:extLst>
+                  <a:ext uri="{FF2B5EF4-FFF2-40B4-BE49-F238E27FC236}">
+                    <a16:creationId xmlns:a16="http://schemas.microsoft.com/office/drawing/2014/main" id="{50EB7DAD-093A-9480-423F-9158C2D5CF7C}"/>
+                  </a:ext>
+                </a:extLst>
+              </p:cNvPr>
+              <p:cNvSpPr/>
+              <p:nvPr/>
+            </p:nvSpPr>
+            <p:spPr>
+              <a:xfrm rot="16200000" flipV="1">
+                <a:off x="3719736" y="1268760"/>
+                <a:ext cx="2880320" cy="2880320"/>
+              </a:xfrm>
+              <a:prstGeom prst="arc">
+                <a:avLst>
+                  <a:gd name="adj1" fmla="val 13922304"/>
+                  <a:gd name="adj2" fmla="val 18382832"/>
+                </a:avLst>
+              </a:prstGeom>
+              <a:ln w="76200"/>
+            </p:spPr>
+            <p:style>
+              <a:lnRef idx="1">
+                <a:schemeClr val="accent1"/>
+              </a:lnRef>
+              <a:fillRef idx="0">
+                <a:schemeClr val="accent1"/>
+              </a:fillRef>
+              <a:effectRef idx="0">
+                <a:schemeClr val="accent1"/>
+              </a:effectRef>
+              <a:fontRef idx="minor">
+                <a:schemeClr val="tx1"/>
+              </a:fontRef>
+            </p:style>
+            <p:txBody>
+              <a:bodyPr rtlCol="0" anchor="ctr"/>
+              <a:lstStyle/>
+              <a:p>
+                <a:pPr algn="ctr"/>
+                <a:endParaRPr kumimoji="1" lang="ja-JP" altLang="en-US"/>
+              </a:p>
+            </p:txBody>
+          </p:sp>
+        </p:grpSp>
+        <p:grpSp>
+          <p:nvGrpSpPr>
+            <p:cNvPr id="29" name="グループ化 28">
+              <a:extLst>
+                <a:ext uri="{FF2B5EF4-FFF2-40B4-BE49-F238E27FC236}">
+                  <a16:creationId xmlns:a16="http://schemas.microsoft.com/office/drawing/2014/main" id="{0D39FDD6-DCE8-F537-F5C2-F3C0F4E43C04}"/>
+                </a:ext>
+              </a:extLst>
+            </p:cNvPr>
+            <p:cNvGrpSpPr/>
+            <p:nvPr/>
+          </p:nvGrpSpPr>
+          <p:grpSpPr>
+            <a:xfrm rot="10800000">
+              <a:off x="2783633" y="1340767"/>
+              <a:ext cx="3096344" cy="2880320"/>
+              <a:chOff x="3503712" y="1268760"/>
+              <a:chExt cx="3096344" cy="2880320"/>
+            </a:xfrm>
+          </p:grpSpPr>
+          <p:sp>
+            <p:nvSpPr>
+              <p:cNvPr id="30" name="円弧 29">
+                <a:extLst>
+                  <a:ext uri="{FF2B5EF4-FFF2-40B4-BE49-F238E27FC236}">
+                    <a16:creationId xmlns:a16="http://schemas.microsoft.com/office/drawing/2014/main" id="{17118F74-29FB-8575-1574-EE3290E1D8D8}"/>
+                  </a:ext>
+                </a:extLst>
+              </p:cNvPr>
+              <p:cNvSpPr/>
+              <p:nvPr/>
+            </p:nvSpPr>
+            <p:spPr>
+              <a:xfrm rot="16200000" flipV="1">
+                <a:off x="3503712" y="1268760"/>
+                <a:ext cx="2880320" cy="2880320"/>
+              </a:xfrm>
+              <a:prstGeom prst="arc">
+                <a:avLst>
+                  <a:gd name="adj1" fmla="val 14690949"/>
+                  <a:gd name="adj2" fmla="val 17653756"/>
+                </a:avLst>
+              </a:prstGeom>
+              <a:ln w="76200"/>
+            </p:spPr>
+            <p:style>
+              <a:lnRef idx="1">
+                <a:schemeClr val="accent1"/>
+              </a:lnRef>
+              <a:fillRef idx="0">
+                <a:schemeClr val="accent1"/>
+              </a:fillRef>
+              <a:effectRef idx="0">
+                <a:schemeClr val="accent1"/>
+              </a:effectRef>
+              <a:fontRef idx="minor">
+                <a:schemeClr val="tx1"/>
+              </a:fontRef>
+            </p:style>
+            <p:txBody>
+              <a:bodyPr rtlCol="0" anchor="ctr"/>
+              <a:lstStyle/>
+              <a:p>
+                <a:pPr algn="ctr"/>
+                <a:endParaRPr kumimoji="1" lang="ja-JP" altLang="en-US"/>
+              </a:p>
+            </p:txBody>
+          </p:sp>
+          <p:sp>
+            <p:nvSpPr>
+              <p:cNvPr id="31" name="円弧 30">
+                <a:extLst>
+                  <a:ext uri="{FF2B5EF4-FFF2-40B4-BE49-F238E27FC236}">
+                    <a16:creationId xmlns:a16="http://schemas.microsoft.com/office/drawing/2014/main" id="{966D0E79-6B56-BFC1-D987-937DAF362831}"/>
+                  </a:ext>
+                </a:extLst>
+              </p:cNvPr>
+              <p:cNvSpPr/>
+              <p:nvPr/>
+            </p:nvSpPr>
+            <p:spPr>
+              <a:xfrm rot="16200000" flipV="1">
+                <a:off x="3719736" y="1268760"/>
+                <a:ext cx="2880320" cy="2880320"/>
+              </a:xfrm>
+              <a:prstGeom prst="arc">
+                <a:avLst>
+                  <a:gd name="adj1" fmla="val 13922304"/>
+                  <a:gd name="adj2" fmla="val 18382832"/>
+                </a:avLst>
+              </a:prstGeom>
+              <a:ln w="76200"/>
+            </p:spPr>
+            <p:style>
+              <a:lnRef idx="1">
+                <a:schemeClr val="accent1"/>
+              </a:lnRef>
+              <a:fillRef idx="0">
+                <a:schemeClr val="accent1"/>
+              </a:fillRef>
+              <a:effectRef idx="0">
+                <a:schemeClr val="accent1"/>
+              </a:effectRef>
+              <a:fontRef idx="minor">
+                <a:schemeClr val="tx1"/>
+              </a:fontRef>
+            </p:style>
+            <p:txBody>
+              <a:bodyPr rtlCol="0" anchor="ctr"/>
+              <a:lstStyle/>
+              <a:p>
+                <a:pPr algn="ctr"/>
+                <a:endParaRPr kumimoji="1" lang="ja-JP" altLang="en-US"/>
+              </a:p>
+            </p:txBody>
+          </p:sp>
+        </p:grpSp>
+      </p:grpSp>
+      <p:grpSp>
+        <p:nvGrpSpPr>
+          <p:cNvPr id="74" name="グループ化 73">
+            <a:extLst>
+              <a:ext uri="{FF2B5EF4-FFF2-40B4-BE49-F238E27FC236}">
+                <a16:creationId xmlns:a16="http://schemas.microsoft.com/office/drawing/2014/main" id="{EACDF45C-8504-B931-4FC6-20910D936AE0}"/>
+              </a:ext>
+            </a:extLst>
+          </p:cNvPr>
+          <p:cNvGrpSpPr/>
+          <p:nvPr/>
+        </p:nvGrpSpPr>
+        <p:grpSpPr>
+          <a:xfrm>
+            <a:off x="2783632" y="836712"/>
+            <a:ext cx="3744416" cy="3744416"/>
+            <a:chOff x="2783632" y="836712"/>
+            <a:chExt cx="3744416" cy="3744416"/>
+          </a:xfrm>
+        </p:grpSpPr>
+        <p:sp>
+          <p:nvSpPr>
+            <p:cNvPr id="72" name="楕円 71">
+              <a:extLst>
+                <a:ext uri="{FF2B5EF4-FFF2-40B4-BE49-F238E27FC236}">
+                  <a16:creationId xmlns:a16="http://schemas.microsoft.com/office/drawing/2014/main" id="{0B276A16-3ED5-15E4-ADF4-8E25F28BD15E}"/>
+                </a:ext>
+              </a:extLst>
+            </p:cNvPr>
+            <p:cNvSpPr/>
+            <p:nvPr/>
+          </p:nvSpPr>
+          <p:spPr>
+            <a:xfrm>
+              <a:off x="3215680" y="1268760"/>
+              <a:ext cx="2880000" cy="2880000"/>
+            </a:xfrm>
+            <a:prstGeom prst="ellipse">
+              <a:avLst/>
+            </a:prstGeom>
+            <a:solidFill>
+              <a:schemeClr val="accent1"/>
+            </a:solidFill>
+            <a:ln w="76200">
+              <a:noFill/>
+            </a:ln>
+          </p:spPr>
+          <p:style>
+            <a:lnRef idx="2">
+              <a:schemeClr val="accent1">
+                <a:shade val="15000"/>
+              </a:schemeClr>
+            </a:lnRef>
+            <a:fillRef idx="1">
+              <a:schemeClr val="accent1"/>
+            </a:fillRef>
+            <a:effectRef idx="0">
+              <a:schemeClr val="accent1"/>
+            </a:effectRef>
+            <a:fontRef idx="minor">
+              <a:schemeClr val="lt1"/>
+            </a:fontRef>
+          </p:style>
+          <p:txBody>
+            <a:bodyPr rtlCol="0" anchor="ctr"/>
+            <a:lstStyle/>
+            <a:p>
+              <a:pPr algn="ctr"/>
+              <a:endParaRPr kumimoji="1" lang="ja-JP" altLang="en-US"/>
+            </a:p>
+          </p:txBody>
+        </p:sp>
+        <p:sp>
+          <p:nvSpPr>
+            <p:cNvPr id="2" name="楕円 1">
+              <a:extLst>
+                <a:ext uri="{FF2B5EF4-FFF2-40B4-BE49-F238E27FC236}">
+                  <a16:creationId xmlns:a16="http://schemas.microsoft.com/office/drawing/2014/main" id="{74126DBA-7A31-A5C4-8466-ED47E006498A}"/>
+                </a:ext>
+              </a:extLst>
+            </p:cNvPr>
+            <p:cNvSpPr/>
+            <p:nvPr/>
+          </p:nvSpPr>
+          <p:spPr>
+            <a:xfrm>
+              <a:off x="3215680" y="1268760"/>
+              <a:ext cx="2880000" cy="2880000"/>
+            </a:xfrm>
+            <a:prstGeom prst="ellipse">
+              <a:avLst/>
+            </a:prstGeom>
+            <a:noFill/>
+            <a:ln w="76200">
+              <a:solidFill>
+                <a:schemeClr val="bg1"/>
+              </a:solidFill>
+            </a:ln>
+          </p:spPr>
+          <p:style>
+            <a:lnRef idx="2">
+              <a:schemeClr val="accent1">
+                <a:shade val="15000"/>
+              </a:schemeClr>
+            </a:lnRef>
+            <a:fillRef idx="1">
+              <a:schemeClr val="accent1"/>
+            </a:fillRef>
+            <a:effectRef idx="0">
+              <a:schemeClr val="accent1"/>
+            </a:effectRef>
+            <a:fontRef idx="minor">
+              <a:schemeClr val="lt1"/>
+            </a:fontRef>
+          </p:style>
+          <p:txBody>
+            <a:bodyPr rtlCol="0" anchor="ctr"/>
+            <a:lstStyle/>
+            <a:p>
+              <a:pPr algn="ctr"/>
+              <a:endParaRPr kumimoji="1" lang="ja-JP" altLang="en-US"/>
+            </a:p>
+          </p:txBody>
+        </p:sp>
+        <p:sp>
+          <p:nvSpPr>
+            <p:cNvPr id="3" name="楕円 2">
+              <a:extLst>
+                <a:ext uri="{FF2B5EF4-FFF2-40B4-BE49-F238E27FC236}">
+                  <a16:creationId xmlns:a16="http://schemas.microsoft.com/office/drawing/2014/main" id="{5412F451-61E7-C9AF-3F4C-25230C34A84A}"/>
+                </a:ext>
+              </a:extLst>
+            </p:cNvPr>
+            <p:cNvSpPr/>
+            <p:nvPr/>
+          </p:nvSpPr>
+          <p:spPr>
+            <a:xfrm>
+              <a:off x="3791424" y="1268760"/>
+              <a:ext cx="1728512" cy="2880000"/>
+            </a:xfrm>
+            <a:prstGeom prst="ellipse">
+              <a:avLst/>
+            </a:prstGeom>
+            <a:noFill/>
+            <a:ln w="76200">
+              <a:solidFill>
+                <a:schemeClr val="bg1"/>
+              </a:solidFill>
+            </a:ln>
+          </p:spPr>
+          <p:style>
+            <a:lnRef idx="2">
+              <a:schemeClr val="accent1">
+                <a:shade val="15000"/>
+              </a:schemeClr>
+            </a:lnRef>
+            <a:fillRef idx="1">
+              <a:schemeClr val="accent1"/>
+            </a:fillRef>
+            <a:effectRef idx="0">
+              <a:schemeClr val="accent1"/>
+            </a:effectRef>
+            <a:fontRef idx="minor">
+              <a:schemeClr val="lt1"/>
+            </a:fontRef>
+          </p:style>
+          <p:txBody>
+            <a:bodyPr rtlCol="0" anchor="ctr"/>
+            <a:lstStyle/>
+            <a:p>
+              <a:pPr algn="ctr"/>
+              <a:endParaRPr kumimoji="1" lang="ja-JP" altLang="en-US"/>
+            </a:p>
+          </p:txBody>
+        </p:sp>
+        <p:cxnSp>
+          <p:nvCxnSpPr>
+            <p:cNvPr id="7" name="直線コネクタ 6">
+              <a:extLst>
+                <a:ext uri="{FF2B5EF4-FFF2-40B4-BE49-F238E27FC236}">
+                  <a16:creationId xmlns:a16="http://schemas.microsoft.com/office/drawing/2014/main" id="{339A8B42-9FEC-636F-6BC6-9569E2FC6CA4}"/>
+                </a:ext>
+              </a:extLst>
+            </p:cNvPr>
+            <p:cNvCxnSpPr>
+              <a:cxnSpLocks/>
+              <a:stCxn id="2" idx="2"/>
+              <a:endCxn id="2" idx="6"/>
+            </p:cNvCxnSpPr>
+            <p:nvPr/>
+          </p:nvCxnSpPr>
+          <p:spPr>
+            <a:xfrm>
+              <a:off x="3215680" y="2708760"/>
+              <a:ext cx="2880000" cy="0"/>
+            </a:xfrm>
+            <a:prstGeom prst="line">
+              <a:avLst/>
+            </a:prstGeom>
+            <a:ln w="76200">
+              <a:solidFill>
+                <a:schemeClr val="bg1"/>
+              </a:solidFill>
+            </a:ln>
+          </p:spPr>
+          <p:style>
+            <a:lnRef idx="1">
+              <a:schemeClr val="accent1"/>
+            </a:lnRef>
+            <a:fillRef idx="0">
+              <a:schemeClr val="accent1"/>
+            </a:fillRef>
+            <a:effectRef idx="0">
+              <a:schemeClr val="accent1"/>
+            </a:effectRef>
+            <a:fontRef idx="minor">
+              <a:schemeClr val="tx1"/>
+            </a:fontRef>
+          </p:style>
+        </p:cxnSp>
+        <p:cxnSp>
+          <p:nvCxnSpPr>
+            <p:cNvPr id="8" name="直線コネクタ 7">
+              <a:extLst>
+                <a:ext uri="{FF2B5EF4-FFF2-40B4-BE49-F238E27FC236}">
+                  <a16:creationId xmlns:a16="http://schemas.microsoft.com/office/drawing/2014/main" id="{8BA4B13A-F2A5-76C9-20AA-AEFC22FAB802}"/>
+                </a:ext>
+              </a:extLst>
+            </p:cNvPr>
+            <p:cNvCxnSpPr>
+              <a:cxnSpLocks/>
+              <a:stCxn id="3" idx="0"/>
+              <a:endCxn id="3" idx="4"/>
+            </p:cNvCxnSpPr>
+            <p:nvPr/>
+          </p:nvCxnSpPr>
+          <p:spPr>
+            <a:xfrm>
+              <a:off x="4655680" y="1268760"/>
+              <a:ext cx="0" cy="2880000"/>
+            </a:xfrm>
+            <a:prstGeom prst="line">
+              <a:avLst/>
+            </a:prstGeom>
+            <a:ln w="76200">
+              <a:solidFill>
+                <a:schemeClr val="bg1"/>
+              </a:solidFill>
+            </a:ln>
+          </p:spPr>
+          <p:style>
+            <a:lnRef idx="1">
+              <a:schemeClr val="accent1"/>
+            </a:lnRef>
+            <a:fillRef idx="0">
+              <a:schemeClr val="accent1"/>
+            </a:fillRef>
+            <a:effectRef idx="0">
+              <a:schemeClr val="accent1"/>
+            </a:effectRef>
+            <a:fontRef idx="minor">
+              <a:schemeClr val="tx1"/>
+            </a:fontRef>
+          </p:style>
+        </p:cxnSp>
+        <p:sp>
+          <p:nvSpPr>
+            <p:cNvPr id="12" name="円弧 11">
+              <a:extLst>
+                <a:ext uri="{FF2B5EF4-FFF2-40B4-BE49-F238E27FC236}">
+                  <a16:creationId xmlns:a16="http://schemas.microsoft.com/office/drawing/2014/main" id="{5BDF1E3F-3FA5-936A-9709-3C79A09A3BBD}"/>
+                </a:ext>
+              </a:extLst>
+            </p:cNvPr>
+            <p:cNvSpPr/>
+            <p:nvPr/>
+          </p:nvSpPr>
+          <p:spPr>
+            <a:xfrm flipV="1">
+              <a:off x="3287688" y="980728"/>
+              <a:ext cx="2736304" cy="1080120"/>
+            </a:xfrm>
+            <a:prstGeom prst="arc">
+              <a:avLst>
+                <a:gd name="adj1" fmla="val 11696102"/>
+                <a:gd name="adj2" fmla="val 20659846"/>
+              </a:avLst>
+            </a:prstGeom>
+            <a:ln w="76200">
+              <a:solidFill>
+                <a:schemeClr val="bg1"/>
+              </a:solidFill>
+            </a:ln>
+          </p:spPr>
+          <p:style>
+            <a:lnRef idx="1">
+              <a:schemeClr val="accent1"/>
+            </a:lnRef>
+            <a:fillRef idx="0">
+              <a:schemeClr val="accent1"/>
+            </a:fillRef>
+            <a:effectRef idx="0">
+              <a:schemeClr val="accent1"/>
+            </a:effectRef>
+            <a:fontRef idx="minor">
+              <a:schemeClr val="tx1"/>
+            </a:fontRef>
+          </p:style>
+          <p:txBody>
+            <a:bodyPr rtlCol="0" anchor="ctr"/>
+            <a:lstStyle/>
+            <a:p>
+              <a:pPr algn="ctr"/>
+              <a:endParaRPr kumimoji="1" lang="ja-JP" altLang="en-US"/>
+            </a:p>
+          </p:txBody>
+        </p:sp>
+        <p:sp>
+          <p:nvSpPr>
+            <p:cNvPr id="13" name="円弧 12">
+              <a:extLst>
+                <a:ext uri="{FF2B5EF4-FFF2-40B4-BE49-F238E27FC236}">
+                  <a16:creationId xmlns:a16="http://schemas.microsoft.com/office/drawing/2014/main" id="{741DEBE0-4FEB-B3FE-29AD-E5E05EB7319A}"/>
+                </a:ext>
+              </a:extLst>
+            </p:cNvPr>
+            <p:cNvSpPr/>
+            <p:nvPr/>
+          </p:nvSpPr>
+          <p:spPr>
+            <a:xfrm rot="10800000" flipV="1">
+              <a:off x="3287688" y="3356992"/>
+              <a:ext cx="2736304" cy="1080120"/>
+            </a:xfrm>
+            <a:prstGeom prst="arc">
+              <a:avLst>
+                <a:gd name="adj1" fmla="val 11720544"/>
+                <a:gd name="adj2" fmla="val 20759633"/>
+              </a:avLst>
+            </a:prstGeom>
+            <a:ln w="76200">
+              <a:solidFill>
+                <a:schemeClr val="bg1"/>
+              </a:solidFill>
+            </a:ln>
+          </p:spPr>
+          <p:style>
+            <a:lnRef idx="1">
+              <a:schemeClr val="accent1"/>
+            </a:lnRef>
+            <a:fillRef idx="0">
+              <a:schemeClr val="accent1"/>
+            </a:fillRef>
+            <a:effectRef idx="0">
+              <a:schemeClr val="accent1"/>
+            </a:effectRef>
+            <a:fontRef idx="minor">
+              <a:schemeClr val="tx1"/>
+            </a:fontRef>
+          </p:style>
+          <p:txBody>
+            <a:bodyPr rtlCol="0" anchor="ctr"/>
+            <a:lstStyle/>
+            <a:p>
+              <a:pPr algn="ctr"/>
+              <a:endParaRPr kumimoji="1" lang="ja-JP" altLang="en-US"/>
+            </a:p>
+          </p:txBody>
+        </p:sp>
+        <p:grpSp>
+          <p:nvGrpSpPr>
+            <p:cNvPr id="54" name="グループ化 53">
+              <a:extLst>
+                <a:ext uri="{FF2B5EF4-FFF2-40B4-BE49-F238E27FC236}">
+                  <a16:creationId xmlns:a16="http://schemas.microsoft.com/office/drawing/2014/main" id="{792F7412-ED80-6A94-E3DB-65A2D14F8B68}"/>
+                </a:ext>
+              </a:extLst>
+            </p:cNvPr>
+            <p:cNvGrpSpPr/>
+            <p:nvPr/>
+          </p:nvGrpSpPr>
+          <p:grpSpPr>
+            <a:xfrm>
+              <a:off x="2783632" y="836712"/>
+              <a:ext cx="3744416" cy="3744416"/>
+              <a:chOff x="2783632" y="836712"/>
+              <a:chExt cx="3744416" cy="3744416"/>
+            </a:xfrm>
+          </p:grpSpPr>
+          <p:sp>
+            <p:nvSpPr>
+              <p:cNvPr id="15" name="円弧 14">
+                <a:extLst>
+                  <a:ext uri="{FF2B5EF4-FFF2-40B4-BE49-F238E27FC236}">
+                    <a16:creationId xmlns:a16="http://schemas.microsoft.com/office/drawing/2014/main" id="{88303419-F9B8-B85B-9E6A-70F3A6F2DA27}"/>
+                  </a:ext>
+                </a:extLst>
+              </p:cNvPr>
+              <p:cNvSpPr/>
+              <p:nvPr/>
+            </p:nvSpPr>
+            <p:spPr>
+              <a:xfrm rot="16200000" flipV="1">
+                <a:off x="2999656" y="1052736"/>
+                <a:ext cx="3312368" cy="3312368"/>
+              </a:xfrm>
+              <a:prstGeom prst="arc">
+                <a:avLst>
+                  <a:gd name="adj1" fmla="val 14548556"/>
+                  <a:gd name="adj2" fmla="val 17761163"/>
+                </a:avLst>
+              </a:prstGeom>
+              <a:ln w="76200">
+                <a:solidFill>
+                  <a:schemeClr val="accent1"/>
+                </a:solidFill>
+              </a:ln>
+            </p:spPr>
+            <p:style>
+              <a:lnRef idx="1">
+                <a:schemeClr val="accent1"/>
+              </a:lnRef>
+              <a:fillRef idx="0">
+                <a:schemeClr val="accent1"/>
+              </a:fillRef>
+              <a:effectRef idx="0">
+                <a:schemeClr val="accent1"/>
+              </a:effectRef>
+              <a:fontRef idx="minor">
+                <a:schemeClr val="tx1"/>
+              </a:fontRef>
+            </p:style>
+            <p:txBody>
+              <a:bodyPr rtlCol="0" anchor="ctr"/>
+              <a:lstStyle/>
+              <a:p>
+                <a:pPr algn="ctr"/>
+                <a:endParaRPr kumimoji="1" lang="ja-JP" altLang="en-US"/>
+              </a:p>
+            </p:txBody>
+          </p:sp>
+          <p:sp>
+            <p:nvSpPr>
+              <p:cNvPr id="53" name="円弧 52">
+                <a:extLst>
+                  <a:ext uri="{FF2B5EF4-FFF2-40B4-BE49-F238E27FC236}">
+                    <a16:creationId xmlns:a16="http://schemas.microsoft.com/office/drawing/2014/main" id="{7308EFBD-EFA6-3C0F-6EEF-EAB28162AA53}"/>
+                  </a:ext>
+                </a:extLst>
+              </p:cNvPr>
+              <p:cNvSpPr/>
+              <p:nvPr/>
+            </p:nvSpPr>
+            <p:spPr>
+              <a:xfrm rot="16200000" flipV="1">
+                <a:off x="2783632" y="836712"/>
+                <a:ext cx="3744416" cy="3744416"/>
+              </a:xfrm>
+              <a:prstGeom prst="arc">
+                <a:avLst>
+                  <a:gd name="adj1" fmla="val 14548556"/>
+                  <a:gd name="adj2" fmla="val 17761163"/>
+                </a:avLst>
+              </a:prstGeom>
+              <a:ln w="76200">
+                <a:solidFill>
+                  <a:schemeClr val="accent1"/>
+                </a:solidFill>
+              </a:ln>
+            </p:spPr>
+            <p:style>
+              <a:lnRef idx="1">
+                <a:schemeClr val="accent1"/>
+              </a:lnRef>
+              <a:fillRef idx="0">
+                <a:schemeClr val="accent1"/>
+              </a:fillRef>
+              <a:effectRef idx="0">
+                <a:schemeClr val="accent1"/>
+              </a:effectRef>
+              <a:fontRef idx="minor">
+                <a:schemeClr val="tx1"/>
+              </a:fontRef>
+            </p:style>
+            <p:txBody>
+              <a:bodyPr rtlCol="0" anchor="ctr"/>
+              <a:lstStyle/>
+              <a:p>
+                <a:pPr algn="ctr"/>
+                <a:endParaRPr kumimoji="1" lang="ja-JP" altLang="en-US"/>
+              </a:p>
+            </p:txBody>
+          </p:sp>
+        </p:grpSp>
+        <p:grpSp>
+          <p:nvGrpSpPr>
+            <p:cNvPr id="55" name="グループ化 54">
+              <a:extLst>
+                <a:ext uri="{FF2B5EF4-FFF2-40B4-BE49-F238E27FC236}">
+                  <a16:creationId xmlns:a16="http://schemas.microsoft.com/office/drawing/2014/main" id="{F56C7AEB-3B49-A678-BBDC-45D71014E579}"/>
+                </a:ext>
+              </a:extLst>
+            </p:cNvPr>
+            <p:cNvGrpSpPr/>
+            <p:nvPr/>
+          </p:nvGrpSpPr>
+          <p:grpSpPr>
+            <a:xfrm rot="10800000">
+              <a:off x="2783632" y="836712"/>
+              <a:ext cx="3744416" cy="3744416"/>
+              <a:chOff x="2783632" y="836712"/>
+              <a:chExt cx="3744416" cy="3744416"/>
+            </a:xfrm>
+          </p:grpSpPr>
+          <p:sp>
+            <p:nvSpPr>
+              <p:cNvPr id="56" name="円弧 55">
+                <a:extLst>
+                  <a:ext uri="{FF2B5EF4-FFF2-40B4-BE49-F238E27FC236}">
+                    <a16:creationId xmlns:a16="http://schemas.microsoft.com/office/drawing/2014/main" id="{CBE5D8DC-6F9E-E0F7-D60F-E8F689A5F9E4}"/>
+                  </a:ext>
+                </a:extLst>
+              </p:cNvPr>
+              <p:cNvSpPr/>
+              <p:nvPr/>
+            </p:nvSpPr>
+            <p:spPr>
+              <a:xfrm rot="16200000" flipV="1">
+                <a:off x="2999656" y="1052736"/>
+                <a:ext cx="3312368" cy="3312368"/>
+              </a:xfrm>
+              <a:prstGeom prst="arc">
+                <a:avLst>
+                  <a:gd name="adj1" fmla="val 14548556"/>
+                  <a:gd name="adj2" fmla="val 17761163"/>
+                </a:avLst>
+              </a:prstGeom>
+              <a:ln w="76200">
+                <a:solidFill>
+                  <a:schemeClr val="accent1"/>
+                </a:solidFill>
+              </a:ln>
+            </p:spPr>
+            <p:style>
+              <a:lnRef idx="1">
+                <a:schemeClr val="accent1"/>
+              </a:lnRef>
+              <a:fillRef idx="0">
+                <a:schemeClr val="accent1"/>
+              </a:fillRef>
+              <a:effectRef idx="0">
+                <a:schemeClr val="accent1"/>
+              </a:effectRef>
+              <a:fontRef idx="minor">
+                <a:schemeClr val="tx1"/>
+              </a:fontRef>
+            </p:style>
+            <p:txBody>
+              <a:bodyPr rtlCol="0" anchor="ctr"/>
+              <a:lstStyle/>
+              <a:p>
+                <a:pPr algn="ctr"/>
+                <a:endParaRPr kumimoji="1" lang="ja-JP" altLang="en-US"/>
+              </a:p>
+            </p:txBody>
+          </p:sp>
+          <p:sp>
+            <p:nvSpPr>
+              <p:cNvPr id="57" name="円弧 56">
+                <a:extLst>
+                  <a:ext uri="{FF2B5EF4-FFF2-40B4-BE49-F238E27FC236}">
+                    <a16:creationId xmlns:a16="http://schemas.microsoft.com/office/drawing/2014/main" id="{ED49D76E-A6DE-2818-634B-CC7E65D803CB}"/>
+                  </a:ext>
+                </a:extLst>
+              </p:cNvPr>
+              <p:cNvSpPr/>
+              <p:nvPr/>
+            </p:nvSpPr>
+            <p:spPr>
+              <a:xfrm rot="16200000" flipV="1">
+                <a:off x="2783632" y="836712"/>
+                <a:ext cx="3744416" cy="3744416"/>
+              </a:xfrm>
+              <a:prstGeom prst="arc">
+                <a:avLst>
+                  <a:gd name="adj1" fmla="val 14548556"/>
+                  <a:gd name="adj2" fmla="val 17761163"/>
+                </a:avLst>
+              </a:prstGeom>
+              <a:ln w="76200">
+                <a:solidFill>
+                  <a:schemeClr val="accent1"/>
+                </a:solidFill>
+              </a:ln>
+            </p:spPr>
+            <p:style>
+              <a:lnRef idx="1">
+                <a:schemeClr val="accent1"/>
+              </a:lnRef>
+              <a:fillRef idx="0">
+                <a:schemeClr val="accent1"/>
+              </a:fillRef>
+              <a:effectRef idx="0">
+                <a:schemeClr val="accent1"/>
+              </a:effectRef>
+              <a:fontRef idx="minor">
+                <a:schemeClr val="tx1"/>
+              </a:fontRef>
+            </p:style>
+            <p:txBody>
+              <a:bodyPr rtlCol="0" anchor="ctr"/>
+              <a:lstStyle/>
+              <a:p>
+                <a:pPr algn="ctr"/>
+                <a:endParaRPr kumimoji="1" lang="ja-JP" altLang="en-US"/>
+              </a:p>
+            </p:txBody>
+          </p:sp>
+        </p:grpSp>
+      </p:grpSp>
+      <p:sp>
+        <p:nvSpPr>
+          <p:cNvPr id="60" name="楕円 59">
+            <a:extLst>
+              <a:ext uri="{FF2B5EF4-FFF2-40B4-BE49-F238E27FC236}">
+                <a16:creationId xmlns:a16="http://schemas.microsoft.com/office/drawing/2014/main" id="{89BF28BB-00C6-9218-282A-716905B28631}"/>
+              </a:ext>
+            </a:extLst>
+          </p:cNvPr>
+          <p:cNvSpPr/>
+          <p:nvPr/>
+        </p:nvSpPr>
+        <p:spPr>
+          <a:xfrm>
+            <a:off x="7752184" y="1988840"/>
+            <a:ext cx="1440000" cy="1440000"/>
+          </a:xfrm>
+          <a:prstGeom prst="ellipse">
+            <a:avLst/>
+          </a:prstGeom>
+          <a:noFill/>
+          <a:ln w="76200">
+            <a:solidFill>
+              <a:schemeClr val="accent1"/>
+            </a:solidFill>
+          </a:ln>
+        </p:spPr>
+        <p:style>
+          <a:lnRef idx="2">
+            <a:schemeClr val="accent1">
+              <a:shade val="15000"/>
+            </a:schemeClr>
+          </a:lnRef>
+          <a:fillRef idx="1">
+            <a:schemeClr val="accent1"/>
+          </a:fillRef>
+          <a:effectRef idx="0">
+            <a:schemeClr val="accent1"/>
+          </a:effectRef>
+          <a:fontRef idx="minor">
+            <a:schemeClr val="lt1"/>
+          </a:fontRef>
+        </p:style>
+        <p:txBody>
+          <a:bodyPr rtlCol="0" anchor="ctr"/>
+          <a:lstStyle/>
+          <a:p>
+            <a:pPr algn="ctr"/>
+            <a:endParaRPr kumimoji="1" lang="ja-JP" altLang="en-US"/>
+          </a:p>
+        </p:txBody>
+      </p:sp>
+      <p:sp>
+        <p:nvSpPr>
+          <p:cNvPr id="61" name="楕円 60">
+            <a:extLst>
+              <a:ext uri="{FF2B5EF4-FFF2-40B4-BE49-F238E27FC236}">
+                <a16:creationId xmlns:a16="http://schemas.microsoft.com/office/drawing/2014/main" id="{54D90128-C4DA-63A9-46F5-0BBE740B696D}"/>
+              </a:ext>
+            </a:extLst>
+          </p:cNvPr>
+          <p:cNvSpPr/>
+          <p:nvPr/>
+        </p:nvSpPr>
+        <p:spPr>
+          <a:xfrm>
+            <a:off x="8040056" y="1988840"/>
+            <a:ext cx="864256" cy="1440000"/>
+          </a:xfrm>
+          <a:prstGeom prst="ellipse">
+            <a:avLst/>
+          </a:prstGeom>
+          <a:noFill/>
+          <a:ln w="76200">
+            <a:solidFill>
+              <a:schemeClr val="accent1"/>
+            </a:solidFill>
+          </a:ln>
+        </p:spPr>
+        <p:style>
+          <a:lnRef idx="2">
+            <a:schemeClr val="accent1">
+              <a:shade val="15000"/>
+            </a:schemeClr>
+          </a:lnRef>
+          <a:fillRef idx="1">
+            <a:schemeClr val="accent1"/>
+          </a:fillRef>
+          <a:effectRef idx="0">
+            <a:schemeClr val="accent1"/>
+          </a:effectRef>
+          <a:fontRef idx="minor">
+            <a:schemeClr val="lt1"/>
+          </a:fontRef>
+        </p:style>
+        <p:txBody>
+          <a:bodyPr rtlCol="0" anchor="ctr"/>
+          <a:lstStyle/>
+          <a:p>
+            <a:pPr algn="ctr"/>
+            <a:endParaRPr kumimoji="1" lang="ja-JP" altLang="en-US"/>
+          </a:p>
+        </p:txBody>
+      </p:sp>
+      <p:cxnSp>
+        <p:nvCxnSpPr>
+          <p:cNvPr id="62" name="直線コネクタ 61">
+            <a:extLst>
+              <a:ext uri="{FF2B5EF4-FFF2-40B4-BE49-F238E27FC236}">
+                <a16:creationId xmlns:a16="http://schemas.microsoft.com/office/drawing/2014/main" id="{99A44A2B-B3D3-8952-726A-91351CF26220}"/>
+              </a:ext>
+            </a:extLst>
+          </p:cNvPr>
+          <p:cNvCxnSpPr>
+            <a:cxnSpLocks/>
+            <a:stCxn id="60" idx="2"/>
+            <a:endCxn id="60" idx="6"/>
+          </p:cNvCxnSpPr>
+          <p:nvPr/>
+        </p:nvCxnSpPr>
+        <p:spPr>
+          <a:xfrm>
+            <a:off x="7752184" y="2708840"/>
+            <a:ext cx="1440000" cy="0"/>
+          </a:xfrm>
+          <a:prstGeom prst="line">
+            <a:avLst/>
+          </a:prstGeom>
+          <a:ln w="76200"/>
+        </p:spPr>
+        <p:style>
+          <a:lnRef idx="1">
+            <a:schemeClr val="accent1"/>
+          </a:lnRef>
+          <a:fillRef idx="0">
+            <a:schemeClr val="accent1"/>
+          </a:fillRef>
+          <a:effectRef idx="0">
+            <a:schemeClr val="accent1"/>
+          </a:effectRef>
+          <a:fontRef idx="minor">
+            <a:schemeClr val="tx1"/>
+          </a:fontRef>
+        </p:style>
+      </p:cxnSp>
+      <p:cxnSp>
+        <p:nvCxnSpPr>
+          <p:cNvPr id="63" name="直線コネクタ 62">
+            <a:extLst>
+              <a:ext uri="{FF2B5EF4-FFF2-40B4-BE49-F238E27FC236}">
+                <a16:creationId xmlns:a16="http://schemas.microsoft.com/office/drawing/2014/main" id="{2EA8BEE5-59EA-08FC-2D92-5DF4AFF52576}"/>
+              </a:ext>
+            </a:extLst>
+          </p:cNvPr>
+          <p:cNvCxnSpPr>
+            <a:cxnSpLocks/>
+            <a:stCxn id="61" idx="0"/>
+            <a:endCxn id="61" idx="4"/>
+          </p:cNvCxnSpPr>
+          <p:nvPr/>
+        </p:nvCxnSpPr>
+        <p:spPr>
+          <a:xfrm>
+            <a:off x="8472184" y="1988840"/>
+            <a:ext cx="0" cy="1440000"/>
+          </a:xfrm>
+          <a:prstGeom prst="line">
+            <a:avLst/>
+          </a:prstGeom>
+          <a:ln w="76200"/>
+        </p:spPr>
+        <p:style>
+          <a:lnRef idx="1">
+            <a:schemeClr val="accent1"/>
+          </a:lnRef>
+          <a:fillRef idx="0">
+            <a:schemeClr val="accent1"/>
+          </a:fillRef>
+          <a:effectRef idx="0">
+            <a:schemeClr val="accent1"/>
+          </a:effectRef>
+          <a:fontRef idx="minor">
+            <a:schemeClr val="tx1"/>
+          </a:fontRef>
+        </p:style>
+      </p:cxnSp>
+      <p:sp>
+        <p:nvSpPr>
+          <p:cNvPr id="64" name="円弧 63">
+            <a:extLst>
+              <a:ext uri="{FF2B5EF4-FFF2-40B4-BE49-F238E27FC236}">
+                <a16:creationId xmlns:a16="http://schemas.microsoft.com/office/drawing/2014/main" id="{1E060891-558C-ED28-1443-094ECE187DA7}"/>
+              </a:ext>
+            </a:extLst>
+          </p:cNvPr>
+          <p:cNvSpPr/>
+          <p:nvPr/>
+        </p:nvSpPr>
+        <p:spPr>
+          <a:xfrm flipV="1">
+            <a:off x="7788188" y="1844824"/>
+            <a:ext cx="1368152" cy="540060"/>
+          </a:xfrm>
+          <a:prstGeom prst="arc">
+            <a:avLst>
+              <a:gd name="adj1" fmla="val 11696102"/>
+              <a:gd name="adj2" fmla="val 20659846"/>
+            </a:avLst>
+          </a:prstGeom>
+          <a:ln w="76200"/>
+        </p:spPr>
+        <p:style>
+          <a:lnRef idx="1">
+            <a:schemeClr val="accent1"/>
+          </a:lnRef>
+          <a:fillRef idx="0">
+            <a:schemeClr val="accent1"/>
+          </a:fillRef>
+          <a:effectRef idx="0">
+            <a:schemeClr val="accent1"/>
+          </a:effectRef>
+          <a:fontRef idx="minor">
+            <a:schemeClr val="tx1"/>
+          </a:fontRef>
+        </p:style>
+        <p:txBody>
+          <a:bodyPr rtlCol="0" anchor="ctr"/>
+          <a:lstStyle/>
+          <a:p>
+            <a:pPr algn="ctr"/>
+            <a:endParaRPr kumimoji="1" lang="ja-JP" altLang="en-US"/>
+          </a:p>
+        </p:txBody>
+      </p:sp>
+      <p:sp>
+        <p:nvSpPr>
+          <p:cNvPr id="65" name="円弧 64">
+            <a:extLst>
+              <a:ext uri="{FF2B5EF4-FFF2-40B4-BE49-F238E27FC236}">
+                <a16:creationId xmlns:a16="http://schemas.microsoft.com/office/drawing/2014/main" id="{C35FA9B6-94F8-1ECC-2372-733314974C2D}"/>
+              </a:ext>
+            </a:extLst>
+          </p:cNvPr>
+          <p:cNvSpPr/>
+          <p:nvPr/>
+        </p:nvSpPr>
+        <p:spPr>
+          <a:xfrm rot="10800000" flipV="1">
+            <a:off x="7788188" y="3032956"/>
+            <a:ext cx="1368152" cy="540060"/>
+          </a:xfrm>
+          <a:prstGeom prst="arc">
+            <a:avLst>
+              <a:gd name="adj1" fmla="val 11720544"/>
+              <a:gd name="adj2" fmla="val 20759633"/>
+            </a:avLst>
+          </a:prstGeom>
+          <a:ln w="76200"/>
+        </p:spPr>
+        <p:style>
+          <a:lnRef idx="1">
+            <a:schemeClr val="accent1"/>
+          </a:lnRef>
+          <a:fillRef idx="0">
+            <a:schemeClr val="accent1"/>
+          </a:fillRef>
+          <a:effectRef idx="0">
+            <a:schemeClr val="accent1"/>
+          </a:effectRef>
+          <a:fontRef idx="minor">
+            <a:schemeClr val="tx1"/>
+          </a:fontRef>
+        </p:style>
+        <p:txBody>
+          <a:bodyPr rtlCol="0" anchor="ctr"/>
+          <a:lstStyle/>
+          <a:p>
+            <a:pPr algn="ctr"/>
+            <a:endParaRPr kumimoji="1" lang="ja-JP" altLang="en-US"/>
+          </a:p>
+        </p:txBody>
+      </p:sp>
+      <p:grpSp>
+        <p:nvGrpSpPr>
+          <p:cNvPr id="66" name="グループ化 65">
+            <a:extLst>
+              <a:ext uri="{FF2B5EF4-FFF2-40B4-BE49-F238E27FC236}">
+                <a16:creationId xmlns:a16="http://schemas.microsoft.com/office/drawing/2014/main" id="{B1B81D97-153D-D52E-ECED-819BD8754691}"/>
+              </a:ext>
+            </a:extLst>
+          </p:cNvPr>
+          <p:cNvGrpSpPr/>
+          <p:nvPr/>
+        </p:nvGrpSpPr>
+        <p:grpSpPr>
+          <a:xfrm>
+            <a:off x="7536160" y="1772816"/>
+            <a:ext cx="1872208" cy="1872208"/>
+            <a:chOff x="2783632" y="836712"/>
+            <a:chExt cx="3744416" cy="3744416"/>
+          </a:xfrm>
+        </p:grpSpPr>
+        <p:sp>
+          <p:nvSpPr>
+            <p:cNvPr id="70" name="円弧 69">
+              <a:extLst>
+                <a:ext uri="{FF2B5EF4-FFF2-40B4-BE49-F238E27FC236}">
+                  <a16:creationId xmlns:a16="http://schemas.microsoft.com/office/drawing/2014/main" id="{F754D8EA-0517-1EE6-C2D3-A654195A4731}"/>
+                </a:ext>
+              </a:extLst>
+            </p:cNvPr>
+            <p:cNvSpPr/>
+            <p:nvPr/>
+          </p:nvSpPr>
+          <p:spPr>
+            <a:xfrm rot="16200000" flipV="1">
+              <a:off x="2999656" y="1052736"/>
+              <a:ext cx="3312368" cy="3312368"/>
+            </a:xfrm>
+            <a:prstGeom prst="arc">
+              <a:avLst>
+                <a:gd name="adj1" fmla="val 14548556"/>
+                <a:gd name="adj2" fmla="val 17761163"/>
+              </a:avLst>
+            </a:prstGeom>
+            <a:ln w="76200">
+              <a:solidFill>
+                <a:schemeClr val="accent1">
+                  <a:lumMod val="60000"/>
+                  <a:lumOff val="40000"/>
+                </a:schemeClr>
+              </a:solidFill>
+            </a:ln>
+          </p:spPr>
+          <p:style>
+            <a:lnRef idx="1">
+              <a:schemeClr val="accent1"/>
+            </a:lnRef>
+            <a:fillRef idx="0">
+              <a:schemeClr val="accent1"/>
+            </a:fillRef>
+            <a:effectRef idx="0">
+              <a:schemeClr val="accent1"/>
+            </a:effectRef>
+            <a:fontRef idx="minor">
+              <a:schemeClr val="tx1"/>
+            </a:fontRef>
+          </p:style>
+          <p:txBody>
+            <a:bodyPr rtlCol="0" anchor="ctr"/>
+            <a:lstStyle/>
+            <a:p>
+              <a:pPr algn="ctr"/>
+              <a:endParaRPr kumimoji="1" lang="ja-JP" altLang="en-US"/>
+            </a:p>
+          </p:txBody>
+        </p:sp>
+        <p:sp>
+          <p:nvSpPr>
+            <p:cNvPr id="71" name="円弧 70">
+              <a:extLst>
+                <a:ext uri="{FF2B5EF4-FFF2-40B4-BE49-F238E27FC236}">
+                  <a16:creationId xmlns:a16="http://schemas.microsoft.com/office/drawing/2014/main" id="{58D9B525-4658-13A5-914B-DEB274FADB50}"/>
+                </a:ext>
+              </a:extLst>
+            </p:cNvPr>
+            <p:cNvSpPr/>
+            <p:nvPr/>
+          </p:nvSpPr>
+          <p:spPr>
+            <a:xfrm rot="16200000" flipV="1">
+              <a:off x="2783632" y="836712"/>
+              <a:ext cx="3744416" cy="3744416"/>
+            </a:xfrm>
+            <a:prstGeom prst="arc">
+              <a:avLst>
+                <a:gd name="adj1" fmla="val 14548556"/>
+                <a:gd name="adj2" fmla="val 17761163"/>
+              </a:avLst>
+            </a:prstGeom>
+            <a:ln w="76200">
+              <a:solidFill>
+                <a:schemeClr val="accent1">
+                  <a:lumMod val="60000"/>
+                  <a:lumOff val="40000"/>
+                </a:schemeClr>
+              </a:solidFill>
+            </a:ln>
+          </p:spPr>
+          <p:style>
+            <a:lnRef idx="1">
+              <a:schemeClr val="accent1"/>
+            </a:lnRef>
+            <a:fillRef idx="0">
+              <a:schemeClr val="accent1"/>
+            </a:fillRef>
+            <a:effectRef idx="0">
+              <a:schemeClr val="accent1"/>
+            </a:effectRef>
+            <a:fontRef idx="minor">
+              <a:schemeClr val="tx1"/>
+            </a:fontRef>
+          </p:style>
+          <p:txBody>
+            <a:bodyPr rtlCol="0" anchor="ctr"/>
+            <a:lstStyle/>
+            <a:p>
+              <a:pPr algn="ctr"/>
+              <a:endParaRPr kumimoji="1" lang="ja-JP" altLang="en-US"/>
+            </a:p>
+          </p:txBody>
+        </p:sp>
+      </p:grpSp>
+      <p:grpSp>
+        <p:nvGrpSpPr>
+          <p:cNvPr id="67" name="グループ化 66">
+            <a:extLst>
+              <a:ext uri="{FF2B5EF4-FFF2-40B4-BE49-F238E27FC236}">
+                <a16:creationId xmlns:a16="http://schemas.microsoft.com/office/drawing/2014/main" id="{C96017CC-0D3C-26D9-C616-FD3B1B5A4C6E}"/>
+              </a:ext>
+            </a:extLst>
+          </p:cNvPr>
+          <p:cNvGrpSpPr/>
+          <p:nvPr/>
+        </p:nvGrpSpPr>
+        <p:grpSpPr>
+          <a:xfrm rot="10800000">
+            <a:off x="7536160" y="1772816"/>
+            <a:ext cx="1872208" cy="1872208"/>
+            <a:chOff x="2783632" y="836712"/>
+            <a:chExt cx="3744416" cy="3744416"/>
+          </a:xfrm>
+        </p:grpSpPr>
+        <p:sp>
+          <p:nvSpPr>
+            <p:cNvPr id="68" name="円弧 67">
+              <a:extLst>
+                <a:ext uri="{FF2B5EF4-FFF2-40B4-BE49-F238E27FC236}">
+                  <a16:creationId xmlns:a16="http://schemas.microsoft.com/office/drawing/2014/main" id="{71B46E5D-98CC-ACB5-9095-03552A776F06}"/>
+                </a:ext>
+              </a:extLst>
+            </p:cNvPr>
+            <p:cNvSpPr/>
+            <p:nvPr/>
+          </p:nvSpPr>
+          <p:spPr>
+            <a:xfrm rot="16200000" flipV="1">
+              <a:off x="2999656" y="1052736"/>
+              <a:ext cx="3312368" cy="3312368"/>
+            </a:xfrm>
+            <a:prstGeom prst="arc">
+              <a:avLst>
+                <a:gd name="adj1" fmla="val 14548556"/>
+                <a:gd name="adj2" fmla="val 17761163"/>
+              </a:avLst>
+            </a:prstGeom>
+            <a:ln w="76200">
+              <a:solidFill>
+                <a:schemeClr val="accent1">
+                  <a:lumMod val="60000"/>
+                  <a:lumOff val="40000"/>
+                </a:schemeClr>
+              </a:solidFill>
+            </a:ln>
+          </p:spPr>
+          <p:style>
+            <a:lnRef idx="1">
+              <a:schemeClr val="accent1"/>
+            </a:lnRef>
+            <a:fillRef idx="0">
+              <a:schemeClr val="accent1"/>
+            </a:fillRef>
+            <a:effectRef idx="0">
+              <a:schemeClr val="accent1"/>
+            </a:effectRef>
+            <a:fontRef idx="minor">
+              <a:schemeClr val="tx1"/>
+            </a:fontRef>
+          </p:style>
+          <p:txBody>
+            <a:bodyPr rtlCol="0" anchor="ctr"/>
+            <a:lstStyle/>
+            <a:p>
+              <a:pPr algn="ctr"/>
+              <a:endParaRPr kumimoji="1" lang="ja-JP" altLang="en-US"/>
+            </a:p>
+          </p:txBody>
+        </p:sp>
+        <p:sp>
+          <p:nvSpPr>
+            <p:cNvPr id="69" name="円弧 68">
+              <a:extLst>
+                <a:ext uri="{FF2B5EF4-FFF2-40B4-BE49-F238E27FC236}">
+                  <a16:creationId xmlns:a16="http://schemas.microsoft.com/office/drawing/2014/main" id="{271FCCF8-F738-0C4A-A0C7-C2F324DA83E7}"/>
+                </a:ext>
+              </a:extLst>
+            </p:cNvPr>
+            <p:cNvSpPr/>
+            <p:nvPr/>
+          </p:nvSpPr>
+          <p:spPr>
+            <a:xfrm rot="16200000" flipV="1">
+              <a:off x="2783632" y="836712"/>
+              <a:ext cx="3744416" cy="3744416"/>
+            </a:xfrm>
+            <a:prstGeom prst="arc">
+              <a:avLst>
+                <a:gd name="adj1" fmla="val 14548556"/>
+                <a:gd name="adj2" fmla="val 17761163"/>
+              </a:avLst>
+            </a:prstGeom>
+            <a:ln w="76200">
+              <a:solidFill>
+                <a:schemeClr val="accent1">
+                  <a:lumMod val="60000"/>
+                  <a:lumOff val="40000"/>
+                </a:schemeClr>
+              </a:solidFill>
+            </a:ln>
+          </p:spPr>
+          <p:style>
+            <a:lnRef idx="1">
+              <a:schemeClr val="accent1"/>
+            </a:lnRef>
+            <a:fillRef idx="0">
+              <a:schemeClr val="accent1"/>
+            </a:fillRef>
+            <a:effectRef idx="0">
+              <a:schemeClr val="accent1"/>
+            </a:effectRef>
+            <a:fontRef idx="minor">
+              <a:schemeClr val="tx1"/>
+            </a:fontRef>
+          </p:style>
+          <p:txBody>
+            <a:bodyPr rtlCol="0" anchor="ctr"/>
+            <a:lstStyle/>
+            <a:p>
+              <a:pPr algn="ctr"/>
+              <a:endParaRPr kumimoji="1" lang="ja-JP" altLang="en-US"/>
+            </a:p>
+          </p:txBody>
+        </p:sp>
+      </p:grpSp>
+      <p:grpSp>
+        <p:nvGrpSpPr>
+          <p:cNvPr id="75" name="グループ化 74">
+            <a:extLst>
+              <a:ext uri="{FF2B5EF4-FFF2-40B4-BE49-F238E27FC236}">
+                <a16:creationId xmlns:a16="http://schemas.microsoft.com/office/drawing/2014/main" id="{D2601C2B-FC61-81C2-6910-CAA2A0969942}"/>
+              </a:ext>
+            </a:extLst>
+          </p:cNvPr>
+          <p:cNvGrpSpPr/>
+          <p:nvPr/>
+        </p:nvGrpSpPr>
+        <p:grpSpPr>
+          <a:xfrm>
+            <a:off x="7536160" y="3789040"/>
+            <a:ext cx="1965631" cy="1965631"/>
+            <a:chOff x="2783632" y="836712"/>
+            <a:chExt cx="3744416" cy="3744416"/>
+          </a:xfrm>
+        </p:grpSpPr>
+        <p:sp>
+          <p:nvSpPr>
+            <p:cNvPr id="76" name="楕円 75">
+              <a:extLst>
+                <a:ext uri="{FF2B5EF4-FFF2-40B4-BE49-F238E27FC236}">
+                  <a16:creationId xmlns:a16="http://schemas.microsoft.com/office/drawing/2014/main" id="{9FF2D707-C952-51B8-25A4-160AE4F6655C}"/>
+                </a:ext>
+              </a:extLst>
+            </p:cNvPr>
+            <p:cNvSpPr/>
+            <p:nvPr/>
+          </p:nvSpPr>
+          <p:spPr>
+            <a:xfrm>
+              <a:off x="3215680" y="1268760"/>
+              <a:ext cx="2880000" cy="2880000"/>
+            </a:xfrm>
+            <a:prstGeom prst="ellipse">
+              <a:avLst/>
+            </a:prstGeom>
+            <a:solidFill>
+              <a:schemeClr val="accent1"/>
+            </a:solidFill>
+            <a:ln w="76200">
+              <a:noFill/>
+            </a:ln>
+          </p:spPr>
+          <p:style>
+            <a:lnRef idx="2">
+              <a:schemeClr val="accent1">
+                <a:shade val="15000"/>
+              </a:schemeClr>
+            </a:lnRef>
+            <a:fillRef idx="1">
+              <a:schemeClr val="accent1"/>
+            </a:fillRef>
+            <a:effectRef idx="0">
+              <a:schemeClr val="accent1"/>
+            </a:effectRef>
+            <a:fontRef idx="minor">
+              <a:schemeClr val="lt1"/>
+            </a:fontRef>
+          </p:style>
+          <p:txBody>
+            <a:bodyPr rtlCol="0" anchor="ctr"/>
+            <a:lstStyle/>
+            <a:p>
+              <a:pPr algn="ctr"/>
+              <a:endParaRPr kumimoji="1" lang="ja-JP" altLang="en-US"/>
+            </a:p>
+          </p:txBody>
+        </p:sp>
+        <p:sp>
+          <p:nvSpPr>
+            <p:cNvPr id="77" name="楕円 76">
+              <a:extLst>
+                <a:ext uri="{FF2B5EF4-FFF2-40B4-BE49-F238E27FC236}">
+                  <a16:creationId xmlns:a16="http://schemas.microsoft.com/office/drawing/2014/main" id="{F89DE5DB-08BC-C905-3D9B-191823F8779A}"/>
+                </a:ext>
+              </a:extLst>
+            </p:cNvPr>
+            <p:cNvSpPr/>
+            <p:nvPr/>
+          </p:nvSpPr>
+          <p:spPr>
+            <a:xfrm>
+              <a:off x="3215680" y="1268760"/>
+              <a:ext cx="2880000" cy="2880000"/>
+            </a:xfrm>
+            <a:prstGeom prst="ellipse">
+              <a:avLst/>
+            </a:prstGeom>
+            <a:noFill/>
+            <a:ln w="76200">
+              <a:solidFill>
+                <a:schemeClr val="bg1"/>
+              </a:solidFill>
+            </a:ln>
+          </p:spPr>
+          <p:style>
+            <a:lnRef idx="2">
+              <a:schemeClr val="accent1">
+                <a:shade val="15000"/>
+              </a:schemeClr>
+            </a:lnRef>
+            <a:fillRef idx="1">
+              <a:schemeClr val="accent1"/>
+            </a:fillRef>
+            <a:effectRef idx="0">
+              <a:schemeClr val="accent1"/>
+            </a:effectRef>
+            <a:fontRef idx="minor">
+              <a:schemeClr val="lt1"/>
+            </a:fontRef>
+          </p:style>
+          <p:txBody>
+            <a:bodyPr rtlCol="0" anchor="ctr"/>
+            <a:lstStyle/>
+            <a:p>
+              <a:pPr algn="ctr"/>
+              <a:endParaRPr kumimoji="1" lang="ja-JP" altLang="en-US"/>
+            </a:p>
+          </p:txBody>
+        </p:sp>
+        <p:sp>
+          <p:nvSpPr>
+            <p:cNvPr id="78" name="楕円 77">
+              <a:extLst>
+                <a:ext uri="{FF2B5EF4-FFF2-40B4-BE49-F238E27FC236}">
+                  <a16:creationId xmlns:a16="http://schemas.microsoft.com/office/drawing/2014/main" id="{DDE78CAE-5AB2-5C8A-020D-F6D6089DAE3C}"/>
+                </a:ext>
+              </a:extLst>
+            </p:cNvPr>
+            <p:cNvSpPr/>
+            <p:nvPr/>
+          </p:nvSpPr>
+          <p:spPr>
+            <a:xfrm>
+              <a:off x="3791424" y="1268760"/>
+              <a:ext cx="1728512" cy="2880000"/>
+            </a:xfrm>
+            <a:prstGeom prst="ellipse">
+              <a:avLst/>
+            </a:prstGeom>
+            <a:noFill/>
+            <a:ln w="76200">
+              <a:solidFill>
+                <a:schemeClr val="bg1"/>
+              </a:solidFill>
+            </a:ln>
+          </p:spPr>
+          <p:style>
+            <a:lnRef idx="2">
+              <a:schemeClr val="accent1">
+                <a:shade val="15000"/>
+              </a:schemeClr>
+            </a:lnRef>
+            <a:fillRef idx="1">
+              <a:schemeClr val="accent1"/>
+            </a:fillRef>
+            <a:effectRef idx="0">
+              <a:schemeClr val="accent1"/>
+            </a:effectRef>
+            <a:fontRef idx="minor">
+              <a:schemeClr val="lt1"/>
+            </a:fontRef>
+          </p:style>
+          <p:txBody>
+            <a:bodyPr rtlCol="0" anchor="ctr"/>
+            <a:lstStyle/>
+            <a:p>
+              <a:pPr algn="ctr"/>
+              <a:endParaRPr kumimoji="1" lang="ja-JP" altLang="en-US"/>
+            </a:p>
+          </p:txBody>
+        </p:sp>
+        <p:cxnSp>
+          <p:nvCxnSpPr>
+            <p:cNvPr id="79" name="直線コネクタ 78">
+              <a:extLst>
+                <a:ext uri="{FF2B5EF4-FFF2-40B4-BE49-F238E27FC236}">
+                  <a16:creationId xmlns:a16="http://schemas.microsoft.com/office/drawing/2014/main" id="{D0CC0217-9675-DD08-7D34-BD5074C50AD8}"/>
+                </a:ext>
+              </a:extLst>
+            </p:cNvPr>
+            <p:cNvCxnSpPr>
+              <a:cxnSpLocks/>
+              <a:stCxn id="77" idx="2"/>
+              <a:endCxn id="77" idx="6"/>
+            </p:cNvCxnSpPr>
+            <p:nvPr/>
+          </p:nvCxnSpPr>
+          <p:spPr>
+            <a:xfrm>
+              <a:off x="3215680" y="2708760"/>
+              <a:ext cx="2880000" cy="0"/>
+            </a:xfrm>
+            <a:prstGeom prst="line">
+              <a:avLst/>
+            </a:prstGeom>
+            <a:ln w="76200">
+              <a:solidFill>
+                <a:schemeClr val="bg1"/>
+              </a:solidFill>
+            </a:ln>
+          </p:spPr>
+          <p:style>
+            <a:lnRef idx="1">
+              <a:schemeClr val="accent1"/>
+            </a:lnRef>
+            <a:fillRef idx="0">
+              <a:schemeClr val="accent1"/>
+            </a:fillRef>
+            <a:effectRef idx="0">
+              <a:schemeClr val="accent1"/>
+            </a:effectRef>
+            <a:fontRef idx="minor">
+              <a:schemeClr val="tx1"/>
+            </a:fontRef>
+          </p:style>
+        </p:cxnSp>
+        <p:cxnSp>
+          <p:nvCxnSpPr>
+            <p:cNvPr id="80" name="直線コネクタ 79">
+              <a:extLst>
+                <a:ext uri="{FF2B5EF4-FFF2-40B4-BE49-F238E27FC236}">
+                  <a16:creationId xmlns:a16="http://schemas.microsoft.com/office/drawing/2014/main" id="{1AA2154F-5EB4-DDA7-6418-45D5F482E735}"/>
+                </a:ext>
+              </a:extLst>
+            </p:cNvPr>
+            <p:cNvCxnSpPr>
+              <a:cxnSpLocks/>
+              <a:stCxn id="78" idx="0"/>
+              <a:endCxn id="78" idx="4"/>
+            </p:cNvCxnSpPr>
+            <p:nvPr/>
+          </p:nvCxnSpPr>
+          <p:spPr>
+            <a:xfrm>
+              <a:off x="4655680" y="1268760"/>
+              <a:ext cx="0" cy="2880000"/>
+            </a:xfrm>
+            <a:prstGeom prst="line">
+              <a:avLst/>
+            </a:prstGeom>
+            <a:ln w="76200">
+              <a:solidFill>
+                <a:schemeClr val="bg1"/>
+              </a:solidFill>
+            </a:ln>
+          </p:spPr>
+          <p:style>
+            <a:lnRef idx="1">
+              <a:schemeClr val="accent1"/>
+            </a:lnRef>
+            <a:fillRef idx="0">
+              <a:schemeClr val="accent1"/>
+            </a:fillRef>
+            <a:effectRef idx="0">
+              <a:schemeClr val="accent1"/>
+            </a:effectRef>
+            <a:fontRef idx="minor">
+              <a:schemeClr val="tx1"/>
+            </a:fontRef>
+          </p:style>
+        </p:cxnSp>
+        <p:sp>
+          <p:nvSpPr>
+            <p:cNvPr id="81" name="円弧 80">
+              <a:extLst>
+                <a:ext uri="{FF2B5EF4-FFF2-40B4-BE49-F238E27FC236}">
+                  <a16:creationId xmlns:a16="http://schemas.microsoft.com/office/drawing/2014/main" id="{C8EFB8ED-F9F0-0293-2D5E-82AC8658BC88}"/>
+                </a:ext>
+              </a:extLst>
+            </p:cNvPr>
+            <p:cNvSpPr/>
+            <p:nvPr/>
+          </p:nvSpPr>
+          <p:spPr>
+            <a:xfrm flipV="1">
+              <a:off x="3287688" y="980728"/>
+              <a:ext cx="2736304" cy="1080120"/>
+            </a:xfrm>
+            <a:prstGeom prst="arc">
+              <a:avLst>
+                <a:gd name="adj1" fmla="val 11696102"/>
+                <a:gd name="adj2" fmla="val 20659846"/>
+              </a:avLst>
+            </a:prstGeom>
+            <a:ln w="76200">
+              <a:solidFill>
+                <a:schemeClr val="bg1"/>
+              </a:solidFill>
+            </a:ln>
+          </p:spPr>
+          <p:style>
+            <a:lnRef idx="1">
+              <a:schemeClr val="accent1"/>
+            </a:lnRef>
+            <a:fillRef idx="0">
+              <a:schemeClr val="accent1"/>
+            </a:fillRef>
+            <a:effectRef idx="0">
+              <a:schemeClr val="accent1"/>
+            </a:effectRef>
+            <a:fontRef idx="minor">
+              <a:schemeClr val="tx1"/>
+            </a:fontRef>
+          </p:style>
+          <p:txBody>
+            <a:bodyPr rtlCol="0" anchor="ctr"/>
+            <a:lstStyle/>
+            <a:p>
+              <a:pPr algn="ctr"/>
+              <a:endParaRPr kumimoji="1" lang="ja-JP" altLang="en-US"/>
+            </a:p>
+          </p:txBody>
+        </p:sp>
+        <p:sp>
+          <p:nvSpPr>
+            <p:cNvPr id="82" name="円弧 81">
+              <a:extLst>
+                <a:ext uri="{FF2B5EF4-FFF2-40B4-BE49-F238E27FC236}">
+                  <a16:creationId xmlns:a16="http://schemas.microsoft.com/office/drawing/2014/main" id="{6FA25A8B-443C-49AC-3650-D69C59CFC6F6}"/>
+                </a:ext>
+              </a:extLst>
+            </p:cNvPr>
+            <p:cNvSpPr/>
+            <p:nvPr/>
+          </p:nvSpPr>
+          <p:spPr>
+            <a:xfrm rot="10800000" flipV="1">
+              <a:off x="3287688" y="3356992"/>
+              <a:ext cx="2736304" cy="1080120"/>
+            </a:xfrm>
+            <a:prstGeom prst="arc">
+              <a:avLst>
+                <a:gd name="adj1" fmla="val 11720544"/>
+                <a:gd name="adj2" fmla="val 20759633"/>
+              </a:avLst>
+            </a:prstGeom>
+            <a:ln w="76200">
+              <a:solidFill>
+                <a:schemeClr val="bg1"/>
+              </a:solidFill>
+            </a:ln>
+          </p:spPr>
+          <p:style>
+            <a:lnRef idx="1">
+              <a:schemeClr val="accent1"/>
+            </a:lnRef>
+            <a:fillRef idx="0">
+              <a:schemeClr val="accent1"/>
+            </a:fillRef>
+            <a:effectRef idx="0">
+              <a:schemeClr val="accent1"/>
+            </a:effectRef>
+            <a:fontRef idx="minor">
+              <a:schemeClr val="tx1"/>
+            </a:fontRef>
+          </p:style>
+          <p:txBody>
+            <a:bodyPr rtlCol="0" anchor="ctr"/>
+            <a:lstStyle/>
+            <a:p>
+              <a:pPr algn="ctr"/>
+              <a:endParaRPr kumimoji="1" lang="ja-JP" altLang="en-US"/>
+            </a:p>
+          </p:txBody>
+        </p:sp>
+        <p:grpSp>
+          <p:nvGrpSpPr>
+            <p:cNvPr id="83" name="グループ化 82">
+              <a:extLst>
+                <a:ext uri="{FF2B5EF4-FFF2-40B4-BE49-F238E27FC236}">
+                  <a16:creationId xmlns:a16="http://schemas.microsoft.com/office/drawing/2014/main" id="{9411A145-97BA-99D8-0AF4-9F16BCD66E14}"/>
+                </a:ext>
+              </a:extLst>
+            </p:cNvPr>
+            <p:cNvGrpSpPr/>
+            <p:nvPr/>
+          </p:nvGrpSpPr>
+          <p:grpSpPr>
+            <a:xfrm>
+              <a:off x="2783632" y="836712"/>
+              <a:ext cx="3744416" cy="3744416"/>
+              <a:chOff x="2783632" y="836712"/>
+              <a:chExt cx="3744416" cy="3744416"/>
+            </a:xfrm>
+          </p:grpSpPr>
+          <p:sp>
+            <p:nvSpPr>
+              <p:cNvPr id="87" name="円弧 86">
+                <a:extLst>
+                  <a:ext uri="{FF2B5EF4-FFF2-40B4-BE49-F238E27FC236}">
+                    <a16:creationId xmlns:a16="http://schemas.microsoft.com/office/drawing/2014/main" id="{7933ECF8-33EC-B5A7-BD53-0C5AF63B6906}"/>
+                  </a:ext>
+                </a:extLst>
+              </p:cNvPr>
+              <p:cNvSpPr/>
+              <p:nvPr/>
+            </p:nvSpPr>
+            <p:spPr>
+              <a:xfrm rot="16200000" flipV="1">
+                <a:off x="2999656" y="1052736"/>
+                <a:ext cx="3312368" cy="3312368"/>
+              </a:xfrm>
+              <a:prstGeom prst="arc">
+                <a:avLst>
+                  <a:gd name="adj1" fmla="val 14548556"/>
+                  <a:gd name="adj2" fmla="val 17761163"/>
+                </a:avLst>
+              </a:prstGeom>
+              <a:ln w="76200">
+                <a:solidFill>
+                  <a:schemeClr val="accent1"/>
+                </a:solidFill>
+              </a:ln>
+            </p:spPr>
+            <p:style>
+              <a:lnRef idx="1">
+                <a:schemeClr val="accent1"/>
+              </a:lnRef>
+              <a:fillRef idx="0">
+                <a:schemeClr val="accent1"/>
+              </a:fillRef>
+              <a:effectRef idx="0">
+                <a:schemeClr val="accent1"/>
+              </a:effectRef>
+              <a:fontRef idx="minor">
+                <a:schemeClr val="tx1"/>
+              </a:fontRef>
+            </p:style>
+            <p:txBody>
+              <a:bodyPr rtlCol="0" anchor="ctr"/>
+              <a:lstStyle/>
+              <a:p>
+                <a:pPr algn="ctr"/>
+                <a:endParaRPr kumimoji="1" lang="ja-JP" altLang="en-US"/>
+              </a:p>
+            </p:txBody>
+          </p:sp>
+          <p:sp>
+            <p:nvSpPr>
+              <p:cNvPr id="88" name="円弧 87">
+                <a:extLst>
+                  <a:ext uri="{FF2B5EF4-FFF2-40B4-BE49-F238E27FC236}">
+                    <a16:creationId xmlns:a16="http://schemas.microsoft.com/office/drawing/2014/main" id="{294BB5F2-EF00-C069-332A-E27DAB28D551}"/>
+                  </a:ext>
+                </a:extLst>
+              </p:cNvPr>
+              <p:cNvSpPr/>
+              <p:nvPr/>
+            </p:nvSpPr>
+            <p:spPr>
+              <a:xfrm rot="16200000" flipV="1">
+                <a:off x="2783632" y="836712"/>
+                <a:ext cx="3744416" cy="3744416"/>
+              </a:xfrm>
+              <a:prstGeom prst="arc">
+                <a:avLst>
+                  <a:gd name="adj1" fmla="val 14548556"/>
+                  <a:gd name="adj2" fmla="val 17761163"/>
+                </a:avLst>
+              </a:prstGeom>
+              <a:ln w="76200">
+                <a:solidFill>
+                  <a:schemeClr val="accent1"/>
+                </a:solidFill>
+              </a:ln>
+            </p:spPr>
+            <p:style>
+              <a:lnRef idx="1">
+                <a:schemeClr val="accent1"/>
+              </a:lnRef>
+              <a:fillRef idx="0">
+                <a:schemeClr val="accent1"/>
+              </a:fillRef>
+              <a:effectRef idx="0">
+                <a:schemeClr val="accent1"/>
+              </a:effectRef>
+              <a:fontRef idx="minor">
+                <a:schemeClr val="tx1"/>
+              </a:fontRef>
+            </p:style>
+            <p:txBody>
+              <a:bodyPr rtlCol="0" anchor="ctr"/>
+              <a:lstStyle/>
+              <a:p>
+                <a:pPr algn="ctr"/>
+                <a:endParaRPr kumimoji="1" lang="ja-JP" altLang="en-US"/>
+              </a:p>
+            </p:txBody>
+          </p:sp>
+        </p:grpSp>
+        <p:grpSp>
+          <p:nvGrpSpPr>
+            <p:cNvPr id="84" name="グループ化 83">
+              <a:extLst>
+                <a:ext uri="{FF2B5EF4-FFF2-40B4-BE49-F238E27FC236}">
+                  <a16:creationId xmlns:a16="http://schemas.microsoft.com/office/drawing/2014/main" id="{D83FA6BF-8C39-78B2-E79A-812573CF3F86}"/>
+                </a:ext>
+              </a:extLst>
+            </p:cNvPr>
+            <p:cNvGrpSpPr/>
+            <p:nvPr/>
+          </p:nvGrpSpPr>
+          <p:grpSpPr>
+            <a:xfrm rot="10800000">
+              <a:off x="2783632" y="836712"/>
+              <a:ext cx="3744416" cy="3744416"/>
+              <a:chOff x="2783632" y="836712"/>
+              <a:chExt cx="3744416" cy="3744416"/>
+            </a:xfrm>
+          </p:grpSpPr>
+          <p:sp>
+            <p:nvSpPr>
+              <p:cNvPr id="85" name="円弧 84">
+                <a:extLst>
+                  <a:ext uri="{FF2B5EF4-FFF2-40B4-BE49-F238E27FC236}">
+                    <a16:creationId xmlns:a16="http://schemas.microsoft.com/office/drawing/2014/main" id="{EC586DA2-E736-1F4F-8445-27ADB386802C}"/>
+                  </a:ext>
+                </a:extLst>
+              </p:cNvPr>
+              <p:cNvSpPr/>
+              <p:nvPr/>
+            </p:nvSpPr>
+            <p:spPr>
+              <a:xfrm rot="16200000" flipV="1">
+                <a:off x="2999656" y="1052736"/>
+                <a:ext cx="3312368" cy="3312368"/>
+              </a:xfrm>
+              <a:prstGeom prst="arc">
+                <a:avLst>
+                  <a:gd name="adj1" fmla="val 14548556"/>
+                  <a:gd name="adj2" fmla="val 17761163"/>
+                </a:avLst>
+              </a:prstGeom>
+              <a:ln w="76200">
+                <a:solidFill>
+                  <a:schemeClr val="accent1"/>
+                </a:solidFill>
+              </a:ln>
+            </p:spPr>
+            <p:style>
+              <a:lnRef idx="1">
+                <a:schemeClr val="accent1"/>
+              </a:lnRef>
+              <a:fillRef idx="0">
+                <a:schemeClr val="accent1"/>
+              </a:fillRef>
+              <a:effectRef idx="0">
+                <a:schemeClr val="accent1"/>
+              </a:effectRef>
+              <a:fontRef idx="minor">
+                <a:schemeClr val="tx1"/>
+              </a:fontRef>
+            </p:style>
+            <p:txBody>
+              <a:bodyPr rtlCol="0" anchor="ctr"/>
+              <a:lstStyle/>
+              <a:p>
+                <a:pPr algn="ctr"/>
+                <a:endParaRPr kumimoji="1" lang="ja-JP" altLang="en-US"/>
+              </a:p>
+            </p:txBody>
+          </p:sp>
+          <p:sp>
+            <p:nvSpPr>
+              <p:cNvPr id="86" name="円弧 85">
+                <a:extLst>
+                  <a:ext uri="{FF2B5EF4-FFF2-40B4-BE49-F238E27FC236}">
+                    <a16:creationId xmlns:a16="http://schemas.microsoft.com/office/drawing/2014/main" id="{026B1521-BB8E-B30F-BF82-937167957208}"/>
+                  </a:ext>
+                </a:extLst>
+              </p:cNvPr>
+              <p:cNvSpPr/>
+              <p:nvPr/>
+            </p:nvSpPr>
+            <p:spPr>
+              <a:xfrm rot="16200000" flipV="1">
+                <a:off x="2783632" y="836712"/>
+                <a:ext cx="3744416" cy="3744416"/>
+              </a:xfrm>
+              <a:prstGeom prst="arc">
+                <a:avLst>
+                  <a:gd name="adj1" fmla="val 14548556"/>
+                  <a:gd name="adj2" fmla="val 17761163"/>
+                </a:avLst>
+              </a:prstGeom>
+              <a:ln w="76200">
+                <a:solidFill>
+                  <a:schemeClr val="accent1"/>
+                </a:solidFill>
+              </a:ln>
+            </p:spPr>
+            <p:style>
+              <a:lnRef idx="1">
+                <a:schemeClr val="accent1"/>
+              </a:lnRef>
+              <a:fillRef idx="0">
+                <a:schemeClr val="accent1"/>
+              </a:fillRef>
+              <a:effectRef idx="0">
+                <a:schemeClr val="accent1"/>
+              </a:effectRef>
+              <a:fontRef idx="minor">
+                <a:schemeClr val="tx1"/>
+              </a:fontRef>
+            </p:style>
+            <p:txBody>
+              <a:bodyPr rtlCol="0" anchor="ctr"/>
+              <a:lstStyle/>
+              <a:p>
+                <a:pPr algn="ctr"/>
+                <a:endParaRPr kumimoji="1" lang="ja-JP" altLang="en-US"/>
+              </a:p>
+            </p:txBody>
+          </p:sp>
+        </p:grpSp>
+      </p:grpSp>
+    </p:spTree>
+    <p:extLst>
+      <p:ext uri="{BB962C8B-B14F-4D97-AF65-F5344CB8AC3E}">
+        <p14:creationId xmlns:p14="http://schemas.microsoft.com/office/powerpoint/2010/main" val="3843787321"/>
+      </p:ext>
+    </p:extLst>
+  </p:cSld>
+  <p:clrMapOvr>
+    <a:masterClrMapping/>
+  </p:clrMapOvr>
+</p:sld>
+</file>
+
+<file path=ppt/slides/slide5.xml><?xml version="1.0" encoding="utf-8"?>
+<p:sld xmlns:a="http://schemas.openxmlformats.org/drawingml/2006/main" xmlns:r="http://schemas.openxmlformats.org/officeDocument/2006/relationships" xmlns:p="http://schemas.openxmlformats.org/presentationml/2006/main">
+  <p:cSld>
+    <p:spTree>
+      <p:nvGrpSpPr>
+        <p:cNvPr id="1" name="">
+          <a:extLst>
+            <a:ext uri="{FF2B5EF4-FFF2-40B4-BE49-F238E27FC236}">
+              <a16:creationId xmlns:a16="http://schemas.microsoft.com/office/drawing/2014/main" id="{0B4BD433-D69A-79F8-C559-ED98831547A3}"/>
+            </a:ext>
+          </a:extLst>
+        </p:cNvPr>
+        <p:cNvGrpSpPr/>
+        <p:nvPr/>
+      </p:nvGrpSpPr>
+      <p:grpSpPr>
+        <a:xfrm>
+          <a:off x="0" y="0"/>
+          <a:ext cx="0" cy="0"/>
+          <a:chOff x="0" y="0"/>
+          <a:chExt cx="0" cy="0"/>
+        </a:xfrm>
+      </p:grpSpPr>
+      <p:grpSp>
+        <p:nvGrpSpPr>
+          <p:cNvPr id="21" name="グループ化 20">
+            <a:extLst>
+              <a:ext uri="{FF2B5EF4-FFF2-40B4-BE49-F238E27FC236}">
+                <a16:creationId xmlns:a16="http://schemas.microsoft.com/office/drawing/2014/main" id="{4D0445DB-96D4-6B16-F7E6-4592B72B5356}"/>
+              </a:ext>
+            </a:extLst>
+          </p:cNvPr>
+          <p:cNvGrpSpPr/>
+          <p:nvPr/>
+        </p:nvGrpSpPr>
+        <p:grpSpPr>
+          <a:xfrm>
+            <a:off x="9768408" y="260648"/>
+            <a:ext cx="1987720" cy="1800200"/>
+            <a:chOff x="2783633" y="980728"/>
+            <a:chExt cx="3816423" cy="3456384"/>
+          </a:xfrm>
+        </p:grpSpPr>
+        <p:sp>
+          <p:nvSpPr>
+            <p:cNvPr id="22" name="楕円 21">
+              <a:extLst>
+                <a:ext uri="{FF2B5EF4-FFF2-40B4-BE49-F238E27FC236}">
+                  <a16:creationId xmlns:a16="http://schemas.microsoft.com/office/drawing/2014/main" id="{EA1000ED-607B-8E29-00BE-3563F1EC2B82}"/>
+                </a:ext>
+              </a:extLst>
+            </p:cNvPr>
+            <p:cNvSpPr/>
+            <p:nvPr/>
+          </p:nvSpPr>
+          <p:spPr>
+            <a:xfrm>
+              <a:off x="3215680" y="1268760"/>
+              <a:ext cx="2880000" cy="2880000"/>
+            </a:xfrm>
+            <a:prstGeom prst="ellipse">
+              <a:avLst/>
+            </a:prstGeom>
+            <a:noFill/>
+            <a:ln w="76200">
+              <a:solidFill>
+                <a:schemeClr val="accent1"/>
+              </a:solidFill>
+            </a:ln>
+          </p:spPr>
+          <p:style>
+            <a:lnRef idx="2">
+              <a:schemeClr val="accent1">
+                <a:shade val="15000"/>
+              </a:schemeClr>
+            </a:lnRef>
+            <a:fillRef idx="1">
+              <a:schemeClr val="accent1"/>
+            </a:fillRef>
+            <a:effectRef idx="0">
+              <a:schemeClr val="accent1"/>
+            </a:effectRef>
+            <a:fontRef idx="minor">
+              <a:schemeClr val="lt1"/>
+            </a:fontRef>
+          </p:style>
+          <p:txBody>
+            <a:bodyPr rtlCol="0" anchor="ctr"/>
+            <a:lstStyle/>
+            <a:p>
+              <a:pPr algn="ctr"/>
+              <a:endParaRPr kumimoji="1" lang="ja-JP" altLang="en-US"/>
+            </a:p>
+          </p:txBody>
+        </p:sp>
+        <p:sp>
+          <p:nvSpPr>
+            <p:cNvPr id="23" name="楕円 22">
+              <a:extLst>
+                <a:ext uri="{FF2B5EF4-FFF2-40B4-BE49-F238E27FC236}">
+                  <a16:creationId xmlns:a16="http://schemas.microsoft.com/office/drawing/2014/main" id="{456ED1B5-F5C4-9BFB-7787-AC2D7720233A}"/>
+                </a:ext>
+              </a:extLst>
+            </p:cNvPr>
+            <p:cNvSpPr/>
+            <p:nvPr/>
+          </p:nvSpPr>
+          <p:spPr>
+            <a:xfrm>
+              <a:off x="3791424" y="1268760"/>
+              <a:ext cx="1728512" cy="2880000"/>
+            </a:xfrm>
+            <a:prstGeom prst="ellipse">
+              <a:avLst/>
+            </a:prstGeom>
+            <a:noFill/>
+            <a:ln w="76200">
+              <a:solidFill>
+                <a:schemeClr val="accent1"/>
+              </a:solidFill>
+            </a:ln>
+          </p:spPr>
+          <p:style>
+            <a:lnRef idx="2">
+              <a:schemeClr val="accent1">
+                <a:shade val="15000"/>
+              </a:schemeClr>
+            </a:lnRef>
+            <a:fillRef idx="1">
+              <a:schemeClr val="accent1"/>
+            </a:fillRef>
+            <a:effectRef idx="0">
+              <a:schemeClr val="accent1"/>
+            </a:effectRef>
+            <a:fontRef idx="minor">
+              <a:schemeClr val="lt1"/>
+            </a:fontRef>
+          </p:style>
+          <p:txBody>
+            <a:bodyPr rtlCol="0" anchor="ctr"/>
+            <a:lstStyle/>
+            <a:p>
+              <a:pPr algn="ctr"/>
+              <a:endParaRPr kumimoji="1" lang="ja-JP" altLang="en-US"/>
+            </a:p>
+          </p:txBody>
+        </p:sp>
+        <p:cxnSp>
+          <p:nvCxnSpPr>
+            <p:cNvPr id="24" name="直線コネクタ 23">
+              <a:extLst>
+                <a:ext uri="{FF2B5EF4-FFF2-40B4-BE49-F238E27FC236}">
+                  <a16:creationId xmlns:a16="http://schemas.microsoft.com/office/drawing/2014/main" id="{D6C8BB6F-DD59-AE6B-AFD5-7CF8678AC012}"/>
+                </a:ext>
+              </a:extLst>
+            </p:cNvPr>
+            <p:cNvCxnSpPr>
+              <a:stCxn id="22" idx="2"/>
+              <a:endCxn id="22" idx="6"/>
+            </p:cNvCxnSpPr>
+            <p:nvPr/>
+          </p:nvCxnSpPr>
+          <p:spPr>
+            <a:xfrm>
+              <a:off x="3215680" y="2708760"/>
+              <a:ext cx="2880000" cy="0"/>
+            </a:xfrm>
+            <a:prstGeom prst="line">
+              <a:avLst/>
+            </a:prstGeom>
+            <a:ln w="76200"/>
+          </p:spPr>
+          <p:style>
+            <a:lnRef idx="1">
+              <a:schemeClr val="accent1"/>
+            </a:lnRef>
+            <a:fillRef idx="0">
+              <a:schemeClr val="accent1"/>
+            </a:fillRef>
+            <a:effectRef idx="0">
+              <a:schemeClr val="accent1"/>
+            </a:effectRef>
+            <a:fontRef idx="minor">
+              <a:schemeClr val="tx1"/>
+            </a:fontRef>
+          </p:style>
+        </p:cxnSp>
+        <p:cxnSp>
+          <p:nvCxnSpPr>
+            <p:cNvPr id="25" name="直線コネクタ 24">
+              <a:extLst>
+                <a:ext uri="{FF2B5EF4-FFF2-40B4-BE49-F238E27FC236}">
+                  <a16:creationId xmlns:a16="http://schemas.microsoft.com/office/drawing/2014/main" id="{8E78A479-4131-9803-DC1C-F52140168701}"/>
+                </a:ext>
+              </a:extLst>
+            </p:cNvPr>
+            <p:cNvCxnSpPr>
+              <a:cxnSpLocks/>
+              <a:stCxn id="23" idx="0"/>
+              <a:endCxn id="23" idx="4"/>
+            </p:cNvCxnSpPr>
+            <p:nvPr/>
+          </p:nvCxnSpPr>
+          <p:spPr>
+            <a:xfrm>
+              <a:off x="4655680" y="1268760"/>
+              <a:ext cx="0" cy="2880000"/>
+            </a:xfrm>
+            <a:prstGeom prst="line">
+              <a:avLst/>
+            </a:prstGeom>
+            <a:ln w="76200"/>
+          </p:spPr>
+          <p:style>
+            <a:lnRef idx="1">
+              <a:schemeClr val="accent1"/>
+            </a:lnRef>
+            <a:fillRef idx="0">
+              <a:schemeClr val="accent1"/>
+            </a:fillRef>
+            <a:effectRef idx="0">
+              <a:schemeClr val="accent1"/>
+            </a:effectRef>
+            <a:fontRef idx="minor">
+              <a:schemeClr val="tx1"/>
+            </a:fontRef>
+          </p:style>
+        </p:cxnSp>
+        <p:sp>
+          <p:nvSpPr>
+            <p:cNvPr id="26" name="円弧 25">
+              <a:extLst>
+                <a:ext uri="{FF2B5EF4-FFF2-40B4-BE49-F238E27FC236}">
+                  <a16:creationId xmlns:a16="http://schemas.microsoft.com/office/drawing/2014/main" id="{72D3D092-C813-196F-B47C-261C897FDAE4}"/>
+                </a:ext>
+              </a:extLst>
+            </p:cNvPr>
+            <p:cNvSpPr/>
+            <p:nvPr/>
+          </p:nvSpPr>
+          <p:spPr>
+            <a:xfrm flipV="1">
+              <a:off x="3287688" y="980728"/>
+              <a:ext cx="2736304" cy="1080120"/>
+            </a:xfrm>
+            <a:prstGeom prst="arc">
+              <a:avLst>
+                <a:gd name="adj1" fmla="val 11696102"/>
+                <a:gd name="adj2" fmla="val 20659846"/>
+              </a:avLst>
+            </a:prstGeom>
+            <a:ln w="76200"/>
+          </p:spPr>
+          <p:style>
+            <a:lnRef idx="1">
+              <a:schemeClr val="accent1"/>
+            </a:lnRef>
+            <a:fillRef idx="0">
+              <a:schemeClr val="accent1"/>
+            </a:fillRef>
+            <a:effectRef idx="0">
+              <a:schemeClr val="accent1"/>
+            </a:effectRef>
+            <a:fontRef idx="minor">
+              <a:schemeClr val="tx1"/>
+            </a:fontRef>
+          </p:style>
+          <p:txBody>
+            <a:bodyPr rtlCol="0" anchor="ctr"/>
+            <a:lstStyle/>
+            <a:p>
+              <a:pPr algn="ctr"/>
+              <a:endParaRPr kumimoji="1" lang="ja-JP" altLang="en-US"/>
+            </a:p>
+          </p:txBody>
+        </p:sp>
+        <p:sp>
+          <p:nvSpPr>
+            <p:cNvPr id="27" name="円弧 26">
+              <a:extLst>
+                <a:ext uri="{FF2B5EF4-FFF2-40B4-BE49-F238E27FC236}">
+                  <a16:creationId xmlns:a16="http://schemas.microsoft.com/office/drawing/2014/main" id="{84A5D68B-079F-7681-EA2F-6D9B4AE0A188}"/>
+                </a:ext>
+              </a:extLst>
+            </p:cNvPr>
+            <p:cNvSpPr/>
+            <p:nvPr/>
+          </p:nvSpPr>
+          <p:spPr>
+            <a:xfrm rot="10800000" flipV="1">
+              <a:off x="3287688" y="3356992"/>
+              <a:ext cx="2736304" cy="1080120"/>
+            </a:xfrm>
+            <a:prstGeom prst="arc">
+              <a:avLst>
+                <a:gd name="adj1" fmla="val 11720544"/>
+                <a:gd name="adj2" fmla="val 20759633"/>
+              </a:avLst>
+            </a:prstGeom>
+            <a:ln w="76200"/>
+          </p:spPr>
+          <p:style>
+            <a:lnRef idx="1">
+              <a:schemeClr val="accent1"/>
+            </a:lnRef>
+            <a:fillRef idx="0">
+              <a:schemeClr val="accent1"/>
+            </a:fillRef>
+            <a:effectRef idx="0">
+              <a:schemeClr val="accent1"/>
+            </a:effectRef>
+            <a:fontRef idx="minor">
+              <a:schemeClr val="tx1"/>
+            </a:fontRef>
+          </p:style>
+          <p:txBody>
+            <a:bodyPr rtlCol="0" anchor="ctr"/>
+            <a:lstStyle/>
+            <a:p>
+              <a:pPr algn="ctr"/>
+              <a:endParaRPr kumimoji="1" lang="ja-JP" altLang="en-US"/>
+            </a:p>
+          </p:txBody>
+        </p:sp>
+        <p:grpSp>
+          <p:nvGrpSpPr>
+            <p:cNvPr id="28" name="グループ化 27">
+              <a:extLst>
+                <a:ext uri="{FF2B5EF4-FFF2-40B4-BE49-F238E27FC236}">
+                  <a16:creationId xmlns:a16="http://schemas.microsoft.com/office/drawing/2014/main" id="{F532CFC9-8FA2-4416-A279-78096543BB54}"/>
+                </a:ext>
+              </a:extLst>
+            </p:cNvPr>
+            <p:cNvGrpSpPr/>
+            <p:nvPr/>
+          </p:nvGrpSpPr>
+          <p:grpSpPr>
+            <a:xfrm>
+              <a:off x="3503712" y="1268760"/>
+              <a:ext cx="3096344" cy="2880320"/>
+              <a:chOff x="3503712" y="1268760"/>
+              <a:chExt cx="3096344" cy="2880320"/>
+            </a:xfrm>
+          </p:grpSpPr>
+          <p:sp>
+            <p:nvSpPr>
+              <p:cNvPr id="32" name="円弧 31">
+                <a:extLst>
+                  <a:ext uri="{FF2B5EF4-FFF2-40B4-BE49-F238E27FC236}">
+                    <a16:creationId xmlns:a16="http://schemas.microsoft.com/office/drawing/2014/main" id="{7B0E2A1A-0511-5E0B-CA3E-8A51B4366FE0}"/>
+                  </a:ext>
+                </a:extLst>
+              </p:cNvPr>
+              <p:cNvSpPr/>
+              <p:nvPr/>
+            </p:nvSpPr>
+            <p:spPr>
+              <a:xfrm rot="16200000" flipV="1">
+                <a:off x="3503712" y="1268760"/>
+                <a:ext cx="2880320" cy="2880320"/>
+              </a:xfrm>
+              <a:prstGeom prst="arc">
+                <a:avLst>
+                  <a:gd name="adj1" fmla="val 14690949"/>
+                  <a:gd name="adj2" fmla="val 17653756"/>
+                </a:avLst>
+              </a:prstGeom>
+              <a:ln w="76200"/>
+            </p:spPr>
+            <p:style>
+              <a:lnRef idx="1">
+                <a:schemeClr val="accent1"/>
+              </a:lnRef>
+              <a:fillRef idx="0">
+                <a:schemeClr val="accent1"/>
+              </a:fillRef>
+              <a:effectRef idx="0">
+                <a:schemeClr val="accent1"/>
+              </a:effectRef>
+              <a:fontRef idx="minor">
+                <a:schemeClr val="tx1"/>
+              </a:fontRef>
+            </p:style>
+            <p:txBody>
+              <a:bodyPr rtlCol="0" anchor="ctr"/>
+              <a:lstStyle/>
+              <a:p>
+                <a:pPr algn="ctr"/>
+                <a:endParaRPr kumimoji="1" lang="ja-JP" altLang="en-US"/>
+              </a:p>
+            </p:txBody>
+          </p:sp>
+          <p:sp>
+            <p:nvSpPr>
+              <p:cNvPr id="33" name="円弧 32">
+                <a:extLst>
+                  <a:ext uri="{FF2B5EF4-FFF2-40B4-BE49-F238E27FC236}">
+                    <a16:creationId xmlns:a16="http://schemas.microsoft.com/office/drawing/2014/main" id="{FC4BFF39-6AEE-CE03-EBBA-A767CADE1684}"/>
+                  </a:ext>
+                </a:extLst>
+              </p:cNvPr>
+              <p:cNvSpPr/>
+              <p:nvPr/>
+            </p:nvSpPr>
+            <p:spPr>
+              <a:xfrm rot="16200000" flipV="1">
+                <a:off x="3719736" y="1268760"/>
+                <a:ext cx="2880320" cy="2880320"/>
+              </a:xfrm>
+              <a:prstGeom prst="arc">
+                <a:avLst>
+                  <a:gd name="adj1" fmla="val 13922304"/>
+                  <a:gd name="adj2" fmla="val 18382832"/>
+                </a:avLst>
+              </a:prstGeom>
+              <a:ln w="76200"/>
+            </p:spPr>
+            <p:style>
+              <a:lnRef idx="1">
+                <a:schemeClr val="accent1"/>
+              </a:lnRef>
+              <a:fillRef idx="0">
+                <a:schemeClr val="accent1"/>
+              </a:fillRef>
+              <a:effectRef idx="0">
+                <a:schemeClr val="accent1"/>
+              </a:effectRef>
+              <a:fontRef idx="minor">
+                <a:schemeClr val="tx1"/>
+              </a:fontRef>
+            </p:style>
+            <p:txBody>
+              <a:bodyPr rtlCol="0" anchor="ctr"/>
+              <a:lstStyle/>
+              <a:p>
+                <a:pPr algn="ctr"/>
+                <a:endParaRPr kumimoji="1" lang="ja-JP" altLang="en-US"/>
+              </a:p>
+            </p:txBody>
+          </p:sp>
+        </p:grpSp>
+        <p:grpSp>
+          <p:nvGrpSpPr>
+            <p:cNvPr id="29" name="グループ化 28">
+              <a:extLst>
+                <a:ext uri="{FF2B5EF4-FFF2-40B4-BE49-F238E27FC236}">
+                  <a16:creationId xmlns:a16="http://schemas.microsoft.com/office/drawing/2014/main" id="{BA708FB0-75E5-BADF-2A73-DF44A4342326}"/>
+                </a:ext>
+              </a:extLst>
+            </p:cNvPr>
+            <p:cNvGrpSpPr/>
+            <p:nvPr/>
+          </p:nvGrpSpPr>
+          <p:grpSpPr>
+            <a:xfrm rot="10800000">
+              <a:off x="2783633" y="1340767"/>
+              <a:ext cx="3096344" cy="2880320"/>
+              <a:chOff x="3503712" y="1268760"/>
+              <a:chExt cx="3096344" cy="2880320"/>
+            </a:xfrm>
+          </p:grpSpPr>
+          <p:sp>
+            <p:nvSpPr>
+              <p:cNvPr id="30" name="円弧 29">
+                <a:extLst>
+                  <a:ext uri="{FF2B5EF4-FFF2-40B4-BE49-F238E27FC236}">
+                    <a16:creationId xmlns:a16="http://schemas.microsoft.com/office/drawing/2014/main" id="{68BB7F9C-D087-4051-54E7-477FE7EF639B}"/>
+                  </a:ext>
+                </a:extLst>
+              </p:cNvPr>
+              <p:cNvSpPr/>
+              <p:nvPr/>
+            </p:nvSpPr>
+            <p:spPr>
+              <a:xfrm rot="16200000" flipV="1">
+                <a:off x="3503712" y="1268760"/>
+                <a:ext cx="2880320" cy="2880320"/>
+              </a:xfrm>
+              <a:prstGeom prst="arc">
+                <a:avLst>
+                  <a:gd name="adj1" fmla="val 14690949"/>
+                  <a:gd name="adj2" fmla="val 17653756"/>
+                </a:avLst>
+              </a:prstGeom>
+              <a:ln w="76200"/>
+            </p:spPr>
+            <p:style>
+              <a:lnRef idx="1">
+                <a:schemeClr val="accent1"/>
+              </a:lnRef>
+              <a:fillRef idx="0">
+                <a:schemeClr val="accent1"/>
+              </a:fillRef>
+              <a:effectRef idx="0">
+                <a:schemeClr val="accent1"/>
+              </a:effectRef>
+              <a:fontRef idx="minor">
+                <a:schemeClr val="tx1"/>
+              </a:fontRef>
+            </p:style>
+            <p:txBody>
+              <a:bodyPr rtlCol="0" anchor="ctr"/>
+              <a:lstStyle/>
+              <a:p>
+                <a:pPr algn="ctr"/>
+                <a:endParaRPr kumimoji="1" lang="ja-JP" altLang="en-US"/>
+              </a:p>
+            </p:txBody>
+          </p:sp>
+          <p:sp>
+            <p:nvSpPr>
+              <p:cNvPr id="31" name="円弧 30">
+                <a:extLst>
+                  <a:ext uri="{FF2B5EF4-FFF2-40B4-BE49-F238E27FC236}">
+                    <a16:creationId xmlns:a16="http://schemas.microsoft.com/office/drawing/2014/main" id="{7D5DC0F6-12D3-940A-9401-0E4AF3CD10F3}"/>
+                  </a:ext>
+                </a:extLst>
+              </p:cNvPr>
+              <p:cNvSpPr/>
+              <p:nvPr/>
+            </p:nvSpPr>
+            <p:spPr>
+              <a:xfrm rot="16200000" flipV="1">
+                <a:off x="3719736" y="1268760"/>
+                <a:ext cx="2880320" cy="2880320"/>
+              </a:xfrm>
+              <a:prstGeom prst="arc">
+                <a:avLst>
+                  <a:gd name="adj1" fmla="val 13922304"/>
+                  <a:gd name="adj2" fmla="val 18382832"/>
+                </a:avLst>
+              </a:prstGeom>
+              <a:ln w="76200"/>
+            </p:spPr>
+            <p:style>
+              <a:lnRef idx="1">
+                <a:schemeClr val="accent1"/>
+              </a:lnRef>
+              <a:fillRef idx="0">
+                <a:schemeClr val="accent1"/>
+              </a:fillRef>
+              <a:effectRef idx="0">
+                <a:schemeClr val="accent1"/>
+              </a:effectRef>
+              <a:fontRef idx="minor">
+                <a:schemeClr val="tx1"/>
+              </a:fontRef>
+            </p:style>
+            <p:txBody>
+              <a:bodyPr rtlCol="0" anchor="ctr"/>
+              <a:lstStyle/>
+              <a:p>
+                <a:pPr algn="ctr"/>
+                <a:endParaRPr kumimoji="1" lang="ja-JP" altLang="en-US"/>
+              </a:p>
+            </p:txBody>
+          </p:sp>
+        </p:grpSp>
+      </p:grpSp>
+      <p:grpSp>
+        <p:nvGrpSpPr>
+          <p:cNvPr id="58" name="グループ化 57">
+            <a:extLst>
+              <a:ext uri="{FF2B5EF4-FFF2-40B4-BE49-F238E27FC236}">
+                <a16:creationId xmlns:a16="http://schemas.microsoft.com/office/drawing/2014/main" id="{CCBDE2B1-65FE-71F4-7E3F-F9FE1CBFAEB5}"/>
+              </a:ext>
+            </a:extLst>
+          </p:cNvPr>
+          <p:cNvGrpSpPr/>
+          <p:nvPr/>
+        </p:nvGrpSpPr>
+        <p:grpSpPr>
+          <a:xfrm>
+            <a:off x="2783632" y="836712"/>
+            <a:ext cx="3744416" cy="3744416"/>
+            <a:chOff x="2783632" y="836712"/>
+            <a:chExt cx="3744416" cy="3744416"/>
+          </a:xfrm>
+        </p:grpSpPr>
+        <p:sp>
+          <p:nvSpPr>
+            <p:cNvPr id="2" name="楕円 1">
+              <a:extLst>
+                <a:ext uri="{FF2B5EF4-FFF2-40B4-BE49-F238E27FC236}">
+                  <a16:creationId xmlns:a16="http://schemas.microsoft.com/office/drawing/2014/main" id="{43155C62-6ADE-8ED4-5762-24CA42C1A2DA}"/>
+                </a:ext>
+              </a:extLst>
+            </p:cNvPr>
+            <p:cNvSpPr/>
+            <p:nvPr/>
+          </p:nvSpPr>
+          <p:spPr>
+            <a:xfrm>
+              <a:off x="3215680" y="1268760"/>
+              <a:ext cx="2880000" cy="2880000"/>
+            </a:xfrm>
+            <a:prstGeom prst="ellipse">
+              <a:avLst/>
+            </a:prstGeom>
+            <a:noFill/>
+            <a:ln w="76200">
+              <a:solidFill>
+                <a:schemeClr val="accent1"/>
+              </a:solidFill>
+            </a:ln>
+          </p:spPr>
+          <p:style>
+            <a:lnRef idx="2">
+              <a:schemeClr val="accent1">
+                <a:shade val="15000"/>
+              </a:schemeClr>
+            </a:lnRef>
+            <a:fillRef idx="1">
+              <a:schemeClr val="accent1"/>
+            </a:fillRef>
+            <a:effectRef idx="0">
+              <a:schemeClr val="accent1"/>
+            </a:effectRef>
+            <a:fontRef idx="minor">
+              <a:schemeClr val="lt1"/>
+            </a:fontRef>
+          </p:style>
+          <p:txBody>
+            <a:bodyPr rtlCol="0" anchor="ctr"/>
+            <a:lstStyle/>
+            <a:p>
+              <a:pPr algn="ctr"/>
+              <a:endParaRPr kumimoji="1" lang="ja-JP" altLang="en-US"/>
+            </a:p>
+          </p:txBody>
+        </p:sp>
+        <p:sp>
+          <p:nvSpPr>
+            <p:cNvPr id="3" name="楕円 2">
+              <a:extLst>
+                <a:ext uri="{FF2B5EF4-FFF2-40B4-BE49-F238E27FC236}">
+                  <a16:creationId xmlns:a16="http://schemas.microsoft.com/office/drawing/2014/main" id="{9ADCB2DC-C3AC-F070-B587-29F459F5A467}"/>
+                </a:ext>
+              </a:extLst>
+            </p:cNvPr>
+            <p:cNvSpPr/>
+            <p:nvPr/>
+          </p:nvSpPr>
+          <p:spPr>
+            <a:xfrm>
+              <a:off x="3791424" y="1268760"/>
+              <a:ext cx="1728512" cy="2880000"/>
+            </a:xfrm>
+            <a:prstGeom prst="ellipse">
+              <a:avLst/>
+            </a:prstGeom>
+            <a:noFill/>
+            <a:ln w="76200">
+              <a:solidFill>
+                <a:schemeClr val="accent1"/>
+              </a:solidFill>
+            </a:ln>
+          </p:spPr>
+          <p:style>
+            <a:lnRef idx="2">
+              <a:schemeClr val="accent1">
+                <a:shade val="15000"/>
+              </a:schemeClr>
+            </a:lnRef>
+            <a:fillRef idx="1">
+              <a:schemeClr val="accent1"/>
+            </a:fillRef>
+            <a:effectRef idx="0">
+              <a:schemeClr val="accent1"/>
+            </a:effectRef>
+            <a:fontRef idx="minor">
+              <a:schemeClr val="lt1"/>
+            </a:fontRef>
+          </p:style>
+          <p:txBody>
+            <a:bodyPr rtlCol="0" anchor="ctr"/>
+            <a:lstStyle/>
+            <a:p>
+              <a:pPr algn="ctr"/>
+              <a:endParaRPr kumimoji="1" lang="ja-JP" altLang="en-US"/>
+            </a:p>
+          </p:txBody>
+        </p:sp>
+        <p:cxnSp>
+          <p:nvCxnSpPr>
+            <p:cNvPr id="7" name="直線コネクタ 6">
+              <a:extLst>
+                <a:ext uri="{FF2B5EF4-FFF2-40B4-BE49-F238E27FC236}">
+                  <a16:creationId xmlns:a16="http://schemas.microsoft.com/office/drawing/2014/main" id="{A3F2F51F-3035-22CD-989A-1E88EE422795}"/>
+                </a:ext>
+              </a:extLst>
+            </p:cNvPr>
+            <p:cNvCxnSpPr>
+              <a:cxnSpLocks/>
+              <a:stCxn id="2" idx="2"/>
+              <a:endCxn id="2" idx="6"/>
+            </p:cNvCxnSpPr>
+            <p:nvPr/>
+          </p:nvCxnSpPr>
+          <p:spPr>
+            <a:xfrm>
+              <a:off x="3215680" y="2708760"/>
+              <a:ext cx="2880000" cy="0"/>
+            </a:xfrm>
+            <a:prstGeom prst="line">
+              <a:avLst/>
+            </a:prstGeom>
+            <a:ln w="76200"/>
+          </p:spPr>
+          <p:style>
+            <a:lnRef idx="1">
+              <a:schemeClr val="accent1"/>
+            </a:lnRef>
+            <a:fillRef idx="0">
+              <a:schemeClr val="accent1"/>
+            </a:fillRef>
+            <a:effectRef idx="0">
+              <a:schemeClr val="accent1"/>
+            </a:effectRef>
+            <a:fontRef idx="minor">
+              <a:schemeClr val="tx1"/>
+            </a:fontRef>
+          </p:style>
+        </p:cxnSp>
+        <p:cxnSp>
+          <p:nvCxnSpPr>
+            <p:cNvPr id="8" name="直線コネクタ 7">
+              <a:extLst>
+                <a:ext uri="{FF2B5EF4-FFF2-40B4-BE49-F238E27FC236}">
+                  <a16:creationId xmlns:a16="http://schemas.microsoft.com/office/drawing/2014/main" id="{4805A631-13FD-969F-A572-C9627A9A604A}"/>
+                </a:ext>
+              </a:extLst>
+            </p:cNvPr>
+            <p:cNvCxnSpPr>
+              <a:cxnSpLocks/>
+              <a:stCxn id="3" idx="0"/>
+              <a:endCxn id="3" idx="4"/>
+            </p:cNvCxnSpPr>
+            <p:nvPr/>
+          </p:nvCxnSpPr>
+          <p:spPr>
+            <a:xfrm>
+              <a:off x="4655680" y="1268760"/>
+              <a:ext cx="0" cy="2880000"/>
+            </a:xfrm>
+            <a:prstGeom prst="line">
+              <a:avLst/>
+            </a:prstGeom>
+            <a:ln w="76200"/>
+          </p:spPr>
+          <p:style>
+            <a:lnRef idx="1">
+              <a:schemeClr val="accent1"/>
+            </a:lnRef>
+            <a:fillRef idx="0">
+              <a:schemeClr val="accent1"/>
+            </a:fillRef>
+            <a:effectRef idx="0">
+              <a:schemeClr val="accent1"/>
+            </a:effectRef>
+            <a:fontRef idx="minor">
+              <a:schemeClr val="tx1"/>
+            </a:fontRef>
+          </p:style>
+        </p:cxnSp>
+        <p:sp>
+          <p:nvSpPr>
+            <p:cNvPr id="12" name="円弧 11">
+              <a:extLst>
+                <a:ext uri="{FF2B5EF4-FFF2-40B4-BE49-F238E27FC236}">
+                  <a16:creationId xmlns:a16="http://schemas.microsoft.com/office/drawing/2014/main" id="{11791BD2-2F3C-3187-1101-7E8A9AE61253}"/>
+                </a:ext>
+              </a:extLst>
+            </p:cNvPr>
+            <p:cNvSpPr/>
+            <p:nvPr/>
+          </p:nvSpPr>
+          <p:spPr>
+            <a:xfrm flipV="1">
+              <a:off x="3287688" y="980728"/>
+              <a:ext cx="2736304" cy="1080120"/>
+            </a:xfrm>
+            <a:prstGeom prst="arc">
+              <a:avLst>
+                <a:gd name="adj1" fmla="val 11696102"/>
+                <a:gd name="adj2" fmla="val 20659846"/>
+              </a:avLst>
+            </a:prstGeom>
+            <a:ln w="76200"/>
+          </p:spPr>
+          <p:style>
+            <a:lnRef idx="1">
+              <a:schemeClr val="accent1"/>
+            </a:lnRef>
+            <a:fillRef idx="0">
+              <a:schemeClr val="accent1"/>
+            </a:fillRef>
+            <a:effectRef idx="0">
+              <a:schemeClr val="accent1"/>
+            </a:effectRef>
+            <a:fontRef idx="minor">
+              <a:schemeClr val="tx1"/>
+            </a:fontRef>
+          </p:style>
+          <p:txBody>
+            <a:bodyPr rtlCol="0" anchor="ctr"/>
+            <a:lstStyle/>
+            <a:p>
+              <a:pPr algn="ctr"/>
+              <a:endParaRPr kumimoji="1" lang="ja-JP" altLang="en-US"/>
+            </a:p>
+          </p:txBody>
+        </p:sp>
+        <p:sp>
+          <p:nvSpPr>
+            <p:cNvPr id="13" name="円弧 12">
+              <a:extLst>
+                <a:ext uri="{FF2B5EF4-FFF2-40B4-BE49-F238E27FC236}">
+                  <a16:creationId xmlns:a16="http://schemas.microsoft.com/office/drawing/2014/main" id="{FC7EB5A5-C5B2-891F-E45A-9A09A6C46331}"/>
+                </a:ext>
+              </a:extLst>
+            </p:cNvPr>
+            <p:cNvSpPr/>
+            <p:nvPr/>
+          </p:nvSpPr>
+          <p:spPr>
+            <a:xfrm rot="10800000" flipV="1">
+              <a:off x="3287688" y="3356992"/>
+              <a:ext cx="2736304" cy="1080120"/>
+            </a:xfrm>
+            <a:prstGeom prst="arc">
+              <a:avLst>
+                <a:gd name="adj1" fmla="val 11720544"/>
+                <a:gd name="adj2" fmla="val 20759633"/>
+              </a:avLst>
+            </a:prstGeom>
+            <a:ln w="76200"/>
+          </p:spPr>
+          <p:style>
+            <a:lnRef idx="1">
+              <a:schemeClr val="accent1"/>
+            </a:lnRef>
+            <a:fillRef idx="0">
+              <a:schemeClr val="accent1"/>
+            </a:fillRef>
+            <a:effectRef idx="0">
+              <a:schemeClr val="accent1"/>
+            </a:effectRef>
+            <a:fontRef idx="minor">
+              <a:schemeClr val="tx1"/>
+            </a:fontRef>
+          </p:style>
+          <p:txBody>
+            <a:bodyPr rtlCol="0" anchor="ctr"/>
+            <a:lstStyle/>
+            <a:p>
+              <a:pPr algn="ctr"/>
+              <a:endParaRPr kumimoji="1" lang="ja-JP" altLang="en-US"/>
+            </a:p>
+          </p:txBody>
+        </p:sp>
+        <p:grpSp>
+          <p:nvGrpSpPr>
+            <p:cNvPr id="54" name="グループ化 53">
+              <a:extLst>
+                <a:ext uri="{FF2B5EF4-FFF2-40B4-BE49-F238E27FC236}">
+                  <a16:creationId xmlns:a16="http://schemas.microsoft.com/office/drawing/2014/main" id="{01B71E19-60EE-D7DC-B31F-355DF6BA85F6}"/>
+                </a:ext>
+              </a:extLst>
+            </p:cNvPr>
+            <p:cNvGrpSpPr/>
+            <p:nvPr/>
+          </p:nvGrpSpPr>
+          <p:grpSpPr>
+            <a:xfrm>
+              <a:off x="2783632" y="836712"/>
+              <a:ext cx="3744416" cy="3744416"/>
+              <a:chOff x="2783632" y="836712"/>
+              <a:chExt cx="3744416" cy="3744416"/>
+            </a:xfrm>
+          </p:grpSpPr>
+          <p:sp>
+            <p:nvSpPr>
+              <p:cNvPr id="15" name="円弧 14">
+                <a:extLst>
+                  <a:ext uri="{FF2B5EF4-FFF2-40B4-BE49-F238E27FC236}">
+                    <a16:creationId xmlns:a16="http://schemas.microsoft.com/office/drawing/2014/main" id="{43CC2331-1C16-39DE-CF86-F7A25660324A}"/>
+                  </a:ext>
+                </a:extLst>
+              </p:cNvPr>
+              <p:cNvSpPr/>
+              <p:nvPr/>
+            </p:nvSpPr>
+            <p:spPr>
+              <a:xfrm rot="16200000" flipV="1">
+                <a:off x="2999656" y="1052736"/>
+                <a:ext cx="3312368" cy="3312368"/>
+              </a:xfrm>
+              <a:prstGeom prst="arc">
+                <a:avLst>
+                  <a:gd name="adj1" fmla="val 14548556"/>
+                  <a:gd name="adj2" fmla="val 17761163"/>
+                </a:avLst>
+              </a:prstGeom>
+              <a:ln w="76200">
+                <a:solidFill>
+                  <a:schemeClr val="accent2"/>
+                </a:solidFill>
+              </a:ln>
+            </p:spPr>
+            <p:style>
+              <a:lnRef idx="1">
+                <a:schemeClr val="accent1"/>
+              </a:lnRef>
+              <a:fillRef idx="0">
+                <a:schemeClr val="accent1"/>
+              </a:fillRef>
+              <a:effectRef idx="0">
+                <a:schemeClr val="accent1"/>
+              </a:effectRef>
+              <a:fontRef idx="minor">
+                <a:schemeClr val="tx1"/>
+              </a:fontRef>
+            </p:style>
+            <p:txBody>
+              <a:bodyPr rtlCol="0" anchor="ctr"/>
+              <a:lstStyle/>
+              <a:p>
+                <a:pPr algn="ctr"/>
+                <a:endParaRPr kumimoji="1" lang="ja-JP" altLang="en-US"/>
+              </a:p>
+            </p:txBody>
+          </p:sp>
+          <p:sp>
+            <p:nvSpPr>
+              <p:cNvPr id="53" name="円弧 52">
+                <a:extLst>
+                  <a:ext uri="{FF2B5EF4-FFF2-40B4-BE49-F238E27FC236}">
+                    <a16:creationId xmlns:a16="http://schemas.microsoft.com/office/drawing/2014/main" id="{429FBD1C-40E2-2FD2-3483-6C2C4D429F5F}"/>
+                  </a:ext>
+                </a:extLst>
+              </p:cNvPr>
+              <p:cNvSpPr/>
+              <p:nvPr/>
+            </p:nvSpPr>
+            <p:spPr>
+              <a:xfrm rot="16200000" flipV="1">
+                <a:off x="2783632" y="836712"/>
+                <a:ext cx="3744416" cy="3744416"/>
+              </a:xfrm>
+              <a:prstGeom prst="arc">
+                <a:avLst>
+                  <a:gd name="adj1" fmla="val 14548556"/>
+                  <a:gd name="adj2" fmla="val 17761163"/>
+                </a:avLst>
+              </a:prstGeom>
+              <a:ln w="76200">
+                <a:solidFill>
+                  <a:schemeClr val="accent2"/>
+                </a:solidFill>
+              </a:ln>
+            </p:spPr>
+            <p:style>
+              <a:lnRef idx="1">
+                <a:schemeClr val="accent1"/>
+              </a:lnRef>
+              <a:fillRef idx="0">
+                <a:schemeClr val="accent1"/>
+              </a:fillRef>
+              <a:effectRef idx="0">
+                <a:schemeClr val="accent1"/>
+              </a:effectRef>
+              <a:fontRef idx="minor">
+                <a:schemeClr val="tx1"/>
+              </a:fontRef>
+            </p:style>
+            <p:txBody>
+              <a:bodyPr rtlCol="0" anchor="ctr"/>
+              <a:lstStyle/>
+              <a:p>
+                <a:pPr algn="ctr"/>
+                <a:endParaRPr kumimoji="1" lang="ja-JP" altLang="en-US"/>
+              </a:p>
+            </p:txBody>
+          </p:sp>
+        </p:grpSp>
+        <p:grpSp>
+          <p:nvGrpSpPr>
+            <p:cNvPr id="55" name="グループ化 54">
+              <a:extLst>
+                <a:ext uri="{FF2B5EF4-FFF2-40B4-BE49-F238E27FC236}">
+                  <a16:creationId xmlns:a16="http://schemas.microsoft.com/office/drawing/2014/main" id="{C848CA51-4934-FCE7-72D5-2DEC5A329441}"/>
+                </a:ext>
+              </a:extLst>
+            </p:cNvPr>
+            <p:cNvGrpSpPr/>
+            <p:nvPr/>
+          </p:nvGrpSpPr>
+          <p:grpSpPr>
+            <a:xfrm rot="10800000">
+              <a:off x="2783632" y="836712"/>
+              <a:ext cx="3744416" cy="3744416"/>
+              <a:chOff x="2783632" y="836712"/>
+              <a:chExt cx="3744416" cy="3744416"/>
+            </a:xfrm>
+          </p:grpSpPr>
+          <p:sp>
+            <p:nvSpPr>
+              <p:cNvPr id="56" name="円弧 55">
+                <a:extLst>
+                  <a:ext uri="{FF2B5EF4-FFF2-40B4-BE49-F238E27FC236}">
+                    <a16:creationId xmlns:a16="http://schemas.microsoft.com/office/drawing/2014/main" id="{66D6DD1D-3DD7-E605-08CE-3456E0F4FE53}"/>
+                  </a:ext>
+                </a:extLst>
+              </p:cNvPr>
+              <p:cNvSpPr/>
+              <p:nvPr/>
+            </p:nvSpPr>
+            <p:spPr>
+              <a:xfrm rot="16200000" flipV="1">
+                <a:off x="2999656" y="1052736"/>
+                <a:ext cx="3312368" cy="3312368"/>
+              </a:xfrm>
+              <a:prstGeom prst="arc">
+                <a:avLst>
+                  <a:gd name="adj1" fmla="val 14548556"/>
+                  <a:gd name="adj2" fmla="val 17761163"/>
+                </a:avLst>
+              </a:prstGeom>
+              <a:ln w="76200">
+                <a:solidFill>
+                  <a:schemeClr val="accent2"/>
+                </a:solidFill>
+              </a:ln>
+            </p:spPr>
+            <p:style>
+              <a:lnRef idx="1">
+                <a:schemeClr val="accent1"/>
+              </a:lnRef>
+              <a:fillRef idx="0">
+                <a:schemeClr val="accent1"/>
+              </a:fillRef>
+              <a:effectRef idx="0">
+                <a:schemeClr val="accent1"/>
+              </a:effectRef>
+              <a:fontRef idx="minor">
+                <a:schemeClr val="tx1"/>
+              </a:fontRef>
+            </p:style>
+            <p:txBody>
+              <a:bodyPr rtlCol="0" anchor="ctr"/>
+              <a:lstStyle/>
+              <a:p>
+                <a:pPr algn="ctr"/>
+                <a:endParaRPr kumimoji="1" lang="ja-JP" altLang="en-US"/>
+              </a:p>
+            </p:txBody>
+          </p:sp>
+          <p:sp>
+            <p:nvSpPr>
+              <p:cNvPr id="57" name="円弧 56">
+                <a:extLst>
+                  <a:ext uri="{FF2B5EF4-FFF2-40B4-BE49-F238E27FC236}">
+                    <a16:creationId xmlns:a16="http://schemas.microsoft.com/office/drawing/2014/main" id="{863DF900-FE1B-4148-38CB-A64675CC238F}"/>
+                  </a:ext>
+                </a:extLst>
+              </p:cNvPr>
+              <p:cNvSpPr/>
+              <p:nvPr/>
+            </p:nvSpPr>
+            <p:spPr>
+              <a:xfrm rot="16200000" flipV="1">
+                <a:off x="2783632" y="836712"/>
+                <a:ext cx="3744416" cy="3744416"/>
+              </a:xfrm>
+              <a:prstGeom prst="arc">
+                <a:avLst>
+                  <a:gd name="adj1" fmla="val 14548556"/>
+                  <a:gd name="adj2" fmla="val 17761163"/>
+                </a:avLst>
+              </a:prstGeom>
+              <a:ln w="76200">
+                <a:solidFill>
+                  <a:schemeClr val="accent2"/>
+                </a:solidFill>
+              </a:ln>
+            </p:spPr>
+            <p:style>
+              <a:lnRef idx="1">
+                <a:schemeClr val="accent1"/>
+              </a:lnRef>
+              <a:fillRef idx="0">
+                <a:schemeClr val="accent1"/>
+              </a:fillRef>
+              <a:effectRef idx="0">
+                <a:schemeClr val="accent1"/>
+              </a:effectRef>
+              <a:fontRef idx="minor">
+                <a:schemeClr val="tx1"/>
+              </a:fontRef>
+            </p:style>
+            <p:txBody>
+              <a:bodyPr rtlCol="0" anchor="ctr"/>
+              <a:lstStyle/>
+              <a:p>
+                <a:pPr algn="ctr"/>
+                <a:endParaRPr kumimoji="1" lang="ja-JP" altLang="en-US"/>
+              </a:p>
+            </p:txBody>
+          </p:sp>
+        </p:grpSp>
+      </p:grpSp>
+      <p:sp>
+        <p:nvSpPr>
+          <p:cNvPr id="60" name="楕円 59">
+            <a:extLst>
+              <a:ext uri="{FF2B5EF4-FFF2-40B4-BE49-F238E27FC236}">
+                <a16:creationId xmlns:a16="http://schemas.microsoft.com/office/drawing/2014/main" id="{89397D56-2D53-A644-6CA2-5CF5080F7D7C}"/>
+              </a:ext>
+            </a:extLst>
+          </p:cNvPr>
+          <p:cNvSpPr/>
+          <p:nvPr/>
+        </p:nvSpPr>
+        <p:spPr>
+          <a:xfrm>
+            <a:off x="7752184" y="1988840"/>
+            <a:ext cx="1440000" cy="1440000"/>
+          </a:xfrm>
+          <a:prstGeom prst="ellipse">
+            <a:avLst/>
+          </a:prstGeom>
+          <a:noFill/>
+          <a:ln w="76200">
+            <a:solidFill>
+              <a:schemeClr val="accent1"/>
+            </a:solidFill>
+          </a:ln>
+        </p:spPr>
+        <p:style>
+          <a:lnRef idx="2">
+            <a:schemeClr val="accent1">
+              <a:shade val="15000"/>
+            </a:schemeClr>
+          </a:lnRef>
+          <a:fillRef idx="1">
+            <a:schemeClr val="accent1"/>
+          </a:fillRef>
+          <a:effectRef idx="0">
+            <a:schemeClr val="accent1"/>
+          </a:effectRef>
+          <a:fontRef idx="minor">
+            <a:schemeClr val="lt1"/>
+          </a:fontRef>
+        </p:style>
+        <p:txBody>
+          <a:bodyPr rtlCol="0" anchor="ctr"/>
+          <a:lstStyle/>
+          <a:p>
+            <a:pPr algn="ctr"/>
+            <a:endParaRPr kumimoji="1" lang="ja-JP" altLang="en-US"/>
+          </a:p>
+        </p:txBody>
+      </p:sp>
+      <p:sp>
+        <p:nvSpPr>
+          <p:cNvPr id="61" name="楕円 60">
+            <a:extLst>
+              <a:ext uri="{FF2B5EF4-FFF2-40B4-BE49-F238E27FC236}">
+                <a16:creationId xmlns:a16="http://schemas.microsoft.com/office/drawing/2014/main" id="{825241CE-EF94-8BD9-5BD3-E67C574340F8}"/>
+              </a:ext>
+            </a:extLst>
+          </p:cNvPr>
+          <p:cNvSpPr/>
+          <p:nvPr/>
+        </p:nvSpPr>
+        <p:spPr>
+          <a:xfrm>
+            <a:off x="8040056" y="1988840"/>
+            <a:ext cx="864256" cy="1440000"/>
+          </a:xfrm>
+          <a:prstGeom prst="ellipse">
+            <a:avLst/>
+          </a:prstGeom>
+          <a:noFill/>
+          <a:ln w="76200">
+            <a:solidFill>
+              <a:schemeClr val="accent1"/>
+            </a:solidFill>
+          </a:ln>
+        </p:spPr>
+        <p:style>
+          <a:lnRef idx="2">
+            <a:schemeClr val="accent1">
+              <a:shade val="15000"/>
+            </a:schemeClr>
+          </a:lnRef>
+          <a:fillRef idx="1">
+            <a:schemeClr val="accent1"/>
+          </a:fillRef>
+          <a:effectRef idx="0">
+            <a:schemeClr val="accent1"/>
+          </a:effectRef>
+          <a:fontRef idx="minor">
+            <a:schemeClr val="lt1"/>
+          </a:fontRef>
+        </p:style>
+        <p:txBody>
+          <a:bodyPr rtlCol="0" anchor="ctr"/>
+          <a:lstStyle/>
+          <a:p>
+            <a:pPr algn="ctr"/>
+            <a:endParaRPr kumimoji="1" lang="ja-JP" altLang="en-US"/>
+          </a:p>
+        </p:txBody>
+      </p:sp>
+      <p:cxnSp>
+        <p:nvCxnSpPr>
+          <p:cNvPr id="62" name="直線コネクタ 61">
+            <a:extLst>
+              <a:ext uri="{FF2B5EF4-FFF2-40B4-BE49-F238E27FC236}">
+                <a16:creationId xmlns:a16="http://schemas.microsoft.com/office/drawing/2014/main" id="{BA71AD28-ABC1-EE00-C44B-6734BA7C545C}"/>
+              </a:ext>
+            </a:extLst>
+          </p:cNvPr>
+          <p:cNvCxnSpPr>
+            <a:cxnSpLocks/>
+            <a:stCxn id="60" idx="2"/>
+            <a:endCxn id="60" idx="6"/>
+          </p:cNvCxnSpPr>
+          <p:nvPr/>
+        </p:nvCxnSpPr>
+        <p:spPr>
+          <a:xfrm>
+            <a:off x="7752184" y="2708840"/>
+            <a:ext cx="1440000" cy="0"/>
+          </a:xfrm>
+          <a:prstGeom prst="line">
+            <a:avLst/>
+          </a:prstGeom>
+          <a:ln w="76200"/>
+        </p:spPr>
+        <p:style>
+          <a:lnRef idx="1">
+            <a:schemeClr val="accent1"/>
+          </a:lnRef>
+          <a:fillRef idx="0">
+            <a:schemeClr val="accent1"/>
+          </a:fillRef>
+          <a:effectRef idx="0">
+            <a:schemeClr val="accent1"/>
+          </a:effectRef>
+          <a:fontRef idx="minor">
+            <a:schemeClr val="tx1"/>
+          </a:fontRef>
+        </p:style>
+      </p:cxnSp>
+      <p:cxnSp>
+        <p:nvCxnSpPr>
+          <p:cNvPr id="63" name="直線コネクタ 62">
+            <a:extLst>
+              <a:ext uri="{FF2B5EF4-FFF2-40B4-BE49-F238E27FC236}">
+                <a16:creationId xmlns:a16="http://schemas.microsoft.com/office/drawing/2014/main" id="{692D3994-1327-2870-D259-05E7B86A2D64}"/>
+              </a:ext>
+            </a:extLst>
+          </p:cNvPr>
+          <p:cNvCxnSpPr>
+            <a:cxnSpLocks/>
+            <a:stCxn id="61" idx="0"/>
+            <a:endCxn id="61" idx="4"/>
+          </p:cNvCxnSpPr>
+          <p:nvPr/>
+        </p:nvCxnSpPr>
+        <p:spPr>
+          <a:xfrm>
+            <a:off x="8472184" y="1988840"/>
+            <a:ext cx="0" cy="1440000"/>
+          </a:xfrm>
+          <a:prstGeom prst="line">
+            <a:avLst/>
+          </a:prstGeom>
+          <a:ln w="76200"/>
+        </p:spPr>
+        <p:style>
+          <a:lnRef idx="1">
+            <a:schemeClr val="accent1"/>
+          </a:lnRef>
+          <a:fillRef idx="0">
+            <a:schemeClr val="accent1"/>
+          </a:fillRef>
+          <a:effectRef idx="0">
+            <a:schemeClr val="accent1"/>
+          </a:effectRef>
+          <a:fontRef idx="minor">
+            <a:schemeClr val="tx1"/>
+          </a:fontRef>
+        </p:style>
+      </p:cxnSp>
+      <p:sp>
+        <p:nvSpPr>
+          <p:cNvPr id="64" name="円弧 63">
+            <a:extLst>
+              <a:ext uri="{FF2B5EF4-FFF2-40B4-BE49-F238E27FC236}">
+                <a16:creationId xmlns:a16="http://schemas.microsoft.com/office/drawing/2014/main" id="{5E458475-5D3A-D6F7-9BF4-C8EF3B20FDE8}"/>
+              </a:ext>
+            </a:extLst>
+          </p:cNvPr>
+          <p:cNvSpPr/>
+          <p:nvPr/>
+        </p:nvSpPr>
+        <p:spPr>
+          <a:xfrm flipV="1">
+            <a:off x="7788188" y="1844824"/>
+            <a:ext cx="1368152" cy="540060"/>
+          </a:xfrm>
+          <a:prstGeom prst="arc">
+            <a:avLst>
+              <a:gd name="adj1" fmla="val 11696102"/>
+              <a:gd name="adj2" fmla="val 20659846"/>
+            </a:avLst>
+          </a:prstGeom>
+          <a:ln w="76200"/>
+        </p:spPr>
+        <p:style>
+          <a:lnRef idx="1">
+            <a:schemeClr val="accent1"/>
+          </a:lnRef>
+          <a:fillRef idx="0">
+            <a:schemeClr val="accent1"/>
+          </a:fillRef>
+          <a:effectRef idx="0">
+            <a:schemeClr val="accent1"/>
+          </a:effectRef>
+          <a:fontRef idx="minor">
+            <a:schemeClr val="tx1"/>
+          </a:fontRef>
+        </p:style>
+        <p:txBody>
+          <a:bodyPr rtlCol="0" anchor="ctr"/>
+          <a:lstStyle/>
+          <a:p>
+            <a:pPr algn="ctr"/>
+            <a:endParaRPr kumimoji="1" lang="ja-JP" altLang="en-US"/>
+          </a:p>
+        </p:txBody>
+      </p:sp>
+      <p:sp>
+        <p:nvSpPr>
+          <p:cNvPr id="65" name="円弧 64">
+            <a:extLst>
+              <a:ext uri="{FF2B5EF4-FFF2-40B4-BE49-F238E27FC236}">
+                <a16:creationId xmlns:a16="http://schemas.microsoft.com/office/drawing/2014/main" id="{D4953A66-631C-0E75-EC21-E0AE11198971}"/>
+              </a:ext>
+            </a:extLst>
+          </p:cNvPr>
+          <p:cNvSpPr/>
+          <p:nvPr/>
+        </p:nvSpPr>
+        <p:spPr>
+          <a:xfrm rot="10800000" flipV="1">
+            <a:off x="7788188" y="3032956"/>
+            <a:ext cx="1368152" cy="540060"/>
+          </a:xfrm>
+          <a:prstGeom prst="arc">
+            <a:avLst>
+              <a:gd name="adj1" fmla="val 11720544"/>
+              <a:gd name="adj2" fmla="val 20759633"/>
+            </a:avLst>
+          </a:prstGeom>
+          <a:ln w="76200"/>
+        </p:spPr>
+        <p:style>
+          <a:lnRef idx="1">
+            <a:schemeClr val="accent1"/>
+          </a:lnRef>
+          <a:fillRef idx="0">
+            <a:schemeClr val="accent1"/>
+          </a:fillRef>
+          <a:effectRef idx="0">
+            <a:schemeClr val="accent1"/>
+          </a:effectRef>
+          <a:fontRef idx="minor">
+            <a:schemeClr val="tx1"/>
+          </a:fontRef>
+        </p:style>
+        <p:txBody>
+          <a:bodyPr rtlCol="0" anchor="ctr"/>
+          <a:lstStyle/>
+          <a:p>
+            <a:pPr algn="ctr"/>
+            <a:endParaRPr kumimoji="1" lang="ja-JP" altLang="en-US"/>
+          </a:p>
+        </p:txBody>
+      </p:sp>
+      <p:grpSp>
+        <p:nvGrpSpPr>
+          <p:cNvPr id="66" name="グループ化 65">
+            <a:extLst>
+              <a:ext uri="{FF2B5EF4-FFF2-40B4-BE49-F238E27FC236}">
+                <a16:creationId xmlns:a16="http://schemas.microsoft.com/office/drawing/2014/main" id="{A0B90EB1-3AC6-C401-50B3-3B523805C6D2}"/>
+              </a:ext>
+            </a:extLst>
+          </p:cNvPr>
+          <p:cNvGrpSpPr/>
+          <p:nvPr/>
+        </p:nvGrpSpPr>
+        <p:grpSpPr>
+          <a:xfrm>
+            <a:off x="7536160" y="1772816"/>
+            <a:ext cx="1872208" cy="1872208"/>
+            <a:chOff x="2783632" y="836712"/>
+            <a:chExt cx="3744416" cy="3744416"/>
+          </a:xfrm>
+        </p:grpSpPr>
+        <p:sp>
+          <p:nvSpPr>
+            <p:cNvPr id="70" name="円弧 69">
+              <a:extLst>
+                <a:ext uri="{FF2B5EF4-FFF2-40B4-BE49-F238E27FC236}">
+                  <a16:creationId xmlns:a16="http://schemas.microsoft.com/office/drawing/2014/main" id="{EC4BB021-BDD7-93E8-C330-4C4E18DAD7D3}"/>
+                </a:ext>
+              </a:extLst>
+            </p:cNvPr>
+            <p:cNvSpPr/>
+            <p:nvPr/>
+          </p:nvSpPr>
+          <p:spPr>
+            <a:xfrm rot="16200000" flipV="1">
+              <a:off x="2999656" y="1052736"/>
+              <a:ext cx="3312368" cy="3312368"/>
+            </a:xfrm>
+            <a:prstGeom prst="arc">
+              <a:avLst>
+                <a:gd name="adj1" fmla="val 14548556"/>
+                <a:gd name="adj2" fmla="val 17761163"/>
+              </a:avLst>
+            </a:prstGeom>
+            <a:ln w="76200">
+              <a:solidFill>
+                <a:schemeClr val="accent1">
+                  <a:lumMod val="60000"/>
+                  <a:lumOff val="40000"/>
+                </a:schemeClr>
+              </a:solidFill>
+            </a:ln>
+          </p:spPr>
+          <p:style>
+            <a:lnRef idx="1">
+              <a:schemeClr val="accent1"/>
+            </a:lnRef>
+            <a:fillRef idx="0">
+              <a:schemeClr val="accent1"/>
+            </a:fillRef>
+            <a:effectRef idx="0">
+              <a:schemeClr val="accent1"/>
+            </a:effectRef>
+            <a:fontRef idx="minor">
+              <a:schemeClr val="tx1"/>
+            </a:fontRef>
+          </p:style>
+          <p:txBody>
+            <a:bodyPr rtlCol="0" anchor="ctr"/>
+            <a:lstStyle/>
+            <a:p>
+              <a:pPr algn="ctr"/>
+              <a:endParaRPr kumimoji="1" lang="ja-JP" altLang="en-US"/>
+            </a:p>
+          </p:txBody>
+        </p:sp>
+        <p:sp>
+          <p:nvSpPr>
+            <p:cNvPr id="71" name="円弧 70">
+              <a:extLst>
+                <a:ext uri="{FF2B5EF4-FFF2-40B4-BE49-F238E27FC236}">
+                  <a16:creationId xmlns:a16="http://schemas.microsoft.com/office/drawing/2014/main" id="{8F81310C-EA81-67C5-85BA-F0E54E609494}"/>
+                </a:ext>
+              </a:extLst>
+            </p:cNvPr>
+            <p:cNvSpPr/>
+            <p:nvPr/>
+          </p:nvSpPr>
+          <p:spPr>
+            <a:xfrm rot="16200000" flipV="1">
+              <a:off x="2783632" y="836712"/>
+              <a:ext cx="3744416" cy="3744416"/>
+            </a:xfrm>
+            <a:prstGeom prst="arc">
+              <a:avLst>
+                <a:gd name="adj1" fmla="val 14548556"/>
+                <a:gd name="adj2" fmla="val 17761163"/>
+              </a:avLst>
+            </a:prstGeom>
+            <a:ln w="76200">
+              <a:solidFill>
+                <a:schemeClr val="accent1">
+                  <a:lumMod val="60000"/>
+                  <a:lumOff val="40000"/>
+                </a:schemeClr>
+              </a:solidFill>
+            </a:ln>
+          </p:spPr>
+          <p:style>
+            <a:lnRef idx="1">
+              <a:schemeClr val="accent1"/>
+            </a:lnRef>
+            <a:fillRef idx="0">
+              <a:schemeClr val="accent1"/>
+            </a:fillRef>
+            <a:effectRef idx="0">
+              <a:schemeClr val="accent1"/>
+            </a:effectRef>
+            <a:fontRef idx="minor">
+              <a:schemeClr val="tx1"/>
+            </a:fontRef>
+          </p:style>
+          <p:txBody>
+            <a:bodyPr rtlCol="0" anchor="ctr"/>
+            <a:lstStyle/>
+            <a:p>
+              <a:pPr algn="ctr"/>
+              <a:endParaRPr kumimoji="1" lang="ja-JP" altLang="en-US"/>
+            </a:p>
+          </p:txBody>
+        </p:sp>
+      </p:grpSp>
+      <p:grpSp>
+        <p:nvGrpSpPr>
+          <p:cNvPr id="67" name="グループ化 66">
+            <a:extLst>
+              <a:ext uri="{FF2B5EF4-FFF2-40B4-BE49-F238E27FC236}">
+                <a16:creationId xmlns:a16="http://schemas.microsoft.com/office/drawing/2014/main" id="{C0402B1C-8AAE-56DB-8B29-D0F12CD48F3C}"/>
+              </a:ext>
+            </a:extLst>
+          </p:cNvPr>
+          <p:cNvGrpSpPr/>
+          <p:nvPr/>
+        </p:nvGrpSpPr>
+        <p:grpSpPr>
+          <a:xfrm rot="10800000">
+            <a:off x="7536160" y="1772816"/>
+            <a:ext cx="1872208" cy="1872208"/>
+            <a:chOff x="2783632" y="836712"/>
+            <a:chExt cx="3744416" cy="3744416"/>
+          </a:xfrm>
+        </p:grpSpPr>
+        <p:sp>
+          <p:nvSpPr>
+            <p:cNvPr id="68" name="円弧 67">
+              <a:extLst>
+                <a:ext uri="{FF2B5EF4-FFF2-40B4-BE49-F238E27FC236}">
+                  <a16:creationId xmlns:a16="http://schemas.microsoft.com/office/drawing/2014/main" id="{F8BC9F43-9123-9D9E-1506-248CC4FE7876}"/>
+                </a:ext>
+              </a:extLst>
+            </p:cNvPr>
+            <p:cNvSpPr/>
+            <p:nvPr/>
+          </p:nvSpPr>
+          <p:spPr>
+            <a:xfrm rot="16200000" flipV="1">
+              <a:off x="2999656" y="1052736"/>
+              <a:ext cx="3312368" cy="3312368"/>
+            </a:xfrm>
+            <a:prstGeom prst="arc">
+              <a:avLst>
+                <a:gd name="adj1" fmla="val 14548556"/>
+                <a:gd name="adj2" fmla="val 17761163"/>
+              </a:avLst>
+            </a:prstGeom>
+            <a:ln w="76200">
+              <a:solidFill>
+                <a:schemeClr val="accent1">
+                  <a:lumMod val="60000"/>
+                  <a:lumOff val="40000"/>
+                </a:schemeClr>
+              </a:solidFill>
+            </a:ln>
+          </p:spPr>
+          <p:style>
+            <a:lnRef idx="1">
+              <a:schemeClr val="accent1"/>
+            </a:lnRef>
+            <a:fillRef idx="0">
+              <a:schemeClr val="accent1"/>
+            </a:fillRef>
+            <a:effectRef idx="0">
+              <a:schemeClr val="accent1"/>
+            </a:effectRef>
+            <a:fontRef idx="minor">
+              <a:schemeClr val="tx1"/>
+            </a:fontRef>
+          </p:style>
+          <p:txBody>
+            <a:bodyPr rtlCol="0" anchor="ctr"/>
+            <a:lstStyle/>
+            <a:p>
+              <a:pPr algn="ctr"/>
+              <a:endParaRPr kumimoji="1" lang="ja-JP" altLang="en-US"/>
+            </a:p>
+          </p:txBody>
+        </p:sp>
+        <p:sp>
+          <p:nvSpPr>
+            <p:cNvPr id="69" name="円弧 68">
+              <a:extLst>
+                <a:ext uri="{FF2B5EF4-FFF2-40B4-BE49-F238E27FC236}">
+                  <a16:creationId xmlns:a16="http://schemas.microsoft.com/office/drawing/2014/main" id="{E3BD7BD3-A9B6-3D9C-B548-B2A478E6DFC0}"/>
+                </a:ext>
+              </a:extLst>
+            </p:cNvPr>
+            <p:cNvSpPr/>
+            <p:nvPr/>
+          </p:nvSpPr>
+          <p:spPr>
+            <a:xfrm rot="16200000" flipV="1">
+              <a:off x="2783632" y="836712"/>
+              <a:ext cx="3744416" cy="3744416"/>
+            </a:xfrm>
+            <a:prstGeom prst="arc">
+              <a:avLst>
+                <a:gd name="adj1" fmla="val 14548556"/>
+                <a:gd name="adj2" fmla="val 17761163"/>
+              </a:avLst>
+            </a:prstGeom>
+            <a:ln w="76200">
+              <a:solidFill>
+                <a:schemeClr val="accent1">
+                  <a:lumMod val="60000"/>
+                  <a:lumOff val="40000"/>
+                </a:schemeClr>
+              </a:solidFill>
+            </a:ln>
+          </p:spPr>
+          <p:style>
+            <a:lnRef idx="1">
+              <a:schemeClr val="accent1"/>
+            </a:lnRef>
+            <a:fillRef idx="0">
+              <a:schemeClr val="accent1"/>
+            </a:fillRef>
+            <a:effectRef idx="0">
+              <a:schemeClr val="accent1"/>
+            </a:effectRef>
+            <a:fontRef idx="minor">
+              <a:schemeClr val="tx1"/>
+            </a:fontRef>
+          </p:style>
+          <p:txBody>
+            <a:bodyPr rtlCol="0" anchor="ctr"/>
+            <a:lstStyle/>
+            <a:p>
+              <a:pPr algn="ctr"/>
+              <a:endParaRPr kumimoji="1" lang="ja-JP" altLang="en-US"/>
+            </a:p>
+          </p:txBody>
+        </p:sp>
+      </p:grpSp>
+    </p:spTree>
+    <p:extLst>
+      <p:ext uri="{BB962C8B-B14F-4D97-AF65-F5344CB8AC3E}">
+        <p14:creationId xmlns:p14="http://schemas.microsoft.com/office/powerpoint/2010/main" val="3837746463"/>
+      </p:ext>
+    </p:extLst>
+  </p:cSld>
+  <p:clrMapOvr>
+    <a:masterClrMapping/>
+  </p:clrMapOvr>
+</p:sld>
+</file>
+
 <file path=ppt/theme/theme1.xml><?xml version="1.0" encoding="utf-8"?>
 <a:theme xmlns:a="http://schemas.openxmlformats.org/drawingml/2006/main" name="Office テーマ">
   <a:themeElements>

</xml_diff>

<commit_message>
Update docs from source repo: d81e259ea8c61e36fef4d7fae9cb7555fdfb4b89
</commit_message>
<xml_diff>
--- a/docs/image/図の編集.pptx
+++ b/docs/image/図の編集.pptx
@@ -8,8 +8,9 @@
     <p:sldId id="256" r:id="rId2"/>
     <p:sldId id="257" r:id="rId3"/>
     <p:sldId id="258" r:id="rId4"/>
-    <p:sldId id="259" r:id="rId5"/>
-    <p:sldId id="260" r:id="rId6"/>
+    <p:sldId id="261" r:id="rId5"/>
+    <p:sldId id="259" r:id="rId6"/>
+    <p:sldId id="260" r:id="rId7"/>
   </p:sldIdLst>
   <p:sldSz cx="12192000" cy="6858000"/>
   <p:notesSz cx="6858000" cy="9144000"/>
@@ -263,7 +264,7 @@
           <a:p>
             <a:fld id="{E95EF2F7-7090-4231-B7EF-7F1B5A5EFE03}" type="datetimeFigureOut">
               <a:rPr kumimoji="1" lang="ja-JP" altLang="en-US" smtClean="0"/>
-              <a:t>2026/4/24</a:t>
+              <a:t>2026/4/25</a:t>
             </a:fld>
             <a:endParaRPr kumimoji="1" lang="ja-JP" altLang="en-US"/>
           </a:p>
@@ -493,7 +494,7 @@
           <a:p>
             <a:fld id="{E95EF2F7-7090-4231-B7EF-7F1B5A5EFE03}" type="datetimeFigureOut">
               <a:rPr kumimoji="1" lang="ja-JP" altLang="en-US" smtClean="0"/>
-              <a:t>2026/4/24</a:t>
+              <a:t>2026/4/25</a:t>
             </a:fld>
             <a:endParaRPr kumimoji="1" lang="ja-JP" altLang="en-US"/>
           </a:p>
@@ -733,7 +734,7 @@
           <a:p>
             <a:fld id="{E95EF2F7-7090-4231-B7EF-7F1B5A5EFE03}" type="datetimeFigureOut">
               <a:rPr kumimoji="1" lang="ja-JP" altLang="en-US" smtClean="0"/>
-              <a:t>2026/4/24</a:t>
+              <a:t>2026/4/25</a:t>
             </a:fld>
             <a:endParaRPr kumimoji="1" lang="ja-JP" altLang="en-US"/>
           </a:p>
@@ -963,7 +964,7 @@
           <a:p>
             <a:fld id="{E95EF2F7-7090-4231-B7EF-7F1B5A5EFE03}" type="datetimeFigureOut">
               <a:rPr kumimoji="1" lang="ja-JP" altLang="en-US" smtClean="0"/>
-              <a:t>2026/4/24</a:t>
+              <a:t>2026/4/25</a:t>
             </a:fld>
             <a:endParaRPr kumimoji="1" lang="ja-JP" altLang="en-US"/>
           </a:p>
@@ -1238,7 +1239,7 @@
           <a:p>
             <a:fld id="{E95EF2F7-7090-4231-B7EF-7F1B5A5EFE03}" type="datetimeFigureOut">
               <a:rPr kumimoji="1" lang="ja-JP" altLang="en-US" smtClean="0"/>
-              <a:t>2026/4/24</a:t>
+              <a:t>2026/4/25</a:t>
             </a:fld>
             <a:endParaRPr kumimoji="1" lang="ja-JP" altLang="en-US"/>
           </a:p>
@@ -1567,7 +1568,7 @@
           <a:p>
             <a:fld id="{E95EF2F7-7090-4231-B7EF-7F1B5A5EFE03}" type="datetimeFigureOut">
               <a:rPr kumimoji="1" lang="ja-JP" altLang="en-US" smtClean="0"/>
-              <a:t>2026/4/24</a:t>
+              <a:t>2026/4/25</a:t>
             </a:fld>
             <a:endParaRPr kumimoji="1" lang="ja-JP" altLang="en-US"/>
           </a:p>
@@ -2043,7 +2044,7 @@
           <a:p>
             <a:fld id="{E95EF2F7-7090-4231-B7EF-7F1B5A5EFE03}" type="datetimeFigureOut">
               <a:rPr kumimoji="1" lang="ja-JP" altLang="en-US" smtClean="0"/>
-              <a:t>2026/4/24</a:t>
+              <a:t>2026/4/25</a:t>
             </a:fld>
             <a:endParaRPr kumimoji="1" lang="ja-JP" altLang="en-US"/>
           </a:p>
@@ -2184,7 +2185,7 @@
           <a:p>
             <a:fld id="{E95EF2F7-7090-4231-B7EF-7F1B5A5EFE03}" type="datetimeFigureOut">
               <a:rPr kumimoji="1" lang="ja-JP" altLang="en-US" smtClean="0"/>
-              <a:t>2026/4/24</a:t>
+              <a:t>2026/4/25</a:t>
             </a:fld>
             <a:endParaRPr kumimoji="1" lang="ja-JP" altLang="en-US"/>
           </a:p>
@@ -2297,7 +2298,7 @@
           <a:p>
             <a:fld id="{E95EF2F7-7090-4231-B7EF-7F1B5A5EFE03}" type="datetimeFigureOut">
               <a:rPr kumimoji="1" lang="ja-JP" altLang="en-US" smtClean="0"/>
-              <a:t>2026/4/24</a:t>
+              <a:t>2026/4/25</a:t>
             </a:fld>
             <a:endParaRPr kumimoji="1" lang="ja-JP" altLang="en-US"/>
           </a:p>
@@ -2640,7 +2641,7 @@
           <a:p>
             <a:fld id="{E95EF2F7-7090-4231-B7EF-7F1B5A5EFE03}" type="datetimeFigureOut">
               <a:rPr kumimoji="1" lang="ja-JP" altLang="en-US" smtClean="0"/>
-              <a:t>2026/4/24</a:t>
+              <a:t>2026/4/25</a:t>
             </a:fld>
             <a:endParaRPr kumimoji="1" lang="ja-JP" altLang="en-US"/>
           </a:p>
@@ -2928,7 +2929,7 @@
           <a:p>
             <a:fld id="{E95EF2F7-7090-4231-B7EF-7F1B5A5EFE03}" type="datetimeFigureOut">
               <a:rPr kumimoji="1" lang="ja-JP" altLang="en-US" smtClean="0"/>
-              <a:t>2026/4/24</a:t>
+              <a:t>2026/4/25</a:t>
             </a:fld>
             <a:endParaRPr kumimoji="1" lang="ja-JP" altLang="en-US"/>
           </a:p>
@@ -3201,7 +3202,7 @@
           <a:p>
             <a:fld id="{E95EF2F7-7090-4231-B7EF-7F1B5A5EFE03}" type="datetimeFigureOut">
               <a:rPr kumimoji="1" lang="ja-JP" altLang="en-US" smtClean="0"/>
-              <a:t>2026/4/24</a:t>
+              <a:t>2026/4/25</a:t>
             </a:fld>
             <a:endParaRPr kumimoji="1" lang="ja-JP" altLang="en-US"/>
           </a:p>
@@ -3618,6 +3619,43 @@
           <a:chExt cx="0" cy="0"/>
         </a:xfrm>
       </p:grpSpPr>
+      <p:pic>
+        <p:nvPicPr>
+          <p:cNvPr id="6" name="図 5">
+            <a:extLst>
+              <a:ext uri="{FF2B5EF4-FFF2-40B4-BE49-F238E27FC236}">
+                <a16:creationId xmlns:a16="http://schemas.microsoft.com/office/drawing/2014/main" id="{8F566602-210C-8124-68B0-694C9DD438FA}"/>
+              </a:ext>
+            </a:extLst>
+          </p:cNvPr>
+          <p:cNvPicPr>
+            <a:picLocks noChangeAspect="1"/>
+          </p:cNvPicPr>
+          <p:nvPr/>
+        </p:nvPicPr>
+        <p:blipFill>
+          <a:blip r:embed="rId2">
+            <a:extLst>
+              <a:ext uri="{28A0092B-C50C-407E-A947-70E740481C1C}">
+                <a14:useLocalDpi xmlns:a14="http://schemas.microsoft.com/office/drawing/2010/main" val="0"/>
+              </a:ext>
+            </a:extLst>
+          </a:blip>
+          <a:srcRect b="58139"/>
+          <a:stretch>
+            <a:fillRect/>
+          </a:stretch>
+        </p:blipFill>
+        <p:spPr>
+          <a:xfrm>
+            <a:off x="3794862" y="31415"/>
+            <a:ext cx="3086100" cy="2870805"/>
+          </a:xfrm>
+          <a:prstGeom prst="rect">
+            <a:avLst/>
+          </a:prstGeom>
+        </p:spPr>
+      </p:pic>
       <p:sp>
         <p:nvSpPr>
           <p:cNvPr id="5" name="テキスト ボックス 4">
@@ -3680,43 +3718,6 @@
       </p:sp>
       <p:pic>
         <p:nvPicPr>
-          <p:cNvPr id="11" name="図 10">
-            <a:extLst>
-              <a:ext uri="{FF2B5EF4-FFF2-40B4-BE49-F238E27FC236}">
-                <a16:creationId xmlns:a16="http://schemas.microsoft.com/office/drawing/2014/main" id="{D97039C1-5D61-7CFD-7DF0-2DF96E9CD10F}"/>
-              </a:ext>
-            </a:extLst>
-          </p:cNvPr>
-          <p:cNvPicPr>
-            <a:picLocks noChangeAspect="1"/>
-          </p:cNvPicPr>
-          <p:nvPr/>
-        </p:nvPicPr>
-        <p:blipFill>
-          <a:blip r:embed="rId2">
-            <a:extLst>
-              <a:ext uri="{28A0092B-C50C-407E-A947-70E740481C1C}">
-                <a14:useLocalDpi xmlns:a14="http://schemas.microsoft.com/office/drawing/2010/main" val="0"/>
-              </a:ext>
-            </a:extLst>
-          </a:blip>
-          <a:srcRect b="56863"/>
-          <a:stretch>
-            <a:fillRect/>
-          </a:stretch>
-        </p:blipFill>
-        <p:spPr>
-          <a:xfrm>
-            <a:off x="429185" y="1649506"/>
-            <a:ext cx="3086100" cy="2958353"/>
-          </a:xfrm>
-          <a:prstGeom prst="rect">
-            <a:avLst/>
-          </a:prstGeom>
-        </p:spPr>
-      </p:pic>
-      <p:pic>
-        <p:nvPicPr>
           <p:cNvPr id="13" name="図 12">
             <a:extLst>
               <a:ext uri="{FF2B5EF4-FFF2-40B4-BE49-F238E27FC236}">
@@ -3744,45 +3745,8 @@
         </p:blipFill>
         <p:spPr>
           <a:xfrm>
-            <a:off x="4364690" y="2402539"/>
+            <a:off x="7752184" y="733146"/>
             <a:ext cx="3086100" cy="1981201"/>
-          </a:xfrm>
-          <a:prstGeom prst="rect">
-            <a:avLst/>
-          </a:prstGeom>
-        </p:spPr>
-      </p:pic>
-      <p:pic>
-        <p:nvPicPr>
-          <p:cNvPr id="17" name="図 16">
-            <a:extLst>
-              <a:ext uri="{FF2B5EF4-FFF2-40B4-BE49-F238E27FC236}">
-                <a16:creationId xmlns:a16="http://schemas.microsoft.com/office/drawing/2014/main" id="{CA697150-1A88-54A8-4FD6-88A3539F95EE}"/>
-              </a:ext>
-            </a:extLst>
-          </p:cNvPr>
-          <p:cNvPicPr>
-            <a:picLocks noChangeAspect="1"/>
-          </p:cNvPicPr>
-          <p:nvPr/>
-        </p:nvPicPr>
-        <p:blipFill>
-          <a:blip r:embed="rId4">
-            <a:extLst>
-              <a:ext uri="{28A0092B-C50C-407E-A947-70E740481C1C}">
-                <a14:useLocalDpi xmlns:a14="http://schemas.microsoft.com/office/drawing/2010/main" val="0"/>
-              </a:ext>
-            </a:extLst>
-          </a:blip>
-          <a:srcRect t="12287" b="48497"/>
-          <a:stretch>
-            <a:fillRect/>
-          </a:stretch>
-        </p:blipFill>
-        <p:spPr>
-          <a:xfrm>
-            <a:off x="8291232" y="2312894"/>
-            <a:ext cx="3086100" cy="2689412"/>
           </a:xfrm>
           <a:prstGeom prst="rect">
             <a:avLst/>
@@ -3803,7 +3767,7 @@
         </p:nvGrpSpPr>
         <p:grpSpPr>
           <a:xfrm rot="16200000">
-            <a:off x="1794620" y="3277721"/>
+            <a:off x="4997275" y="1608328"/>
             <a:ext cx="672353" cy="523220"/>
             <a:chOff x="6338046" y="896471"/>
             <a:chExt cx="672353" cy="523220"/>
@@ -3911,7 +3875,7 @@
         </p:nvGrpSpPr>
         <p:grpSpPr>
           <a:xfrm rot="16200000">
-            <a:off x="5823696" y="3277722"/>
+            <a:off x="9211190" y="1608329"/>
             <a:ext cx="672353" cy="523220"/>
             <a:chOff x="6338046" y="896471"/>
             <a:chExt cx="672353" cy="523220"/>
@@ -4005,6 +3969,312 @@
           </p:txBody>
         </p:sp>
       </p:grpSp>
+      <p:pic>
+        <p:nvPicPr>
+          <p:cNvPr id="12" name="図 11">
+            <a:extLst>
+              <a:ext uri="{FF2B5EF4-FFF2-40B4-BE49-F238E27FC236}">
+                <a16:creationId xmlns:a16="http://schemas.microsoft.com/office/drawing/2014/main" id="{6DBD6F53-110A-46A3-7E0D-87B0D51ECDFB}"/>
+              </a:ext>
+            </a:extLst>
+          </p:cNvPr>
+          <p:cNvPicPr>
+            <a:picLocks noChangeAspect="1"/>
+          </p:cNvPicPr>
+          <p:nvPr/>
+        </p:nvPicPr>
+        <p:blipFill>
+          <a:blip r:embed="rId2">
+            <a:extLst>
+              <a:ext uri="{28A0092B-C50C-407E-A947-70E740481C1C}">
+                <a14:useLocalDpi xmlns:a14="http://schemas.microsoft.com/office/drawing/2010/main" val="0"/>
+              </a:ext>
+            </a:extLst>
+          </a:blip>
+          <a:srcRect b="58139"/>
+          <a:stretch>
+            <a:fillRect/>
+          </a:stretch>
+        </p:blipFill>
+        <p:spPr>
+          <a:xfrm>
+            <a:off x="3791744" y="3501008"/>
+            <a:ext cx="3086100" cy="2870805"/>
+          </a:xfrm>
+          <a:prstGeom prst="rect">
+            <a:avLst/>
+          </a:prstGeom>
+        </p:spPr>
+      </p:pic>
+      <p:grpSp>
+        <p:nvGrpSpPr>
+          <p:cNvPr id="14" name="グループ化 13">
+            <a:extLst>
+              <a:ext uri="{FF2B5EF4-FFF2-40B4-BE49-F238E27FC236}">
+                <a16:creationId xmlns:a16="http://schemas.microsoft.com/office/drawing/2014/main" id="{E1A65EF1-EA79-96FB-AB3E-9D4CA013F23B}"/>
+              </a:ext>
+            </a:extLst>
+          </p:cNvPr>
+          <p:cNvGrpSpPr/>
+          <p:nvPr/>
+        </p:nvGrpSpPr>
+        <p:grpSpPr>
+          <a:xfrm rot="16200000">
+            <a:off x="5733402" y="4583686"/>
+            <a:ext cx="672353" cy="523220"/>
+            <a:chOff x="6338046" y="896471"/>
+            <a:chExt cx="672353" cy="523220"/>
+          </a:xfrm>
+        </p:grpSpPr>
+        <p:sp>
+          <p:nvSpPr>
+            <p:cNvPr id="15" name="楕円 14">
+              <a:extLst>
+                <a:ext uri="{FF2B5EF4-FFF2-40B4-BE49-F238E27FC236}">
+                  <a16:creationId xmlns:a16="http://schemas.microsoft.com/office/drawing/2014/main" id="{B3DFE468-0FC4-EEB4-1AB2-27C4195AFD77}"/>
+                </a:ext>
+              </a:extLst>
+            </p:cNvPr>
+            <p:cNvSpPr/>
+            <p:nvPr/>
+          </p:nvSpPr>
+          <p:spPr>
+            <a:xfrm>
+              <a:off x="6736277" y="1010911"/>
+              <a:ext cx="216000" cy="216000"/>
+            </a:xfrm>
+            <a:prstGeom prst="ellipse">
+              <a:avLst/>
+            </a:prstGeom>
+            <a:noFill/>
+            <a:ln w="28575">
+              <a:solidFill>
+                <a:srgbClr val="FF7C80"/>
+              </a:solidFill>
+            </a:ln>
+          </p:spPr>
+          <p:style>
+            <a:lnRef idx="2">
+              <a:schemeClr val="accent1">
+                <a:shade val="15000"/>
+              </a:schemeClr>
+            </a:lnRef>
+            <a:fillRef idx="1">
+              <a:schemeClr val="accent1"/>
+            </a:fillRef>
+            <a:effectRef idx="0">
+              <a:schemeClr val="accent1"/>
+            </a:effectRef>
+            <a:fontRef idx="minor">
+              <a:schemeClr val="lt1"/>
+            </a:fontRef>
+          </p:style>
+          <p:txBody>
+            <a:bodyPr rtlCol="0" anchor="ctr"/>
+            <a:lstStyle/>
+            <a:p>
+              <a:pPr algn="ctr"/>
+              <a:endParaRPr kumimoji="1" lang="ja-JP" altLang="en-US"/>
+            </a:p>
+          </p:txBody>
+        </p:sp>
+        <p:sp>
+          <p:nvSpPr>
+            <p:cNvPr id="16" name="テキスト ボックス 15">
+              <a:extLst>
+                <a:ext uri="{FF2B5EF4-FFF2-40B4-BE49-F238E27FC236}">
+                  <a16:creationId xmlns:a16="http://schemas.microsoft.com/office/drawing/2014/main" id="{4974A751-C091-38A4-69DB-1F8E206D62EB}"/>
+                </a:ext>
+              </a:extLst>
+            </p:cNvPr>
+            <p:cNvSpPr txBox="1"/>
+            <p:nvPr/>
+          </p:nvSpPr>
+          <p:spPr>
+            <a:xfrm>
+              <a:off x="6338046" y="896471"/>
+              <a:ext cx="672353" cy="523220"/>
+            </a:xfrm>
+            <a:prstGeom prst="rect">
+              <a:avLst/>
+            </a:prstGeom>
+            <a:noFill/>
+          </p:spPr>
+          <p:txBody>
+            <a:bodyPr wrap="square" rtlCol="0">
+              <a:spAutoFit/>
+            </a:bodyPr>
+            <a:lstStyle/>
+            <a:p>
+              <a:r>
+                <a:rPr kumimoji="1" lang="ja-JP" altLang="en-US" sz="2800"/>
+                <a:t>👉</a:t>
+              </a:r>
+            </a:p>
+          </p:txBody>
+        </p:sp>
+      </p:grpSp>
+      <p:pic>
+        <p:nvPicPr>
+          <p:cNvPr id="19" name="図 18">
+            <a:extLst>
+              <a:ext uri="{FF2B5EF4-FFF2-40B4-BE49-F238E27FC236}">
+                <a16:creationId xmlns:a16="http://schemas.microsoft.com/office/drawing/2014/main" id="{BA70DDDC-50B1-1E5C-0211-CA3B4C7C31FC}"/>
+              </a:ext>
+            </a:extLst>
+          </p:cNvPr>
+          <p:cNvPicPr>
+            <a:picLocks noChangeAspect="1"/>
+          </p:cNvPicPr>
+          <p:nvPr/>
+        </p:nvPicPr>
+        <p:blipFill>
+          <a:blip r:embed="rId4">
+            <a:extLst>
+              <a:ext uri="{28A0092B-C50C-407E-A947-70E740481C1C}">
+                <a14:useLocalDpi xmlns:a14="http://schemas.microsoft.com/office/drawing/2010/main" val="0"/>
+              </a:ext>
+            </a:extLst>
+          </a:blip>
+          <a:srcRect t="29533" b="32461"/>
+          <a:stretch>
+            <a:fillRect/>
+          </a:stretch>
+        </p:blipFill>
+        <p:spPr>
+          <a:xfrm>
+            <a:off x="7752184" y="3717032"/>
+            <a:ext cx="3086100" cy="2606469"/>
+          </a:xfrm>
+          <a:prstGeom prst="rect">
+            <a:avLst/>
+          </a:prstGeom>
+        </p:spPr>
+      </p:pic>
+      <p:pic>
+        <p:nvPicPr>
+          <p:cNvPr id="2" name="図 1">
+            <a:extLst>
+              <a:ext uri="{FF2B5EF4-FFF2-40B4-BE49-F238E27FC236}">
+                <a16:creationId xmlns:a16="http://schemas.microsoft.com/office/drawing/2014/main" id="{CF826F45-FA5A-B9F0-FF0F-B62281B666B7}"/>
+              </a:ext>
+            </a:extLst>
+          </p:cNvPr>
+          <p:cNvPicPr>
+            <a:picLocks noChangeAspect="1"/>
+          </p:cNvPicPr>
+          <p:nvPr/>
+        </p:nvPicPr>
+        <p:blipFill>
+          <a:blip r:embed="rId2">
+            <a:extLst>
+              <a:ext uri="{28A0092B-C50C-407E-A947-70E740481C1C}">
+                <a14:useLocalDpi xmlns:a14="http://schemas.microsoft.com/office/drawing/2010/main" val="0"/>
+              </a:ext>
+            </a:extLst>
+          </a:blip>
+          <a:srcRect b="58139"/>
+          <a:stretch>
+            <a:fillRect/>
+          </a:stretch>
+        </p:blipFill>
+        <p:spPr>
+          <a:xfrm>
+            <a:off x="335360" y="3573016"/>
+            <a:ext cx="3086100" cy="2870805"/>
+          </a:xfrm>
+          <a:prstGeom prst="rect">
+            <a:avLst/>
+          </a:prstGeom>
+        </p:spPr>
+      </p:pic>
+      <p:sp>
+        <p:nvSpPr>
+          <p:cNvPr id="8" name="楕円 7">
+            <a:extLst>
+              <a:ext uri="{FF2B5EF4-FFF2-40B4-BE49-F238E27FC236}">
+                <a16:creationId xmlns:a16="http://schemas.microsoft.com/office/drawing/2014/main" id="{EB83A7A8-34F9-5147-C817-7724C35881FF}"/>
+              </a:ext>
+            </a:extLst>
+          </p:cNvPr>
+          <p:cNvSpPr/>
+          <p:nvPr/>
+        </p:nvSpPr>
+        <p:spPr>
+          <a:xfrm rot="16200000">
+            <a:off x="3096778" y="3989316"/>
+            <a:ext cx="288000" cy="288000"/>
+          </a:xfrm>
+          <a:prstGeom prst="ellipse">
+            <a:avLst/>
+          </a:prstGeom>
+          <a:noFill/>
+          <a:ln w="28575">
+            <a:solidFill>
+              <a:srgbClr val="FF7C80"/>
+            </a:solidFill>
+          </a:ln>
+        </p:spPr>
+        <p:style>
+          <a:lnRef idx="2">
+            <a:schemeClr val="accent1">
+              <a:shade val="15000"/>
+            </a:schemeClr>
+          </a:lnRef>
+          <a:fillRef idx="1">
+            <a:schemeClr val="accent1"/>
+          </a:fillRef>
+          <a:effectRef idx="0">
+            <a:schemeClr val="accent1"/>
+          </a:effectRef>
+          <a:fontRef idx="minor">
+            <a:schemeClr val="lt1"/>
+          </a:fontRef>
+        </p:style>
+        <p:txBody>
+          <a:bodyPr rtlCol="0" anchor="ctr"/>
+          <a:lstStyle/>
+          <a:p>
+            <a:pPr algn="ctr"/>
+            <a:endParaRPr kumimoji="1" lang="ja-JP" altLang="en-US"/>
+          </a:p>
+        </p:txBody>
+      </p:sp>
+      <p:sp>
+        <p:nvSpPr>
+          <p:cNvPr id="9" name="テキスト ボックス 8">
+            <a:extLst>
+              <a:ext uri="{FF2B5EF4-FFF2-40B4-BE49-F238E27FC236}">
+                <a16:creationId xmlns:a16="http://schemas.microsoft.com/office/drawing/2014/main" id="{ACC5F45B-7EBE-FB15-AA21-426EB1C83D74}"/>
+              </a:ext>
+            </a:extLst>
+          </p:cNvPr>
+          <p:cNvSpPr txBox="1"/>
+          <p:nvPr/>
+        </p:nvSpPr>
+        <p:spPr>
+          <a:xfrm rot="16200000">
+            <a:off x="2925089" y="4143093"/>
+            <a:ext cx="672353" cy="523220"/>
+          </a:xfrm>
+          <a:prstGeom prst="rect">
+            <a:avLst/>
+          </a:prstGeom>
+          <a:noFill/>
+        </p:spPr>
+        <p:txBody>
+          <a:bodyPr wrap="square" rtlCol="0">
+            <a:spAutoFit/>
+          </a:bodyPr>
+          <a:lstStyle/>
+          <a:p>
+            <a:r>
+              <a:rPr kumimoji="1" lang="ja-JP" altLang="en-US" sz="2800"/>
+              <a:t>👉</a:t>
+            </a:r>
+          </a:p>
+        </p:txBody>
+      </p:sp>
     </p:spTree>
     <p:extLst>
       <p:ext uri="{BB962C8B-B14F-4D97-AF65-F5344CB8AC3E}">
@@ -4171,6 +4441,80 @@
           <a:chExt cx="0" cy="0"/>
         </a:xfrm>
       </p:grpSpPr>
+      <p:pic>
+        <p:nvPicPr>
+          <p:cNvPr id="13" name="図 12">
+            <a:extLst>
+              <a:ext uri="{FF2B5EF4-FFF2-40B4-BE49-F238E27FC236}">
+                <a16:creationId xmlns:a16="http://schemas.microsoft.com/office/drawing/2014/main" id="{22DE5BB7-C7E3-1C93-67F3-3A4CB488319A}"/>
+              </a:ext>
+            </a:extLst>
+          </p:cNvPr>
+          <p:cNvPicPr>
+            <a:picLocks noChangeAspect="1"/>
+          </p:cNvPicPr>
+          <p:nvPr/>
+        </p:nvPicPr>
+        <p:blipFill>
+          <a:blip r:embed="rId2">
+            <a:extLst>
+              <a:ext uri="{28A0092B-C50C-407E-A947-70E740481C1C}">
+                <a14:useLocalDpi xmlns:a14="http://schemas.microsoft.com/office/drawing/2010/main" val="0"/>
+              </a:ext>
+            </a:extLst>
+          </a:blip>
+          <a:srcRect t="32772" b="26480"/>
+          <a:stretch>
+            <a:fillRect/>
+          </a:stretch>
+        </p:blipFill>
+        <p:spPr>
+          <a:xfrm>
+            <a:off x="4727848" y="1916832"/>
+            <a:ext cx="3086100" cy="2794475"/>
+          </a:xfrm>
+          <a:prstGeom prst="rect">
+            <a:avLst/>
+          </a:prstGeom>
+        </p:spPr>
+      </p:pic>
+      <p:pic>
+        <p:nvPicPr>
+          <p:cNvPr id="5" name="図 4">
+            <a:extLst>
+              <a:ext uri="{FF2B5EF4-FFF2-40B4-BE49-F238E27FC236}">
+                <a16:creationId xmlns:a16="http://schemas.microsoft.com/office/drawing/2014/main" id="{4171D047-8286-328B-3393-2CAEF360C294}"/>
+              </a:ext>
+            </a:extLst>
+          </p:cNvPr>
+          <p:cNvPicPr>
+            <a:picLocks noChangeAspect="1"/>
+          </p:cNvPicPr>
+          <p:nvPr/>
+        </p:nvPicPr>
+        <p:blipFill>
+          <a:blip r:embed="rId3">
+            <a:extLst>
+              <a:ext uri="{28A0092B-C50C-407E-A947-70E740481C1C}">
+                <a14:useLocalDpi xmlns:a14="http://schemas.microsoft.com/office/drawing/2010/main" val="0"/>
+              </a:ext>
+            </a:extLst>
+          </a:blip>
+          <a:srcRect t="6015" b="48037"/>
+          <a:stretch>
+            <a:fillRect/>
+          </a:stretch>
+        </p:blipFill>
+        <p:spPr>
+          <a:xfrm>
+            <a:off x="983432" y="1988840"/>
+            <a:ext cx="3086100" cy="3151068"/>
+          </a:xfrm>
+          <a:prstGeom prst="rect">
+            <a:avLst/>
+          </a:prstGeom>
+        </p:spPr>
+      </p:pic>
       <p:sp>
         <p:nvSpPr>
           <p:cNvPr id="2" name="テキスト ボックス 1">
@@ -4255,154 +4599,6 @@
           </a:p>
         </p:txBody>
       </p:sp>
-      <p:pic>
-        <p:nvPicPr>
-          <p:cNvPr id="4" name="図 3">
-            <a:extLst>
-              <a:ext uri="{FF2B5EF4-FFF2-40B4-BE49-F238E27FC236}">
-                <a16:creationId xmlns:a16="http://schemas.microsoft.com/office/drawing/2014/main" id="{259F0C4B-37DA-6AE8-38E8-F019D868B9E0}"/>
-              </a:ext>
-            </a:extLst>
-          </p:cNvPr>
-          <p:cNvPicPr>
-            <a:picLocks noChangeAspect="1"/>
-          </p:cNvPicPr>
-          <p:nvPr/>
-        </p:nvPicPr>
-        <p:blipFill>
-          <a:blip r:embed="rId2">
-            <a:extLst>
-              <a:ext uri="{28A0092B-C50C-407E-A947-70E740481C1C}">
-                <a14:useLocalDpi xmlns:a14="http://schemas.microsoft.com/office/drawing/2010/main" val="0"/>
-              </a:ext>
-            </a:extLst>
-          </a:blip>
-          <a:srcRect t="5833" b="70278"/>
-          <a:stretch>
-            <a:fillRect/>
-          </a:stretch>
-        </p:blipFill>
-        <p:spPr>
-          <a:xfrm>
-            <a:off x="962025" y="1971676"/>
-            <a:ext cx="3086100" cy="1638300"/>
-          </a:xfrm>
-          <a:prstGeom prst="rect">
-            <a:avLst/>
-          </a:prstGeom>
-        </p:spPr>
-      </p:pic>
-      <p:pic>
-        <p:nvPicPr>
-          <p:cNvPr id="6" name="図 5">
-            <a:extLst>
-              <a:ext uri="{FF2B5EF4-FFF2-40B4-BE49-F238E27FC236}">
-                <a16:creationId xmlns:a16="http://schemas.microsoft.com/office/drawing/2014/main" id="{E856E5AA-120E-A924-4C51-D9FAE167EACB}"/>
-              </a:ext>
-            </a:extLst>
-          </p:cNvPr>
-          <p:cNvPicPr>
-            <a:picLocks noChangeAspect="1"/>
-          </p:cNvPicPr>
-          <p:nvPr/>
-        </p:nvPicPr>
-        <p:blipFill>
-          <a:blip r:embed="rId3">
-            <a:extLst>
-              <a:ext uri="{28A0092B-C50C-407E-A947-70E740481C1C}">
-                <a14:useLocalDpi xmlns:a14="http://schemas.microsoft.com/office/drawing/2010/main" val="0"/>
-              </a:ext>
-            </a:extLst>
-          </a:blip>
-          <a:srcRect t="28333" b="30556"/>
-          <a:stretch>
-            <a:fillRect/>
-          </a:stretch>
-        </p:blipFill>
-        <p:spPr>
-          <a:xfrm>
-            <a:off x="4772025" y="1924050"/>
-            <a:ext cx="3086100" cy="2819400"/>
-          </a:xfrm>
-          <a:prstGeom prst="rect">
-            <a:avLst/>
-          </a:prstGeom>
-        </p:spPr>
-      </p:pic>
-      <p:pic>
-        <p:nvPicPr>
-          <p:cNvPr id="8" name="図 7">
-            <a:extLst>
-              <a:ext uri="{FF2B5EF4-FFF2-40B4-BE49-F238E27FC236}">
-                <a16:creationId xmlns:a16="http://schemas.microsoft.com/office/drawing/2014/main" id="{A5F64802-8123-0F6D-9E3F-F8C25B214733}"/>
-              </a:ext>
-            </a:extLst>
-          </p:cNvPr>
-          <p:cNvPicPr>
-            <a:picLocks noChangeAspect="1"/>
-          </p:cNvPicPr>
-          <p:nvPr/>
-        </p:nvPicPr>
-        <p:blipFill>
-          <a:blip r:embed="rId4">
-            <a:extLst>
-              <a:ext uri="{28A0092B-C50C-407E-A947-70E740481C1C}">
-                <a14:useLocalDpi xmlns:a14="http://schemas.microsoft.com/office/drawing/2010/main" val="0"/>
-              </a:ext>
-            </a:extLst>
-          </a:blip>
-          <a:srcRect t="12500" b="44722"/>
-          <a:stretch>
-            <a:fillRect/>
-          </a:stretch>
-        </p:blipFill>
-        <p:spPr>
-          <a:xfrm>
-            <a:off x="8610600" y="2019300"/>
-            <a:ext cx="3086100" cy="2933700"/>
-          </a:xfrm>
-          <a:prstGeom prst="rect">
-            <a:avLst/>
-          </a:prstGeom>
-        </p:spPr>
-      </p:pic>
-      <p:pic>
-        <p:nvPicPr>
-          <p:cNvPr id="9" name="図 8">
-            <a:extLst>
-              <a:ext uri="{FF2B5EF4-FFF2-40B4-BE49-F238E27FC236}">
-                <a16:creationId xmlns:a16="http://schemas.microsoft.com/office/drawing/2014/main" id="{38A6923C-BE5D-8FCA-171D-A81A71973D68}"/>
-              </a:ext>
-            </a:extLst>
-          </p:cNvPr>
-          <p:cNvPicPr>
-            <a:picLocks noChangeAspect="1"/>
-          </p:cNvPicPr>
-          <p:nvPr/>
-        </p:nvPicPr>
-        <p:blipFill>
-          <a:blip r:embed="rId2">
-            <a:extLst>
-              <a:ext uri="{28A0092B-C50C-407E-A947-70E740481C1C}">
-                <a14:useLocalDpi xmlns:a14="http://schemas.microsoft.com/office/drawing/2010/main" val="0"/>
-              </a:ext>
-            </a:extLst>
-          </a:blip>
-          <a:srcRect t="43611" b="29027"/>
-          <a:stretch>
-            <a:fillRect/>
-          </a:stretch>
-        </p:blipFill>
-        <p:spPr>
-          <a:xfrm>
-            <a:off x="876300" y="3524250"/>
-            <a:ext cx="3086100" cy="1876425"/>
-          </a:xfrm>
-          <a:prstGeom prst="rect">
-            <a:avLst/>
-          </a:prstGeom>
-        </p:spPr>
-      </p:pic>
       <p:sp>
         <p:nvSpPr>
           <p:cNvPr id="21" name="楕円 20">
@@ -4490,114 +4686,93 @@
           </a:p>
         </p:txBody>
       </p:sp>
-      <p:grpSp>
-        <p:nvGrpSpPr>
-          <p:cNvPr id="10" name="グループ化 9">
-            <a:extLst>
-              <a:ext uri="{FF2B5EF4-FFF2-40B4-BE49-F238E27FC236}">
-                <a16:creationId xmlns:a16="http://schemas.microsoft.com/office/drawing/2014/main" id="{69C6C111-8640-3D40-164F-217F097422C5}"/>
-              </a:ext>
-            </a:extLst>
-          </p:cNvPr>
-          <p:cNvGrpSpPr/>
+      <p:sp>
+        <p:nvSpPr>
+          <p:cNvPr id="14" name="楕円 13">
+            <a:extLst>
+              <a:ext uri="{FF2B5EF4-FFF2-40B4-BE49-F238E27FC236}">
+                <a16:creationId xmlns:a16="http://schemas.microsoft.com/office/drawing/2014/main" id="{359588D5-377F-C5EE-9318-86E82153E092}"/>
+              </a:ext>
+            </a:extLst>
+          </p:cNvPr>
+          <p:cNvSpPr/>
           <p:nvPr/>
-        </p:nvGrpSpPr>
-        <p:grpSpPr>
+        </p:nvSpPr>
+        <p:spPr>
           <a:xfrm rot="16200000">
-            <a:off x="6490447" y="4087346"/>
+            <a:off x="7417259" y="3709830"/>
+            <a:ext cx="288000" cy="288000"/>
+          </a:xfrm>
+          <a:prstGeom prst="ellipse">
+            <a:avLst/>
+          </a:prstGeom>
+          <a:noFill/>
+          <a:ln w="28575">
+            <a:solidFill>
+              <a:srgbClr val="FF7C80"/>
+            </a:solidFill>
+          </a:ln>
+        </p:spPr>
+        <p:style>
+          <a:lnRef idx="2">
+            <a:schemeClr val="accent1">
+              <a:shade val="15000"/>
+            </a:schemeClr>
+          </a:lnRef>
+          <a:fillRef idx="1">
+            <a:schemeClr val="accent1"/>
+          </a:fillRef>
+          <a:effectRef idx="0">
+            <a:schemeClr val="accent1"/>
+          </a:effectRef>
+          <a:fontRef idx="minor">
+            <a:schemeClr val="lt1"/>
+          </a:fontRef>
+        </p:style>
+        <p:txBody>
+          <a:bodyPr rtlCol="0" anchor="ctr"/>
+          <a:lstStyle/>
+          <a:p>
+            <a:pPr algn="ctr"/>
+            <a:endParaRPr kumimoji="1" lang="ja-JP" altLang="en-US"/>
+          </a:p>
+        </p:txBody>
+      </p:sp>
+      <p:sp>
+        <p:nvSpPr>
+          <p:cNvPr id="15" name="テキスト ボックス 14">
+            <a:extLst>
+              <a:ext uri="{FF2B5EF4-FFF2-40B4-BE49-F238E27FC236}">
+                <a16:creationId xmlns:a16="http://schemas.microsoft.com/office/drawing/2014/main" id="{36CC16A9-F3EA-1B11-44B3-F7446E0F1AC3}"/>
+              </a:ext>
+            </a:extLst>
+          </p:cNvPr>
+          <p:cNvSpPr txBox="1"/>
+          <p:nvPr/>
+        </p:nvSpPr>
+        <p:spPr>
+          <a:xfrm rot="16200000">
+            <a:off x="7245570" y="3863607"/>
             <a:ext cx="672353" cy="523220"/>
-            <a:chOff x="6338046" y="896471"/>
-            <a:chExt cx="672353" cy="523220"/>
           </a:xfrm>
-        </p:grpSpPr>
-        <p:sp>
-          <p:nvSpPr>
-            <p:cNvPr id="11" name="楕円 10">
-              <a:extLst>
-                <a:ext uri="{FF2B5EF4-FFF2-40B4-BE49-F238E27FC236}">
-                  <a16:creationId xmlns:a16="http://schemas.microsoft.com/office/drawing/2014/main" id="{24B13730-B151-577C-D268-7837EFF90167}"/>
-                </a:ext>
-              </a:extLst>
-            </p:cNvPr>
-            <p:cNvSpPr/>
-            <p:nvPr/>
-          </p:nvSpPr>
-          <p:spPr>
-            <a:xfrm>
-              <a:off x="6736277" y="1010911"/>
-              <a:ext cx="216000" cy="216000"/>
-            </a:xfrm>
-            <a:prstGeom prst="ellipse">
-              <a:avLst/>
-            </a:prstGeom>
-            <a:noFill/>
-            <a:ln w="28575">
-              <a:solidFill>
-                <a:srgbClr val="FF7C80"/>
-              </a:solidFill>
-            </a:ln>
-          </p:spPr>
-          <p:style>
-            <a:lnRef idx="2">
-              <a:schemeClr val="accent1">
-                <a:shade val="15000"/>
-              </a:schemeClr>
-            </a:lnRef>
-            <a:fillRef idx="1">
-              <a:schemeClr val="accent1"/>
-            </a:fillRef>
-            <a:effectRef idx="0">
-              <a:schemeClr val="accent1"/>
-            </a:effectRef>
-            <a:fontRef idx="minor">
-              <a:schemeClr val="lt1"/>
-            </a:fontRef>
-          </p:style>
-          <p:txBody>
-            <a:bodyPr rtlCol="0" anchor="ctr"/>
-            <a:lstStyle/>
-            <a:p>
-              <a:pPr algn="ctr"/>
-              <a:endParaRPr kumimoji="1" lang="ja-JP" altLang="en-US"/>
-            </a:p>
-          </p:txBody>
-        </p:sp>
-        <p:sp>
-          <p:nvSpPr>
-            <p:cNvPr id="12" name="テキスト ボックス 11">
-              <a:extLst>
-                <a:ext uri="{FF2B5EF4-FFF2-40B4-BE49-F238E27FC236}">
-                  <a16:creationId xmlns:a16="http://schemas.microsoft.com/office/drawing/2014/main" id="{37844864-5D3C-C558-C5ED-698183F7324A}"/>
-                </a:ext>
-              </a:extLst>
-            </p:cNvPr>
-            <p:cNvSpPr txBox="1"/>
-            <p:nvPr/>
-          </p:nvSpPr>
-          <p:spPr>
-            <a:xfrm>
-              <a:off x="6338046" y="896471"/>
-              <a:ext cx="672353" cy="523220"/>
-            </a:xfrm>
-            <a:prstGeom prst="rect">
-              <a:avLst/>
-            </a:prstGeom>
-            <a:noFill/>
-          </p:spPr>
-          <p:txBody>
-            <a:bodyPr wrap="square" rtlCol="0">
-              <a:spAutoFit/>
-            </a:bodyPr>
-            <a:lstStyle/>
-            <a:p>
-              <a:r>
-                <a:rPr kumimoji="1" lang="ja-JP" altLang="en-US" sz="2800"/>
-                <a:t>👉</a:t>
-              </a:r>
-            </a:p>
-          </p:txBody>
-        </p:sp>
-      </p:grpSp>
+          <a:prstGeom prst="rect">
+            <a:avLst/>
+          </a:prstGeom>
+          <a:noFill/>
+        </p:spPr>
+        <p:txBody>
+          <a:bodyPr wrap="square" rtlCol="0">
+            <a:spAutoFit/>
+          </a:bodyPr>
+          <a:lstStyle/>
+          <a:p>
+            <a:r>
+              <a:rPr kumimoji="1" lang="ja-JP" altLang="en-US" sz="2800"/>
+              <a:t>👉</a:t>
+            </a:r>
+          </a:p>
+        </p:txBody>
+      </p:sp>
     </p:spTree>
     <p:extLst>
       <p:ext uri="{BB962C8B-B14F-4D97-AF65-F5344CB8AC3E}">
@@ -4612,6 +4787,36 @@
 </file>
 
 <file path=ppt/slides/slide4.xml><?xml version="1.0" encoding="utf-8"?>
+<p:sld xmlns:a="http://schemas.openxmlformats.org/drawingml/2006/main" xmlns:r="http://schemas.openxmlformats.org/officeDocument/2006/relationships" xmlns:p="http://schemas.openxmlformats.org/presentationml/2006/main">
+  <p:cSld>
+    <p:spTree>
+      <p:nvGrpSpPr>
+        <p:cNvPr id="1" name=""/>
+        <p:cNvGrpSpPr/>
+        <p:nvPr/>
+      </p:nvGrpSpPr>
+      <p:grpSpPr>
+        <a:xfrm>
+          <a:off x="0" y="0"/>
+          <a:ext cx="0" cy="0"/>
+          <a:chOff x="0" y="0"/>
+          <a:chExt cx="0" cy="0"/>
+        </a:xfrm>
+      </p:grpSpPr>
+    </p:spTree>
+    <p:extLst>
+      <p:ext uri="{BB962C8B-B14F-4D97-AF65-F5344CB8AC3E}">
+        <p14:creationId xmlns:p14="http://schemas.microsoft.com/office/powerpoint/2010/main" val="2980541397"/>
+      </p:ext>
+    </p:extLst>
+  </p:cSld>
+  <p:clrMapOvr>
+    <a:masterClrMapping/>
+  </p:clrMapOvr>
+</p:sld>
+</file>
+
+<file path=ppt/slides/slide5.xml><?xml version="1.0" encoding="utf-8"?>
 <p:sld xmlns:a="http://schemas.openxmlformats.org/drawingml/2006/main" xmlns:r="http://schemas.openxmlformats.org/officeDocument/2006/relationships" xmlns:p="http://schemas.openxmlformats.org/presentationml/2006/main">
   <p:cSld>
     <p:spTree>
@@ -6963,7 +7168,7 @@
 </p:sld>
 </file>
 
-<file path=ppt/slides/slide5.xml><?xml version="1.0" encoding="utf-8"?>
+<file path=ppt/slides/slide6.xml><?xml version="1.0" encoding="utf-8"?>
 <p:sld xmlns:a="http://schemas.openxmlformats.org/drawingml/2006/main" xmlns:r="http://schemas.openxmlformats.org/officeDocument/2006/relationships" xmlns:p="http://schemas.openxmlformats.org/presentationml/2006/main">
   <p:cSld>
     <p:spTree>

</xml_diff>